<commit_message>
Revise presentation methods and forecast results
</commit_message>
<xml_diff>
--- a/GISProjectDrewBaker/Documentation/GISPresentationDrewBaker.pptx
+++ b/GISProjectDrewBaker/Documentation/GISPresentationDrewBaker.pptx
@@ -2,18 +2,18 @@
 <file path=ppt/presentation.xml><?xml version="1.0" encoding="utf-8"?>
 <p:presentation xmlns:p="http://schemas.openxmlformats.org/presentationml/2006/main">
   <p:sldMasterIdLst>
-    <p:sldMasterId xmlns:r="http://schemas.openxmlformats.org/officeDocument/2006/relationships" id="2147483648" r:id="Ree726481c94b4c45"/>
+    <p:sldMasterId xmlns:r="http://schemas.openxmlformats.org/officeDocument/2006/relationships" id="2147483648" r:id="R4bc514cc72f94168"/>
   </p:sldMasterIdLst>
   <p:notesMasterIdLst>
-    <p:notesMasterId xmlns:r="http://schemas.openxmlformats.org/officeDocument/2006/relationships" r:id="R68211583829d42c6"/>
+    <p:notesMasterId xmlns:r="http://schemas.openxmlformats.org/officeDocument/2006/relationships" r:id="R58250559d34e441a"/>
   </p:notesMasterIdLst>
   <p:sldIdLst>
-    <p:sldId xmlns:r="http://schemas.openxmlformats.org/officeDocument/2006/relationships" id="256" r:id="R93b2ac7a5fa744d2"/>
-    <p:sldId xmlns:r="http://schemas.openxmlformats.org/officeDocument/2006/relationships" id="257" r:id="R0c5997b6b56341ed"/>
-    <p:sldId xmlns:r="http://schemas.openxmlformats.org/officeDocument/2006/relationships" id="258" r:id="R58bb9ad949a44c76"/>
-    <p:sldId xmlns:r="http://schemas.openxmlformats.org/officeDocument/2006/relationships" id="259" r:id="Ref715ab3ecab4906"/>
-    <p:sldId xmlns:r="http://schemas.openxmlformats.org/officeDocument/2006/relationships" id="260" r:id="Rcbc5fc644c454b6b"/>
-    <p:sldId xmlns:r="http://schemas.openxmlformats.org/officeDocument/2006/relationships" id="261" r:id="R9d34da87454648a1"/>
+    <p:sldId xmlns:r="http://schemas.openxmlformats.org/officeDocument/2006/relationships" id="256" r:id="Rf879ede7e35f4684"/>
+    <p:sldId xmlns:r="http://schemas.openxmlformats.org/officeDocument/2006/relationships" id="257" r:id="R26d851868314496f"/>
+    <p:sldId xmlns:r="http://schemas.openxmlformats.org/officeDocument/2006/relationships" id="258" r:id="Rbf9dfa7382b84714"/>
+    <p:sldId xmlns:r="http://schemas.openxmlformats.org/officeDocument/2006/relationships" id="259" r:id="Re8ee5990899a4e28"/>
+    <p:sldId xmlns:r="http://schemas.openxmlformats.org/officeDocument/2006/relationships" id="260" r:id="Rb31255b437c84b4e"/>
+    <p:sldId xmlns:r="http://schemas.openxmlformats.org/officeDocument/2006/relationships" id="261" r:id="R2928e4056cf04ccd"/>
   </p:sldIdLst>
   <p:sldSz cx="12192000" cy="6858000"/>
   <p:notesSz cx="6858000" cy="9144000"/>
@@ -537,7 +537,7 @@
           <a:lstStyle xmlns:a="http://schemas.openxmlformats.org/drawingml/2006/main"/>
           <a:p xmlns:a="http://schemas.openxmlformats.org/drawingml/2006/main">
             <a:r>
-              <a:t>Regional comparisons use 135 paired cells with complete annual DHW coverage. Q2 uses matching January–June and August–November seasonal windows. Q3 uses chronological model development through 2014 and held-out evaluation for 2015–2025.</a:t>
+              <a:t>The area of interest (AOI) covers West Hawaiʻi on Hawaiʻi Island. Its boundary is 18.90–20.30° N and −156.10 to −155.65° longitude. The satellite data use a 0.05-degree grid. Q1 compares full-calendar-year heat exposure in 2015 and 2019. Degree Heating Weeks (DHW) measures accumulated thermal stress in °C-weeks. Q2 compares matched seasons and complete nighttime logger means with satellite sea surface temperature (SST), using mean satellite-minus-logger difference and root mean square difference (RMSD). Q3 evaluates seven-day-ahead satellite SST forecasts with mean absolute error (MAE) and root mean square error (RMSE). Persistence forecasts today’s SST seven days ahead. Seasonal averages use historical temperatures around the target day of year.</a:t>
             </a:r>
           </a:p>
           <a:p xmlns:a="http://schemas.openxmlformats.org/drawingml/2006/main">
@@ -547,7 +547,7 @@
           </a:p>
           <a:p xmlns:a="http://schemas.openxmlformats.org/drawingml/2006/main">
             <a:r>
-              <a:t>NOAA NCEI: https://www.ncei.noaa.gov/erddap/tabledap/CRCP_Subsurface_Temp_Hawaii.html</a:t>
+              <a:t>NOAA NCEI underwater temperatures: https://www.ncei.noaa.gov/erddap/tabledap/CRCP_Subsurface_Temp_Hawaii.html</a:t>
             </a:r>
           </a:p>
           <a:p xmlns:a="http://schemas.openxmlformats.org/drawingml/2006/main">
@@ -557,7 +557,12 @@
           </a:p>
           <a:p xmlns:a="http://schemas.openxmlformats.org/drawingml/2006/main">
             <a:r>
-              <a:t>Project results: https://github.com/drwbkr1/West-Hawaii-Heat-Stress-ASM540/tree/main/Analysis</a:t>
+              <a:t>Process log: https://github.com/drwbkr1/West-Hawaii-Heat-Stress-ASM540/blob/main/Documentation/PROCESS_LOG.md</a:t>
+            </a:r>
+          </a:p>
+          <a:p xmlns:a="http://schemas.openxmlformats.org/drawingml/2006/main">
+            <a:r>
+              <a:t>Notebook: https://github.com/drwbkr1/West-Hawaii-Heat-Stress-ASM540/blob/main/Analysis/Q3/Q3_SST_Forecasting.ipynb</a:t>
             </a:r>
           </a:p>
         </p:txBody>
@@ -627,7 +632,12 @@
           <a:lstStyle xmlns:a="http://schemas.openxmlformats.org/drawingml/2006/main"/>
           <a:p xmlns:a="http://schemas.openxmlformats.org/drawingml/2006/main">
             <a:r>
-              <a:t>Median peak DHW uses the 135 paired valid water cells. Habitat area refers to mapped reef and hardbottom. Assessed habitat totals 4,731.23 ha from 5,702.29 ha mapped. 2019 had a higher median annual mean SST, while 2015 had greater accumulated DHW.</a:t>
+              <a:t>Q1 GIS workflow: Create Fishnet makes the AOI and 0.05-degree satellite grid in WGS84. Project both to NAD83 UTM Zone 5N using NAD_1983_To_WGS_1984_3. Copy and Clip the 2007 NOAA NCCOS habitat to the AOI. Calculate geodesic hectares, select Coral Reef and Hardbottom, Intersect habitat with the projected grid, and summarize piece areas by Cell_ID. Prepare CRW_Key from cell-center latitude and longitude. Retain valid zero DHW values and set masked DHW to null. Summary Statistics by CRW_Key and Event_Year calculates annual maximum DHW, valid days, and days at DHW ≥4 and ≥8. Join annual values to grid copies, classify peak DHW, join classes to reef intersection pieces, and sum reef hectares. Match the 135 common cells with complete annual coverage for paired comparisons. Values on the slide list 2015 then 2019. Mapped reef/hardbottom area is 5,702.29 ha, of which 4,731.23 ha has valid DHW and 971.05 ha is unassessed.</a:t>
+            </a:r>
+          </a:p>
+          <a:p xmlns:a="http://schemas.openxmlformats.org/drawingml/2006/main">
+            <a:r>
+              <a:t>Results: https://github.com/drwbkr1/West-Hawaii-Heat-Stress-ASM540/tree/main/Analysis/Q1/Outputs</a:t>
             </a:r>
           </a:p>
           <a:p xmlns:a="http://schemas.openxmlformats.org/drawingml/2006/main">
@@ -637,7 +647,7 @@
           </a:p>
           <a:p xmlns:a="http://schemas.openxmlformats.org/drawingml/2006/main">
             <a:r>
-              <a:t>NOAA NCEI: https://www.ncei.noaa.gov/erddap/tabledap/CRCP_Subsurface_Temp_Hawaii.html</a:t>
+              <a:t>NOAA NCEI underwater temperatures: https://www.ncei.noaa.gov/erddap/tabledap/CRCP_Subsurface_Temp_Hawaii.html</a:t>
             </a:r>
           </a:p>
           <a:p xmlns:a="http://schemas.openxmlformats.org/drawingml/2006/main">
@@ -647,7 +657,12 @@
           </a:p>
           <a:p xmlns:a="http://schemas.openxmlformats.org/drawingml/2006/main">
             <a:r>
-              <a:t>Project results: https://github.com/drwbkr1/West-Hawaii-Heat-Stress-ASM540/tree/main/Analysis</a:t>
+              <a:t>Process log: https://github.com/drwbkr1/West-Hawaii-Heat-Stress-ASM540/blob/main/Documentation/PROCESS_LOG.md</a:t>
+            </a:r>
+          </a:p>
+          <a:p xmlns:a="http://schemas.openxmlformats.org/drawingml/2006/main">
+            <a:r>
+              <a:t>Notebook: https://github.com/drwbkr1/West-Hawaii-Heat-Stress-ASM540/blob/main/Analysis/Q3/Q3_SST_Forecasting.ipynb</a:t>
             </a:r>
           </a:p>
         </p:txBody>
@@ -717,7 +732,12 @@
           <a:lstStyle xmlns:a="http://schemas.openxmlformats.org/drawingml/2006/main"/>
           <a:p xmlns:a="http://schemas.openxmlformats.org/drawingml/2006/main">
             <a:r>
-              <a:t>RMSD is the square root of the mean squared satellite-minus-logger temperature difference. These August–November comparisons use 122 complete nights per site and year. Nighttime means use 00:00 to before 06:00 HST with 72 five-minute or 360 one-minute observations.</a:t>
+              <a:t>The existing printed chart is Documentation/Figures/August_November_RMSD.png. August–November RMSD (°C), 2015/2019: OCC-HAW-001 0.741/0.334, OCC-HAW-002 0.566/0.290, OCC-HAW-009 0.317/0.210. Q2 workflow: Copy Rows from CSV, remove units rows, Delete Identical on observation fields, and use Find Identical to check time/site/deployment keys. Parse numeric temperature/depth and convert UTC to HST (UTC−10). Merge observations and summarize deployment coordinates. XY Table To Point uses recorded longitude and latitude in WGS84. Spatial Join associates deployments with satellite cells, and attribute joins carry CRW_Key back to observations. These are coordinate-based points and spatial joins. No address geocoding is used. Select 00:00 to before 06:00 HST, summarize nightly temperatures, and keep complete nights with 72 five-minute or 360 one-minute readings. Join satellite SST by cell and date. Calculate satellite SST minus the nightly underwater mean, square the difference, summarize by common season/site/depth/year, and take the square root of mean squared difference. This late-season chart uses 122 complete matched nights per site/year, 732 comparisons in total.</a:t>
+            </a:r>
+          </a:p>
+          <a:p xmlns:a="http://schemas.openxmlformats.org/drawingml/2006/main">
+            <a:r>
+              <a:t>Results: https://github.com/drwbkr1/West-Hawaii-Heat-Stress-ASM540/blob/main/Analysis/Q2/Outputs/Q2_SiteSeason_Statistics.csv</a:t>
             </a:r>
           </a:p>
           <a:p xmlns:a="http://schemas.openxmlformats.org/drawingml/2006/main">
@@ -727,7 +747,7 @@
           </a:p>
           <a:p xmlns:a="http://schemas.openxmlformats.org/drawingml/2006/main">
             <a:r>
-              <a:t>NOAA NCEI: https://www.ncei.noaa.gov/erddap/tabledap/CRCP_Subsurface_Temp_Hawaii.html</a:t>
+              <a:t>NOAA NCEI underwater temperatures: https://www.ncei.noaa.gov/erddap/tabledap/CRCP_Subsurface_Temp_Hawaii.html</a:t>
             </a:r>
           </a:p>
           <a:p xmlns:a="http://schemas.openxmlformats.org/drawingml/2006/main">
@@ -737,7 +757,12 @@
           </a:p>
           <a:p xmlns:a="http://schemas.openxmlformats.org/drawingml/2006/main">
             <a:r>
-              <a:t>Project results: https://github.com/drwbkr1/West-Hawaii-Heat-Stress-ASM540/tree/main/Analysis</a:t>
+              <a:t>Process log: https://github.com/drwbkr1/West-Hawaii-Heat-Stress-ASM540/blob/main/Documentation/PROCESS_LOG.md</a:t>
+            </a:r>
+          </a:p>
+          <a:p xmlns:a="http://schemas.openxmlformats.org/drawingml/2006/main">
+            <a:r>
+              <a:t>Notebook: https://github.com/drwbkr1/West-Hawaii-Heat-Stress-ASM540/blob/main/Analysis/Q3/Q3_SST_Forecasting.ipynb</a:t>
             </a:r>
           </a:p>
         </p:txBody>
@@ -807,7 +832,7 @@
           <a:lstStyle xmlns:a="http://schemas.openxmlformats.org/drawingml/2006/main"/>
           <a:p xmlns:a="http://schemas.openxmlformats.org/drawingml/2006/main">
             <a:r>
-              <a:t>Forecast target: satellite SST seven days ahead. Train 2003–2013, validation 2014, then refit on eligible pre-2015 examples. A frozen random forest with 300 trees, depth 16, leaf size 20 and seed 540 evaluates 2015–2025. Target-date DHW only groups evaluation results and never serves as a predictor. Persistence copies current SST. Seasonal averages use earlier data around the target day of year. Lower MAE is better.</a:t>
+              <a:t>The editable chart retains the saved held-out test MAE values: persistence 0.2228°C, random forest 0.2350°C, seasonal baseline 0.5656°C. The target is satellite SST seven days ahead. Chronological splits: initial training 2003–2013, 11,949 examples; validation 2014, 1,074 forecasts; final testing 2015–2025, 11,754 forecasts. Training targets precede validation issue dates. Development targets precede test issue dates. Four RF candidates combine maximum depth 8 or 16 with minimum leaf size 5 or 20. Each uses 300 trees and random seed 540. Select candidate 4 (depth 16, leaf size 20) using validation MAE, with RMSE as a tie-breaker. Validation MAE is RF 0.2116°C, persistence 0.2202°C, seasonal 0.5575°C. Refit the selected configuration on 13,044 eligible pre-2015 examples. Predictors use current/lagged SST, rolling means, seven-day change, seasonal sine/cosine, and cell indicators. Future DHW only groups evaluation results.</a:t>
             </a:r>
           </a:p>
           <a:p xmlns:a="http://schemas.openxmlformats.org/drawingml/2006/main">
@@ -817,7 +842,7 @@
           </a:p>
           <a:p xmlns:a="http://schemas.openxmlformats.org/drawingml/2006/main">
             <a:r>
-              <a:t>NOAA NCEI: https://www.ncei.noaa.gov/erddap/tabledap/CRCP_Subsurface_Temp_Hawaii.html</a:t>
+              <a:t>NOAA NCEI underwater temperatures: https://www.ncei.noaa.gov/erddap/tabledap/CRCP_Subsurface_Temp_Hawaii.html</a:t>
             </a:r>
           </a:p>
           <a:p xmlns:a="http://schemas.openxmlformats.org/drawingml/2006/main">
@@ -827,7 +852,12 @@
           </a:p>
           <a:p xmlns:a="http://schemas.openxmlformats.org/drawingml/2006/main">
             <a:r>
-              <a:t>Project results: https://github.com/drwbkr1/West-Hawaii-Heat-Stress-ASM540/tree/main/Analysis</a:t>
+              <a:t>Process log: https://github.com/drwbkr1/West-Hawaii-Heat-Stress-ASM540/blob/main/Documentation/PROCESS_LOG.md</a:t>
+            </a:r>
+          </a:p>
+          <a:p xmlns:a="http://schemas.openxmlformats.org/drawingml/2006/main">
+            <a:r>
+              <a:t>Notebook: https://github.com/drwbkr1/West-Hawaii-Heat-Stress-ASM540/blob/main/Analysis/Q3/Q3_SST_Forecasting.ipynb</a:t>
             </a:r>
           </a:p>
         </p:txBody>
@@ -897,12 +927,12 @@
           <a:lstStyle xmlns:a="http://schemas.openxmlformats.org/drawingml/2006/main"/>
           <a:p xmlns:a="http://schemas.openxmlformats.org/drawingml/2006/main">
             <a:r>
-              <a:t>The project evaluates thermal exposure and seven-day satellite SST forecasts at three selected cells. A future extension applies the workflow to Florida.</a:t>
-            </a:r>
-          </a:p>
-          <a:p xmlns:a="http://schemas.openxmlformats.org/drawingml/2006/main">
-            <a:r>
-              <a:t>StoryMap: https://storymaps.arcgis.com/stories/7e6551719d15418a997e2517c2bc24cc</a:t>
+              <a:t>The animated GIF shows the two southern cells for every evaluated year from 2015 through 2025. RF skill varies by cell and year. Strong heat-stress years expose larger forecast errors. Animation color on the right represents annual RF improvement over persistence, 100 × (1 − RF MAE / persistence MAE). Positive skill favors RF and negative skill favors persistence. The accompanying DHW categories and errors on this slide pool all three forecast cells over held-out test target dates. DHW &lt;4: N=11,168, RF MAE 0.2214°C, persistence MAE 0.2209°C. DHW 4 to below 8: N=259, RF MAE 0.5392°C, persistence MAE 0.2337°C. DHW ≥8: N=327, RF MAE 0.4594°C, persistence MAE 0.2779°C. High-DHW RF MAE is about 65.3% higher than persistence and about 2.1 times its own low-DHW MAE. The low-DHW result is essentially a tie with persistence. For 2015 annual forecasts, southern nearshore RF skill is −63.5826% and offshore skill is −63.2058%, with 358 forecasts per cell. Peak DHW is 13.16 and 13.29 °C-weeks respectively, with 73 evaluated days at DHW ≥8 at each cell. The animation uses annual summaries of evaluated target dates. It is a different aggregation from the pooled DHW groups printed alongside it.</a:t>
+            </a:r>
+          </a:p>
+          <a:p xmlns:a="http://schemas.openxmlformats.org/drawingml/2006/main">
+            <a:r>
+              <a:t>Annual results: https://github.com/drwbkr1/West-Hawaii-Heat-Stress-ASM540/blob/main/Analysis/Q3/Outputs/Q3_CellForecast_Annual_Summary.csv</a:t>
             </a:r>
           </a:p>
           <a:p xmlns:a="http://schemas.openxmlformats.org/drawingml/2006/main">
@@ -912,7 +942,7 @@
           </a:p>
           <a:p xmlns:a="http://schemas.openxmlformats.org/drawingml/2006/main">
             <a:r>
-              <a:t>NOAA NCEI: https://www.ncei.noaa.gov/erddap/tabledap/CRCP_Subsurface_Temp_Hawaii.html</a:t>
+              <a:t>NOAA NCEI underwater temperatures: https://www.ncei.noaa.gov/erddap/tabledap/CRCP_Subsurface_Temp_Hawaii.html</a:t>
             </a:r>
           </a:p>
           <a:p xmlns:a="http://schemas.openxmlformats.org/drawingml/2006/main">
@@ -922,7 +952,12 @@
           </a:p>
           <a:p xmlns:a="http://schemas.openxmlformats.org/drawingml/2006/main">
             <a:r>
-              <a:t>Project results: https://github.com/drwbkr1/West-Hawaii-Heat-Stress-ASM540/tree/main/Analysis</a:t>
+              <a:t>Process log: https://github.com/drwbkr1/West-Hawaii-Heat-Stress-ASM540/blob/main/Documentation/PROCESS_LOG.md</a:t>
+            </a:r>
+          </a:p>
+          <a:p xmlns:a="http://schemas.openxmlformats.org/drawingml/2006/main">
+            <a:r>
+              <a:t>Notebook: https://github.com/drwbkr1/West-Hawaii-Heat-Stress-ASM540/blob/main/Analysis/Q3/Q3_SST_Forecasting.ipynb</a:t>
             </a:r>
           </a:p>
         </p:txBody>
@@ -2735,12 +2770,12 @@
   </p:cSld>
   <p:clrMap bg1="lt1" tx1="dk1" bg2="lt2" tx2="dk2" accent1="accent1" accent2="accent2" accent3="accent3" accent4="accent4" accent5="accent5" accent6="accent6" hlink="hlink" folHlink="folHlink"/>
   <p:sldLayoutIdLst>
-    <p:sldLayoutId xmlns:r="http://schemas.openxmlformats.org/officeDocument/2006/relationships" id="2147483649" r:id="R5c7493d7f0b5423d"/>
-    <p:sldLayoutId xmlns:r="http://schemas.openxmlformats.org/officeDocument/2006/relationships" id="2147483650" r:id="R328c85617e93455d"/>
-    <p:sldLayoutId xmlns:r="http://schemas.openxmlformats.org/officeDocument/2006/relationships" id="2147483651" r:id="R3e7f081ad29f4b1f"/>
-    <p:sldLayoutId xmlns:r="http://schemas.openxmlformats.org/officeDocument/2006/relationships" id="2147483652" r:id="R9619bbb9c2e54362"/>
-    <p:sldLayoutId xmlns:r="http://schemas.openxmlformats.org/officeDocument/2006/relationships" id="2147483653" r:id="Raca8e794c0194793"/>
-    <p:sldLayoutId xmlns:r="http://schemas.openxmlformats.org/officeDocument/2006/relationships" id="2147483654" r:id="R275f5bf3eaa74a27"/>
+    <p:sldLayoutId xmlns:r="http://schemas.openxmlformats.org/officeDocument/2006/relationships" id="2147483649" r:id="R0210c505b3494c25"/>
+    <p:sldLayoutId xmlns:r="http://schemas.openxmlformats.org/officeDocument/2006/relationships" id="2147483650" r:id="Rbe66e302c7e6479d"/>
+    <p:sldLayoutId xmlns:r="http://schemas.openxmlformats.org/officeDocument/2006/relationships" id="2147483651" r:id="Rdbe7972b15b7457b"/>
+    <p:sldLayoutId xmlns:r="http://schemas.openxmlformats.org/officeDocument/2006/relationships" id="2147483652" r:id="R9b3b5159d7e34db0"/>
+    <p:sldLayoutId xmlns:r="http://schemas.openxmlformats.org/officeDocument/2006/relationships" id="2147483653" r:id="Rc8bae8308b4a4210"/>
+    <p:sldLayoutId xmlns:r="http://schemas.openxmlformats.org/officeDocument/2006/relationships" id="2147483654" r:id="Rec2e61500fef410b"/>
   </p:sldLayoutIdLst>
   <p:txStyles>
     <p:titleStyle>
@@ -3826,17 +3861,45 @@
                 <a:ea typeface="Arial"/>
                 <a:cs typeface="Arial"/>
               </a:rPr>
-              <a:t>Study area and analytical approach</a:t>
+              <a:t>Study area and project questions</a:t>
             </a:r>
           </a:p>
         </p:txBody>
       </p:sp>
-      <p:sp>
-        <p:nvSpPr>
-          <p:cNvPr id="2" name="">
+      <p:pic>
+        <p:nvPicPr>
+          <p:cNvPr id="8" name="">
             <a:extLst xmlns:a="http://schemas.openxmlformats.org/drawingml/2006/main">
               <a:ext uri="{FF2B5EF4-FFF2-40B4-BE49-F238E27FC236}">
-                <a16:creationId xmlns:a16="http://schemas.microsoft.com/office/drawing/2014/main" id="{A7971451-0659-446B-8DA9-60C511211B84}"/>
+                <a16:creationId xmlns:a16="http://schemas.microsoft.com/office/drawing/2014/main" id="{846F7E99-528A-4A6B-9AE3-9673207ABE33}"/>
+              </a:ext>
+            </a:extLst>
+          </p:cNvPr>
+          <p:cNvPicPr>
+            <a:picLocks xmlns:a="http://schemas.openxmlformats.org/drawingml/2006/main" noChangeAspect="1"/>
+          </p:cNvPicPr>
+          <p:nvPr/>
+        </p:nvPicPr>
+        <p:blipFill>
+          <a:blip xmlns:r="http://schemas.openxmlformats.org/officeDocument/2006/relationships" xmlns:a="http://schemas.openxmlformats.org/drawingml/2006/main" r:embed="Ra8e41c0111b3415c"/>
+          <a:stretch xmlns:a="http://schemas.openxmlformats.org/drawingml/2006/main"/>
+        </p:blipFill>
+        <p:spPr>
+          <a:xfrm xmlns:a="http://schemas.openxmlformats.org/drawingml/2006/main">
+            <a:off x="6619875" y="1714500"/>
+            <a:ext cx="5095875" cy="4333875"/>
+          </a:xfrm>
+          <a:prstGeom xmlns:a="http://schemas.openxmlformats.org/drawingml/2006/main" prst="rect">
+            <a:avLst/>
+          </a:prstGeom>
+        </p:spPr>
+      </p:pic>
+      <p:sp>
+        <p:nvSpPr>
+          <p:cNvPr id="10" name="">
+            <a:extLst xmlns:a="http://schemas.openxmlformats.org/drawingml/2006/main">
+              <a:ext uri="{FF2B5EF4-FFF2-40B4-BE49-F238E27FC236}">
+                <a16:creationId xmlns:a16="http://schemas.microsoft.com/office/drawing/2014/main" id="{AD36D1C9-C8F8-4A35-8631-8A9C5C0A0F2B}"/>
               </a:ext>
             </a:extLst>
           </p:cNvPr>
@@ -3847,8 +3910,8 @@
         </p:nvSpPr>
         <p:spPr>
           <a:xfrm xmlns:a="http://schemas.openxmlformats.org/drawingml/2006/main">
-            <a:off x="571500" y="1571625"/>
-            <a:ext cx="5334000" cy="428625"/>
+            <a:off x="571500" y="1333500"/>
+            <a:ext cx="5810250" cy="352425"/>
           </a:xfrm>
           <a:prstGeom xmlns:a="http://schemas.openxmlformats.org/drawingml/2006/main" prst="rect">
             <a:avLst/>
@@ -3862,7 +3925,7 @@
           <a:bodyPr xmlns:a="http://schemas.openxmlformats.org/drawingml/2006/main"/>
           <a:lstStyle xmlns:a="http://schemas.openxmlformats.org/drawingml/2006/main">
             <a:defPPr>
-              <a:defRPr sz="2250" b="1">
+              <a:defRPr sz="2100" b="1">
                 <a:solidFill>
                   <a:srgbClr val="167D91"/>
                 </a:solidFill>
@@ -3875,7 +3938,7 @@
           <a:p xmlns:a="http://schemas.openxmlformats.org/drawingml/2006/main">
             <a:pPr>
               <a:buNone/>
-              <a:defRPr sz="2250" b="1">
+              <a:defRPr sz="2100" b="1">
                 <a:solidFill>
                   <a:srgbClr val="167D91"/>
                 </a:solidFill>
@@ -3885,7 +3948,7 @@
               </a:defRPr>
             </a:pPr>
             <a:r>
-              <a:rPr sz="2250" b="1">
+              <a:rPr sz="2100" b="1">
                 <a:solidFill>
                   <a:srgbClr val="167D91"/>
                 </a:solidFill>
@@ -3893,17 +3956,17 @@
                 <a:ea typeface="Arial"/>
                 <a:cs typeface="Arial"/>
               </a:rPr>
-              <a:t>Regional heat exposure</a:t>
+              <a:t>Study area: West Hawaiʻi</a:t>
             </a:r>
           </a:p>
         </p:txBody>
       </p:sp>
       <p:sp>
         <p:nvSpPr>
-          <p:cNvPr id="3" name="">
+          <p:cNvPr id="11" name="">
             <a:extLst xmlns:a="http://schemas.openxmlformats.org/drawingml/2006/main">
               <a:ext uri="{FF2B5EF4-FFF2-40B4-BE49-F238E27FC236}">
-                <a16:creationId xmlns:a16="http://schemas.microsoft.com/office/drawing/2014/main" id="{23E5B070-3062-43C0-992D-BA1A0D577462}"/>
+                <a16:creationId xmlns:a16="http://schemas.microsoft.com/office/drawing/2014/main" id="{13748C93-CE5C-489F-AD8E-3CA6D028B132}"/>
               </a:ext>
             </a:extLst>
           </p:cNvPr>
@@ -3914,8 +3977,8 @@
         </p:nvSpPr>
         <p:spPr>
           <a:xfrm xmlns:a="http://schemas.openxmlformats.org/drawingml/2006/main">
-            <a:off x="571500" y="2095500"/>
-            <a:ext cx="5048250" cy="1047750"/>
+            <a:off x="571500" y="1752600"/>
+            <a:ext cx="5715000" cy="857250"/>
           </a:xfrm>
           <a:prstGeom xmlns:a="http://schemas.openxmlformats.org/drawingml/2006/main" prst="rect">
             <a:avLst/>
@@ -3929,7 +3992,7 @@
           <a:bodyPr xmlns:a="http://schemas.openxmlformats.org/drawingml/2006/main"/>
           <a:lstStyle xmlns:a="http://schemas.openxmlformats.org/drawingml/2006/main">
             <a:defPPr>
-              <a:defRPr sz="2100" b="0">
+              <a:defRPr sz="1875" b="0">
                 <a:solidFill>
                   <a:srgbClr val="263C49"/>
                 </a:solidFill>
@@ -3942,7 +4005,7 @@
           <a:p xmlns:a="http://schemas.openxmlformats.org/drawingml/2006/main">
             <a:pPr>
               <a:buNone/>
-              <a:defRPr sz="2100" b="0">
+              <a:defRPr sz="1875" b="0">
                 <a:solidFill>
                   <a:srgbClr val="263C49"/>
                 </a:solidFill>
@@ -3952,7 +4015,7 @@
               </a:defRPr>
             </a:pPr>
             <a:r>
-              <a:rPr sz="2100" b="0">
+              <a:rPr sz="1875" b="0">
                 <a:solidFill>
                   <a:srgbClr val="263C49"/>
                 </a:solidFill>
@@ -3960,17 +4023,17 @@
                 <a:ea typeface="Arial"/>
                 <a:cs typeface="Arial"/>
               </a:rPr>
-              <a:t>Match 2015 and 2019 satellite cells. Overlay mapped reef and hardbottom habitat.</a:t>
+              <a:t>AOI: the west coast of Hawaiʻi Island, 18.90–20.30° N and 156.10–155.65° W. Satellite grid: 0.05° (about 5 km).</a:t>
             </a:r>
           </a:p>
         </p:txBody>
       </p:sp>
       <p:sp>
         <p:nvSpPr>
-          <p:cNvPr id="4" name="">
+          <p:cNvPr id="12" name="">
             <a:extLst xmlns:a="http://schemas.openxmlformats.org/drawingml/2006/main">
               <a:ext uri="{FF2B5EF4-FFF2-40B4-BE49-F238E27FC236}">
-                <a16:creationId xmlns:a16="http://schemas.microsoft.com/office/drawing/2014/main" id="{065FFC4F-309A-421A-978B-117E6D63C94B}"/>
+                <a16:creationId xmlns:a16="http://schemas.microsoft.com/office/drawing/2014/main" id="{DDBCC69A-0A81-4AF9-8E1D-DC71443EB140}"/>
               </a:ext>
             </a:extLst>
           </p:cNvPr>
@@ -3981,8 +4044,8 @@
         </p:nvSpPr>
         <p:spPr>
           <a:xfrm xmlns:a="http://schemas.openxmlformats.org/drawingml/2006/main">
-            <a:off x="571500" y="3333750"/>
-            <a:ext cx="5334000" cy="428625"/>
+            <a:off x="571500" y="2619375"/>
+            <a:ext cx="5810250" cy="352425"/>
           </a:xfrm>
           <a:prstGeom xmlns:a="http://schemas.openxmlformats.org/drawingml/2006/main" prst="rect">
             <a:avLst/>
@@ -3996,7 +4059,7 @@
           <a:bodyPr xmlns:a="http://schemas.openxmlformats.org/drawingml/2006/main"/>
           <a:lstStyle xmlns:a="http://schemas.openxmlformats.org/drawingml/2006/main">
             <a:defPPr>
-              <a:defRPr sz="2250" b="1">
+              <a:defRPr sz="2100" b="1">
                 <a:solidFill>
                   <a:srgbClr val="167D91"/>
                 </a:solidFill>
@@ -4009,7 +4072,7 @@
           <a:p xmlns:a="http://schemas.openxmlformats.org/drawingml/2006/main">
             <a:pPr>
               <a:buNone/>
-              <a:defRPr sz="2250" b="1">
+              <a:defRPr sz="2100" b="1">
                 <a:solidFill>
                   <a:srgbClr val="167D91"/>
                 </a:solidFill>
@@ -4019,7 +4082,7 @@
               </a:defRPr>
             </a:pPr>
             <a:r>
-              <a:rPr sz="2250" b="1">
+              <a:rPr sz="2100" b="1">
                 <a:solidFill>
                   <a:srgbClr val="167D91"/>
                 </a:solidFill>
@@ -4027,17 +4090,17 @@
                 <a:ea typeface="Arial"/>
                 <a:cs typeface="Arial"/>
               </a:rPr>
-              <a:t>Underwater comparison</a:t>
+              <a:t>Q1: Which year had more heat stress?</a:t>
             </a:r>
           </a:p>
         </p:txBody>
       </p:sp>
       <p:sp>
         <p:nvSpPr>
-          <p:cNvPr id="5" name="">
+          <p:cNvPr id="13" name="">
             <a:extLst xmlns:a="http://schemas.openxmlformats.org/drawingml/2006/main">
               <a:ext uri="{FF2B5EF4-FFF2-40B4-BE49-F238E27FC236}">
-                <a16:creationId xmlns:a16="http://schemas.microsoft.com/office/drawing/2014/main" id="{EB526435-B7EE-45BD-9D7E-10C21AAB8210}"/>
+                <a16:creationId xmlns:a16="http://schemas.microsoft.com/office/drawing/2014/main" id="{CF8A5E01-D607-46B4-A82D-8AA599648E7A}"/>
               </a:ext>
             </a:extLst>
           </p:cNvPr>
@@ -4048,8 +4111,8 @@
         </p:nvSpPr>
         <p:spPr>
           <a:xfrm xmlns:a="http://schemas.openxmlformats.org/drawingml/2006/main">
-            <a:off x="571500" y="3857625"/>
-            <a:ext cx="5048250" cy="1000125"/>
+            <a:off x="571500" y="3038475"/>
+            <a:ext cx="5715000" cy="857250"/>
           </a:xfrm>
           <a:prstGeom xmlns:a="http://schemas.openxmlformats.org/drawingml/2006/main" prst="rect">
             <a:avLst/>
@@ -4063,7 +4126,7 @@
           <a:bodyPr xmlns:a="http://schemas.openxmlformats.org/drawingml/2006/main"/>
           <a:lstStyle xmlns:a="http://schemas.openxmlformats.org/drawingml/2006/main">
             <a:defPPr>
-              <a:defRPr sz="2100" b="0">
+              <a:defRPr sz="1875" b="0">
                 <a:solidFill>
                   <a:srgbClr val="263C49"/>
                 </a:solidFill>
@@ -4076,7 +4139,7 @@
           <a:p xmlns:a="http://schemas.openxmlformats.org/drawingml/2006/main">
             <a:pPr>
               <a:buNone/>
-              <a:defRPr sz="2100" b="0">
+              <a:defRPr sz="1875" b="0">
                 <a:solidFill>
                   <a:srgbClr val="263C49"/>
                 </a:solidFill>
@@ -4086,7 +4149,7 @@
               </a:defRPr>
             </a:pPr>
             <a:r>
-              <a:rPr sz="2100" b="0">
+              <a:rPr sz="1875" b="0">
                 <a:solidFill>
                   <a:srgbClr val="263C49"/>
                 </a:solidFill>
@@ -4094,17 +4157,17 @@
                 <a:ea typeface="Arial"/>
                 <a:cs typeface="Arial"/>
               </a:rPr>
-              <a:t>Match complete nighttime logger records to daily satellite observations.</a:t>
+              <a:t>Compare 2015 and 2019 peak DHW (°C-weeks), days at DHW ≥4 / ≥8, and exposed reef area (ha).</a:t>
             </a:r>
           </a:p>
         </p:txBody>
       </p:sp>
       <p:sp>
         <p:nvSpPr>
-          <p:cNvPr id="6" name="">
+          <p:cNvPr id="14" name="">
             <a:extLst xmlns:a="http://schemas.openxmlformats.org/drawingml/2006/main">
               <a:ext uri="{FF2B5EF4-FFF2-40B4-BE49-F238E27FC236}">
-                <a16:creationId xmlns:a16="http://schemas.microsoft.com/office/drawing/2014/main" id="{000EB112-3919-407B-99EB-11198E9DD466}"/>
+                <a16:creationId xmlns:a16="http://schemas.microsoft.com/office/drawing/2014/main" id="{C8173C50-5C72-45D5-9FF6-6C15F4414E17}"/>
               </a:ext>
             </a:extLst>
           </p:cNvPr>
@@ -4115,8 +4178,8 @@
         </p:nvSpPr>
         <p:spPr>
           <a:xfrm xmlns:a="http://schemas.openxmlformats.org/drawingml/2006/main">
-            <a:off x="571500" y="5048250"/>
-            <a:ext cx="5334000" cy="428625"/>
+            <a:off x="571500" y="3905250"/>
+            <a:ext cx="5810250" cy="352425"/>
           </a:xfrm>
           <a:prstGeom xmlns:a="http://schemas.openxmlformats.org/drawingml/2006/main" prst="rect">
             <a:avLst/>
@@ -4130,7 +4193,7 @@
           <a:bodyPr xmlns:a="http://schemas.openxmlformats.org/drawingml/2006/main"/>
           <a:lstStyle xmlns:a="http://schemas.openxmlformats.org/drawingml/2006/main">
             <a:defPPr>
-              <a:defRPr sz="2250" b="1">
+              <a:defRPr sz="2100" b="1">
                 <a:solidFill>
                   <a:srgbClr val="167D91"/>
                 </a:solidFill>
@@ -4143,7 +4206,7 @@
           <a:p xmlns:a="http://schemas.openxmlformats.org/drawingml/2006/main">
             <a:pPr>
               <a:buNone/>
-              <a:defRPr sz="2250" b="1">
+              <a:defRPr sz="2100" b="1">
                 <a:solidFill>
                   <a:srgbClr val="167D91"/>
                 </a:solidFill>
@@ -4153,7 +4216,7 @@
               </a:defRPr>
             </a:pPr>
             <a:r>
-              <a:rPr sz="2250" b="1">
+              <a:rPr sz="2100" b="1">
                 <a:solidFill>
                   <a:srgbClr val="167D91"/>
                 </a:solidFill>
@@ -4161,17 +4224,17 @@
                 <a:ea typeface="Arial"/>
                 <a:cs typeface="Arial"/>
               </a:rPr>
-              <a:t>Forecast test</a:t>
+              <a:t>Q2: Do satellite and logger SST agree?</a:t>
             </a:r>
           </a:p>
         </p:txBody>
       </p:sp>
       <p:sp>
         <p:nvSpPr>
-          <p:cNvPr id="7" name="">
+          <p:cNvPr id="15" name="">
             <a:extLst xmlns:a="http://schemas.openxmlformats.org/drawingml/2006/main">
               <a:ext uri="{FF2B5EF4-FFF2-40B4-BE49-F238E27FC236}">
-                <a16:creationId xmlns:a16="http://schemas.microsoft.com/office/drawing/2014/main" id="{90DCF91C-A2D8-40BA-B07A-9FE52BD5F6CB}"/>
+                <a16:creationId xmlns:a16="http://schemas.microsoft.com/office/drawing/2014/main" id="{978D2EDC-6868-451B-89DF-45A23690B7BA}"/>
               </a:ext>
             </a:extLst>
           </p:cNvPr>
@@ -4182,8 +4245,8 @@
         </p:nvSpPr>
         <p:spPr>
           <a:xfrm xmlns:a="http://schemas.openxmlformats.org/drawingml/2006/main">
-            <a:off x="571500" y="5572125"/>
-            <a:ext cx="5334000" cy="952500"/>
+            <a:off x="571500" y="4324350"/>
+            <a:ext cx="5715000" cy="857250"/>
           </a:xfrm>
           <a:prstGeom xmlns:a="http://schemas.openxmlformats.org/drawingml/2006/main" prst="rect">
             <a:avLst/>
@@ -4197,7 +4260,7 @@
           <a:bodyPr xmlns:a="http://schemas.openxmlformats.org/drawingml/2006/main"/>
           <a:lstStyle xmlns:a="http://schemas.openxmlformats.org/drawingml/2006/main">
             <a:defPPr>
-              <a:defRPr sz="2100" b="0">
+              <a:defRPr sz="1875" b="0">
                 <a:solidFill>
                   <a:srgbClr val="263C49"/>
                 </a:solidFill>
@@ -4210,7 +4273,7 @@
           <a:p xmlns:a="http://schemas.openxmlformats.org/drawingml/2006/main">
             <a:pPr>
               <a:buNone/>
-              <a:defRPr sz="2100" b="0">
+              <a:defRPr sz="1875" b="0">
                 <a:solidFill>
                   <a:srgbClr val="263C49"/>
                 </a:solidFill>
@@ -4220,7 +4283,7 @@
               </a:defRPr>
             </a:pPr>
             <a:r>
-              <a:rPr sz="2100" b="0">
+              <a:rPr sz="1875" b="0">
                 <a:solidFill>
                   <a:srgbClr val="263C49"/>
                 </a:solidFill>
@@ -4228,39 +4291,145 @@
                 <a:ea typeface="Arial"/>
                 <a:cs typeface="Arial"/>
               </a:rPr>
-              <a:t>Compare a random forest with persistence and seasonal averages at three cells.</a:t>
+              <a:t>Compare nighttime logger means with satellite SST. Measure bias and RMSD (°C) by site, depth, and season.</a:t>
             </a:r>
           </a:p>
         </p:txBody>
       </p:sp>
-      <p:pic>
-        <p:nvPicPr>
-          <p:cNvPr id="8" name="">
+      <p:sp>
+        <p:nvSpPr>
+          <p:cNvPr id="16" name="">
             <a:extLst xmlns:a="http://schemas.openxmlformats.org/drawingml/2006/main">
               <a:ext uri="{FF2B5EF4-FFF2-40B4-BE49-F238E27FC236}">
-                <a16:creationId xmlns:a16="http://schemas.microsoft.com/office/drawing/2014/main" id="{DD899A49-C722-40A7-AD9C-67FE8B7936DA}"/>
+                <a16:creationId xmlns:a16="http://schemas.microsoft.com/office/drawing/2014/main" id="{A0A46B54-0109-48B0-AD75-2D5ABF8A30E0}"/>
               </a:ext>
             </a:extLst>
           </p:cNvPr>
-          <p:cNvPicPr>
-            <a:picLocks xmlns:a="http://schemas.openxmlformats.org/drawingml/2006/main" noChangeAspect="1"/>
-          </p:cNvPicPr>
+          <p:cNvSpPr>
+            <a:spLocks xmlns:a="http://schemas.openxmlformats.org/drawingml/2006/main" noGrp="1"/>
+          </p:cNvSpPr>
           <p:nvPr/>
-        </p:nvPicPr>
-        <p:blipFill>
-          <a:blip xmlns:r="http://schemas.openxmlformats.org/officeDocument/2006/relationships" xmlns:a="http://schemas.openxmlformats.org/drawingml/2006/main" r:embed="Rc0841741de2e4387"/>
-          <a:stretch xmlns:a="http://schemas.openxmlformats.org/drawingml/2006/main"/>
-        </p:blipFill>
+        </p:nvSpPr>
         <p:spPr>
           <a:xfrm xmlns:a="http://schemas.openxmlformats.org/drawingml/2006/main">
-            <a:off x="6238875" y="1664710"/>
-            <a:ext cx="5429250" cy="4195330"/>
+            <a:off x="571500" y="5191125"/>
+            <a:ext cx="5810250" cy="352425"/>
           </a:xfrm>
           <a:prstGeom xmlns:a="http://schemas.openxmlformats.org/drawingml/2006/main" prst="rect">
             <a:avLst/>
           </a:prstGeom>
+          <a:noFill xmlns:a="http://schemas.openxmlformats.org/drawingml/2006/main"/>
+          <a:ln xmlns:a="http://schemas.openxmlformats.org/drawingml/2006/main" w="0">
+            <a:noFill/>
+          </a:ln>
         </p:spPr>
-      </p:pic>
+        <p:txBody>
+          <a:bodyPr xmlns:a="http://schemas.openxmlformats.org/drawingml/2006/main"/>
+          <a:lstStyle xmlns:a="http://schemas.openxmlformats.org/drawingml/2006/main">
+            <a:defPPr>
+              <a:defRPr sz="2100" b="1">
+                <a:solidFill>
+                  <a:srgbClr val="167D91"/>
+                </a:solidFill>
+                <a:latin typeface="Arial"/>
+                <a:ea typeface="Arial"/>
+                <a:cs typeface="Arial"/>
+              </a:defRPr>
+            </a:defPPr>
+          </a:lstStyle>
+          <a:p xmlns:a="http://schemas.openxmlformats.org/drawingml/2006/main">
+            <a:pPr>
+              <a:buNone/>
+              <a:defRPr sz="2100" b="1">
+                <a:solidFill>
+                  <a:srgbClr val="167D91"/>
+                </a:solidFill>
+                <a:latin typeface="Arial"/>
+                <a:ea typeface="Arial"/>
+                <a:cs typeface="Arial"/>
+              </a:defRPr>
+            </a:pPr>
+            <a:r>
+              <a:rPr sz="2100" b="1">
+                <a:solidFill>
+                  <a:srgbClr val="167D91"/>
+                </a:solidFill>
+                <a:latin typeface="Arial"/>
+                <a:ea typeface="Arial"/>
+                <a:cs typeface="Arial"/>
+              </a:rPr>
+              <a:t>Q3: Can RF beat simple SST forecasts?</a:t>
+            </a:r>
+          </a:p>
+        </p:txBody>
+      </p:sp>
+      <p:sp>
+        <p:nvSpPr>
+          <p:cNvPr id="17" name="">
+            <a:extLst xmlns:a="http://schemas.openxmlformats.org/drawingml/2006/main">
+              <a:ext uri="{FF2B5EF4-FFF2-40B4-BE49-F238E27FC236}">
+                <a16:creationId xmlns:a16="http://schemas.microsoft.com/office/drawing/2014/main" id="{96C4D699-57B2-42AC-BBEF-4401C5AB19B5}"/>
+              </a:ext>
+            </a:extLst>
+          </p:cNvPr>
+          <p:cNvSpPr>
+            <a:spLocks xmlns:a="http://schemas.openxmlformats.org/drawingml/2006/main" noGrp="1"/>
+          </p:cNvSpPr>
+          <p:nvPr/>
+        </p:nvSpPr>
+        <p:spPr>
+          <a:xfrm xmlns:a="http://schemas.openxmlformats.org/drawingml/2006/main">
+            <a:off x="571500" y="5610225"/>
+            <a:ext cx="5715000" cy="857250"/>
+          </a:xfrm>
+          <a:prstGeom xmlns:a="http://schemas.openxmlformats.org/drawingml/2006/main" prst="rect">
+            <a:avLst/>
+          </a:prstGeom>
+          <a:noFill xmlns:a="http://schemas.openxmlformats.org/drawingml/2006/main"/>
+          <a:ln xmlns:a="http://schemas.openxmlformats.org/drawingml/2006/main" w="0">
+            <a:noFill/>
+          </a:ln>
+        </p:spPr>
+        <p:txBody>
+          <a:bodyPr xmlns:a="http://schemas.openxmlformats.org/drawingml/2006/main"/>
+          <a:lstStyle xmlns:a="http://schemas.openxmlformats.org/drawingml/2006/main">
+            <a:defPPr>
+              <a:defRPr sz="1875" b="0">
+                <a:solidFill>
+                  <a:srgbClr val="263C49"/>
+                </a:solidFill>
+                <a:latin typeface="Arial"/>
+                <a:ea typeface="Arial"/>
+                <a:cs typeface="Arial"/>
+              </a:defRPr>
+            </a:defPPr>
+          </a:lstStyle>
+          <a:p xmlns:a="http://schemas.openxmlformats.org/drawingml/2006/main">
+            <a:pPr>
+              <a:buNone/>
+              <a:defRPr sz="1875" b="0">
+                <a:solidFill>
+                  <a:srgbClr val="263C49"/>
+                </a:solidFill>
+                <a:latin typeface="Arial"/>
+                <a:ea typeface="Arial"/>
+                <a:cs typeface="Arial"/>
+              </a:defRPr>
+            </a:pPr>
+            <a:r>
+              <a:rPr sz="1875" b="0">
+                <a:solidFill>
+                  <a:srgbClr val="263C49"/>
+                </a:solidFill>
+                <a:latin typeface="Arial"/>
+                <a:ea typeface="Arial"/>
+                <a:cs typeface="Arial"/>
+              </a:rPr>
+              <a:t>Forecast satellite SST seven days ahead at three cells. Compare MAE and RMSE (°C) with persistence and seasonal averages.</a:t>
+            </a:r>
+          </a:p>
+        </p:txBody>
+      </p:sp>
     </p:spTree>
     <p:extLst>
       <p:ext uri="{BB962C8B-B14F-4D97-AF65-F5344CB8AC3E}">
@@ -4362,7 +4531,7 @@
           <p:cNvPr id="2" name="">
             <a:extLst xmlns:a="http://schemas.openxmlformats.org/drawingml/2006/main">
               <a:ext uri="{FF2B5EF4-FFF2-40B4-BE49-F238E27FC236}">
-                <a16:creationId xmlns:a16="http://schemas.microsoft.com/office/drawing/2014/main" id="{694F657C-FD05-4D04-9809-2629AAE9AAD1}"/>
+                <a16:creationId xmlns:a16="http://schemas.microsoft.com/office/drawing/2014/main" id="{16FF666C-8738-4274-8B3D-5B4D61EB2186}"/>
               </a:ext>
             </a:extLst>
           </p:cNvPr>
@@ -4372,13 +4541,13 @@
           <p:nvPr/>
         </p:nvPicPr>
         <p:blipFill>
-          <a:blip xmlns:r="http://schemas.openxmlformats.org/officeDocument/2006/relationships" xmlns:a="http://schemas.openxmlformats.org/drawingml/2006/main" r:embed="Rf770cea00bd646dd"/>
+          <a:blip xmlns:r="http://schemas.openxmlformats.org/officeDocument/2006/relationships" xmlns:a="http://schemas.openxmlformats.org/drawingml/2006/main" r:embed="R81baaf4465384c2b"/>
           <a:stretch xmlns:a="http://schemas.openxmlformats.org/drawingml/2006/main"/>
         </p:blipFill>
         <p:spPr>
           <a:xfrm xmlns:a="http://schemas.openxmlformats.org/drawingml/2006/main">
-            <a:off x="815228" y="1333500"/>
-            <a:ext cx="6656294" cy="5143500"/>
+            <a:off x="333375" y="1333500"/>
+            <a:ext cx="6810375" cy="5095875"/>
           </a:xfrm>
           <a:prstGeom xmlns:a="http://schemas.openxmlformats.org/drawingml/2006/main" prst="rect">
             <a:avLst/>
@@ -4387,10 +4556,10 @@
       </p:pic>
       <p:sp>
         <p:nvSpPr>
-          <p:cNvPr id="3" name="">
+          <p:cNvPr id="9" name="">
             <a:extLst xmlns:a="http://schemas.openxmlformats.org/drawingml/2006/main">
               <a:ext uri="{FF2B5EF4-FFF2-40B4-BE49-F238E27FC236}">
-                <a16:creationId xmlns:a16="http://schemas.microsoft.com/office/drawing/2014/main" id="{0716BE57-B410-4F9D-A889-91B651E2868B}"/>
+                <a16:creationId xmlns:a16="http://schemas.microsoft.com/office/drawing/2014/main" id="{20686C9A-02FA-4697-B203-76580071B786}"/>
               </a:ext>
             </a:extLst>
           </p:cNvPr>
@@ -4401,8 +4570,8 @@
         </p:nvSpPr>
         <p:spPr>
           <a:xfrm xmlns:a="http://schemas.openxmlformats.org/drawingml/2006/main">
-            <a:off x="8334375" y="1524000"/>
-            <a:ext cx="3286125" cy="428625"/>
+            <a:off x="7524750" y="1476375"/>
+            <a:ext cx="4191000" cy="400050"/>
           </a:xfrm>
           <a:prstGeom xmlns:a="http://schemas.openxmlformats.org/drawingml/2006/main" prst="rect">
             <a:avLst/>
@@ -4416,7 +4585,7 @@
           <a:bodyPr xmlns:a="http://schemas.openxmlformats.org/drawingml/2006/main"/>
           <a:lstStyle xmlns:a="http://schemas.openxmlformats.org/drawingml/2006/main">
             <a:defPPr>
-              <a:defRPr sz="2175" b="1">
+              <a:defRPr sz="2100" b="1">
                 <a:solidFill>
                   <a:srgbClr val="167D91"/>
                 </a:solidFill>
@@ -4429,7 +4598,7 @@
           <a:p xmlns:a="http://schemas.openxmlformats.org/drawingml/2006/main">
             <a:pPr>
               <a:buNone/>
-              <a:defRPr sz="2175" b="1">
+              <a:defRPr sz="2100" b="1">
                 <a:solidFill>
                   <a:srgbClr val="167D91"/>
                 </a:solidFill>
@@ -4439,7 +4608,7 @@
               </a:defRPr>
             </a:pPr>
             <a:r>
-              <a:rPr sz="2175" b="1">
+              <a:rPr sz="2100" b="1">
                 <a:solidFill>
                   <a:srgbClr val="167D91"/>
                 </a:solidFill>
@@ -4447,17 +4616,17 @@
                 <a:ea typeface="Arial"/>
                 <a:cs typeface="Arial"/>
               </a:rPr>
-              <a:t>Median peak DHW</a:t>
+              <a:t>Project, clip, and intersect</a:t>
             </a:r>
           </a:p>
         </p:txBody>
       </p:sp>
       <p:sp>
         <p:nvSpPr>
-          <p:cNvPr id="4" name="">
+          <p:cNvPr id="10" name="">
             <a:extLst xmlns:a="http://schemas.openxmlformats.org/drawingml/2006/main">
               <a:ext uri="{FF2B5EF4-FFF2-40B4-BE49-F238E27FC236}">
-                <a16:creationId xmlns:a16="http://schemas.microsoft.com/office/drawing/2014/main" id="{44856D46-D322-412E-A7DA-A9EE3E84BB7E}"/>
+                <a16:creationId xmlns:a16="http://schemas.microsoft.com/office/drawing/2014/main" id="{596B1BF4-21C6-4EED-B7A1-0550F526D7FF}"/>
               </a:ext>
             </a:extLst>
           </p:cNvPr>
@@ -4468,8 +4637,8 @@
         </p:nvSpPr>
         <p:spPr>
           <a:xfrm xmlns:a="http://schemas.openxmlformats.org/drawingml/2006/main">
-            <a:off x="8334375" y="2047875"/>
-            <a:ext cx="3286125" cy="1285875"/>
+            <a:off x="7524750" y="1933575"/>
+            <a:ext cx="4191000" cy="1190625"/>
           </a:xfrm>
           <a:prstGeom xmlns:a="http://schemas.openxmlformats.org/drawingml/2006/main" prst="rect">
             <a:avLst/>
@@ -4483,7 +4652,7 @@
           <a:bodyPr xmlns:a="http://schemas.openxmlformats.org/drawingml/2006/main"/>
           <a:lstStyle xmlns:a="http://schemas.openxmlformats.org/drawingml/2006/main">
             <a:defPPr>
-              <a:defRPr sz="2175" b="0">
+              <a:defRPr sz="1875" b="0">
                 <a:solidFill>
                   <a:srgbClr val="263C49"/>
                 </a:solidFill>
@@ -4496,7 +4665,7 @@
           <a:p xmlns:a="http://schemas.openxmlformats.org/drawingml/2006/main">
             <a:pPr>
               <a:buNone/>
-              <a:defRPr sz="2175" b="0">
+              <a:defRPr sz="1875" b="0">
                 <a:solidFill>
                   <a:srgbClr val="263C49"/>
                 </a:solidFill>
@@ -4506,7 +4675,7 @@
               </a:defRPr>
             </a:pPr>
             <a:r>
-              <a:rPr sz="2175" b="0">
+              <a:rPr sz="1875" b="0">
                 <a:solidFill>
                   <a:srgbClr val="263C49"/>
                 </a:solidFill>
@@ -4514,65 +4683,17 @@
                 <a:ea typeface="Arial"/>
                 <a:cs typeface="Arial"/>
               </a:rPr>
-              <a:t>11.64 in 2015</a:t>
-            </a:r>
-          </a:p>
-          <a:p xmlns:a="http://schemas.openxmlformats.org/drawingml/2006/main">
-            <a:pPr>
-              <a:buNone/>
-              <a:defRPr sz="2175" b="0">
-                <a:solidFill>
-                  <a:srgbClr val="263C49"/>
-                </a:solidFill>
-                <a:latin typeface="Arial"/>
-                <a:ea typeface="Arial"/>
-                <a:cs typeface="Arial"/>
-              </a:defRPr>
-            </a:pPr>
-            <a:r>
-              <a:rPr sz="2175" b="0">
-                <a:solidFill>
-                  <a:srgbClr val="263C49"/>
-                </a:solidFill>
-                <a:latin typeface="Arial"/>
-                <a:ea typeface="Arial"/>
-                <a:cs typeface="Arial"/>
-              </a:rPr>
-              <a:t>10.39 in 2019</a:t>
-            </a:r>
-          </a:p>
-          <a:p xmlns:a="http://schemas.openxmlformats.org/drawingml/2006/main">
-            <a:pPr>
-              <a:buNone/>
-              <a:defRPr sz="2175" b="0">
-                <a:solidFill>
-                  <a:srgbClr val="263C49"/>
-                </a:solidFill>
-                <a:latin typeface="Arial"/>
-                <a:ea typeface="Arial"/>
-                <a:cs typeface="Arial"/>
-              </a:defRPr>
-            </a:pPr>
-            <a:r>
-              <a:rPr sz="2175" b="0">
-                <a:solidFill>
-                  <a:srgbClr val="263C49"/>
-                </a:solidFill>
-                <a:latin typeface="Arial"/>
-                <a:ea typeface="Arial"/>
-                <a:cs typeface="Arial"/>
-              </a:rPr>
-              <a:t>°C-weeks</a:t>
+              <a:t>Create a 0.05° fishnet and project to UTM 5N. Clip habitat to the AOI, intersect with the grid, and calculate reef hectares.</a:t>
             </a:r>
           </a:p>
         </p:txBody>
       </p:sp>
       <p:sp>
         <p:nvSpPr>
-          <p:cNvPr id="5" name="">
+          <p:cNvPr id="11" name="">
             <a:extLst xmlns:a="http://schemas.openxmlformats.org/drawingml/2006/main">
               <a:ext uri="{FF2B5EF4-FFF2-40B4-BE49-F238E27FC236}">
-                <a16:creationId xmlns:a16="http://schemas.microsoft.com/office/drawing/2014/main" id="{19CA54D0-B307-42AE-8EC4-9961B18EF7DF}"/>
+                <a16:creationId xmlns:a16="http://schemas.microsoft.com/office/drawing/2014/main" id="{4C9E3A45-18F7-425C-AEAC-E433788C8C06}"/>
               </a:ext>
             </a:extLst>
           </p:cNvPr>
@@ -4583,8 +4704,8 @@
         </p:nvSpPr>
         <p:spPr>
           <a:xfrm xmlns:a="http://schemas.openxmlformats.org/drawingml/2006/main">
-            <a:off x="8334375" y="3571875"/>
-            <a:ext cx="3286125" cy="762000"/>
+            <a:off x="7524750" y="3286125"/>
+            <a:ext cx="4191000" cy="400050"/>
           </a:xfrm>
           <a:prstGeom xmlns:a="http://schemas.openxmlformats.org/drawingml/2006/main" prst="rect">
             <a:avLst/>
@@ -4598,7 +4719,7 @@
           <a:bodyPr xmlns:a="http://schemas.openxmlformats.org/drawingml/2006/main"/>
           <a:lstStyle xmlns:a="http://schemas.openxmlformats.org/drawingml/2006/main">
             <a:defPPr>
-              <a:defRPr sz="2175" b="1">
+              <a:defRPr sz="2100" b="1">
                 <a:solidFill>
                   <a:srgbClr val="167D91"/>
                 </a:solidFill>
@@ -4611,7 +4732,7 @@
           <a:p xmlns:a="http://schemas.openxmlformats.org/drawingml/2006/main">
             <a:pPr>
               <a:buNone/>
-              <a:defRPr sz="2175" b="1">
+              <a:defRPr sz="2100" b="1">
                 <a:solidFill>
                   <a:srgbClr val="167D91"/>
                 </a:solidFill>
@@ -4621,7 +4742,7 @@
               </a:defRPr>
             </a:pPr>
             <a:r>
-              <a:rPr sz="2175" b="1">
+              <a:rPr sz="2100" b="1">
                 <a:solidFill>
                   <a:srgbClr val="167D91"/>
                 </a:solidFill>
@@ -4629,17 +4750,17 @@
                 <a:ea typeface="Arial"/>
                 <a:cs typeface="Arial"/>
               </a:rPr>
-              <a:t>Reef area reaching DHW ≥8</a:t>
+              <a:t>Summarize and join DHW</a:t>
             </a:r>
           </a:p>
         </p:txBody>
       </p:sp>
       <p:sp>
         <p:nvSpPr>
-          <p:cNvPr id="6" name="">
+          <p:cNvPr id="12" name="">
             <a:extLst xmlns:a="http://schemas.openxmlformats.org/drawingml/2006/main">
               <a:ext uri="{FF2B5EF4-FFF2-40B4-BE49-F238E27FC236}">
-                <a16:creationId xmlns:a16="http://schemas.microsoft.com/office/drawing/2014/main" id="{81566CB9-C51C-4CEF-8F64-4616613972E8}"/>
+                <a16:creationId xmlns:a16="http://schemas.microsoft.com/office/drawing/2014/main" id="{1D879499-DB44-4D41-98D5-3354408E326D}"/>
               </a:ext>
             </a:extLst>
           </p:cNvPr>
@@ -4650,8 +4771,8 @@
         </p:nvSpPr>
         <p:spPr>
           <a:xfrm xmlns:a="http://schemas.openxmlformats.org/drawingml/2006/main">
-            <a:off x="8334375" y="4476750"/>
-            <a:ext cx="3286125" cy="904875"/>
+            <a:off x="7524750" y="3743325"/>
+            <a:ext cx="4191000" cy="1047750"/>
           </a:xfrm>
           <a:prstGeom xmlns:a="http://schemas.openxmlformats.org/drawingml/2006/main" prst="rect">
             <a:avLst/>
@@ -4665,7 +4786,7 @@
           <a:bodyPr xmlns:a="http://schemas.openxmlformats.org/drawingml/2006/main"/>
           <a:lstStyle xmlns:a="http://schemas.openxmlformats.org/drawingml/2006/main">
             <a:defPPr>
-              <a:defRPr sz="2175" b="0">
+              <a:defRPr sz="1875" b="0">
                 <a:solidFill>
                   <a:srgbClr val="263C49"/>
                 </a:solidFill>
@@ -4678,7 +4799,7 @@
           <a:p xmlns:a="http://schemas.openxmlformats.org/drawingml/2006/main">
             <a:pPr>
               <a:buNone/>
-              <a:defRPr sz="2175" b="0">
+              <a:defRPr sz="1875" b="0">
                 <a:solidFill>
                   <a:srgbClr val="263C49"/>
                 </a:solidFill>
@@ -4688,7 +4809,7 @@
               </a:defRPr>
             </a:pPr>
             <a:r>
-              <a:rPr sz="2175" b="0">
+              <a:rPr sz="1875" b="0">
                 <a:solidFill>
                   <a:srgbClr val="263C49"/>
                 </a:solidFill>
@@ -4696,41 +4817,17 @@
                 <a:ea typeface="Arial"/>
                 <a:cs typeface="Arial"/>
               </a:rPr>
-              <a:t>4,731 ha in 2015</a:t>
-            </a:r>
-          </a:p>
-          <a:p xmlns:a="http://schemas.openxmlformats.org/drawingml/2006/main">
-            <a:pPr>
-              <a:buNone/>
-              <a:defRPr sz="2175" b="0">
-                <a:solidFill>
-                  <a:srgbClr val="263C49"/>
-                </a:solidFill>
-                <a:latin typeface="Arial"/>
-                <a:ea typeface="Arial"/>
-                <a:cs typeface="Arial"/>
-              </a:defRPr>
-            </a:pPr>
-            <a:r>
-              <a:rPr sz="2175" b="0">
-                <a:solidFill>
-                  <a:srgbClr val="263C49"/>
-                </a:solidFill>
-                <a:latin typeface="Arial"/>
-                <a:ea typeface="Arial"/>
-                <a:cs typeface="Arial"/>
-              </a:rPr>
-              <a:t>3,612 ha in 2019</a:t>
+              <a:t>Summarize daily DHW by cell and year. Join peak DHW and threshold-day totals to the grid and reef pieces.</a:t>
             </a:r>
           </a:p>
         </p:txBody>
       </p:sp>
       <p:sp>
         <p:nvSpPr>
-          <p:cNvPr id="7" name="">
+          <p:cNvPr id="13" name="">
             <a:extLst xmlns:a="http://schemas.openxmlformats.org/drawingml/2006/main">
               <a:ext uri="{FF2B5EF4-FFF2-40B4-BE49-F238E27FC236}">
-                <a16:creationId xmlns:a16="http://schemas.microsoft.com/office/drawing/2014/main" id="{81B54E4A-7D04-4A90-A1DD-695A7DA415EA}"/>
+                <a16:creationId xmlns:a16="http://schemas.microsoft.com/office/drawing/2014/main" id="{A2F4BBCF-5421-43B6-88FE-F96EB02768A4}"/>
               </a:ext>
             </a:extLst>
           </p:cNvPr>
@@ -4741,8 +4838,8 @@
         </p:nvSpPr>
         <p:spPr>
           <a:xfrm xmlns:a="http://schemas.openxmlformats.org/drawingml/2006/main">
-            <a:off x="8334375" y="5667375"/>
-            <a:ext cx="3286125" cy="809625"/>
+            <a:off x="7524750" y="4953000"/>
+            <a:ext cx="4191000" cy="400050"/>
           </a:xfrm>
           <a:prstGeom xmlns:a="http://schemas.openxmlformats.org/drawingml/2006/main" prst="rect">
             <a:avLst/>
@@ -4756,9 +4853,9 @@
           <a:bodyPr xmlns:a="http://schemas.openxmlformats.org/drawingml/2006/main"/>
           <a:lstStyle xmlns:a="http://schemas.openxmlformats.org/drawingml/2006/main">
             <a:defPPr>
-              <a:defRPr sz="1725" b="0">
-                <a:solidFill>
-                  <a:srgbClr val="263C49"/>
+              <a:defRPr sz="2100" b="1">
+                <a:solidFill>
+                  <a:srgbClr val="167D91"/>
                 </a:solidFill>
                 <a:latin typeface="Arial"/>
                 <a:ea typeface="Arial"/>
@@ -4769,7 +4866,61 @@
           <a:p xmlns:a="http://schemas.openxmlformats.org/drawingml/2006/main">
             <a:pPr>
               <a:buNone/>
-              <a:defRPr sz="1725" b="0">
+              <a:defRPr sz="2100" b="1">
+                <a:solidFill>
+                  <a:srgbClr val="167D91"/>
+                </a:solidFill>
+                <a:latin typeface="Arial"/>
+                <a:ea typeface="Arial"/>
+                <a:cs typeface="Arial"/>
+              </a:defRPr>
+            </a:pPr>
+            <a:r>
+              <a:rPr sz="2100" b="1">
+                <a:solidFill>
+                  <a:srgbClr val="167D91"/>
+                </a:solidFill>
+                <a:latin typeface="Arial"/>
+                <a:ea typeface="Arial"/>
+                <a:cs typeface="Arial"/>
+              </a:rPr>
+              <a:t>Compare the two years</a:t>
+            </a:r>
+          </a:p>
+        </p:txBody>
+      </p:sp>
+      <p:sp>
+        <p:nvSpPr>
+          <p:cNvPr id="14" name="">
+            <a:extLst xmlns:a="http://schemas.openxmlformats.org/drawingml/2006/main">
+              <a:ext uri="{FF2B5EF4-FFF2-40B4-BE49-F238E27FC236}">
+                <a16:creationId xmlns:a16="http://schemas.microsoft.com/office/drawing/2014/main" id="{8B8502F0-3690-48A8-AECB-594664198DA1}"/>
+              </a:ext>
+            </a:extLst>
+          </p:cNvPr>
+          <p:cNvSpPr>
+            <a:spLocks xmlns:a="http://schemas.openxmlformats.org/drawingml/2006/main" noGrp="1"/>
+          </p:cNvSpPr>
+          <p:nvPr/>
+        </p:nvSpPr>
+        <p:spPr>
+          <a:xfrm xmlns:a="http://schemas.openxmlformats.org/drawingml/2006/main">
+            <a:off x="7524750" y="5410200"/>
+            <a:ext cx="4191000" cy="1143000"/>
+          </a:xfrm>
+          <a:prstGeom xmlns:a="http://schemas.openxmlformats.org/drawingml/2006/main" prst="rect">
+            <a:avLst/>
+          </a:prstGeom>
+          <a:noFill xmlns:a="http://schemas.openxmlformats.org/drawingml/2006/main"/>
+          <a:ln xmlns:a="http://schemas.openxmlformats.org/drawingml/2006/main" w="0">
+            <a:noFill/>
+          </a:ln>
+        </p:spPr>
+        <p:txBody>
+          <a:bodyPr xmlns:a="http://schemas.openxmlformats.org/drawingml/2006/main"/>
+          <a:lstStyle xmlns:a="http://schemas.openxmlformats.org/drawingml/2006/main">
+            <a:defPPr>
+              <a:defRPr sz="1875" b="0">
                 <a:solidFill>
                   <a:srgbClr val="263C49"/>
                 </a:solidFill>
@@ -4777,9 +4928,22 @@
                 <a:ea typeface="Arial"/>
                 <a:cs typeface="Arial"/>
               </a:defRPr>
+            </a:defPPr>
+          </a:lstStyle>
+          <a:p xmlns:a="http://schemas.openxmlformats.org/drawingml/2006/main">
+            <a:pPr>
+              <a:buNone/>
+              <a:defRPr sz="1875" b="0">
+                <a:solidFill>
+                  <a:srgbClr val="263C49"/>
+                </a:solidFill>
+                <a:latin typeface="Arial"/>
+                <a:ea typeface="Arial"/>
+                <a:cs typeface="Arial"/>
+              </a:defRPr>
             </a:pPr>
             <a:r>
-              <a:rPr sz="1725" b="0">
+              <a:rPr sz="1875" b="0">
                 <a:solidFill>
                   <a:srgbClr val="263C49"/>
                 </a:solidFill>
@@ -4787,7 +4951,7 @@
                 <a:ea typeface="Arial"/>
                 <a:cs typeface="Arial"/>
               </a:rPr>
-              <a:t>971 ha of mapped habitat lacked valid satellite DHW.</a:t>
+              <a:t>Pair 135 valid water cells. Median peak DHW: 11.64 vs. 10.39 °C-weeks. Reef area at DHW ≥8: 4,731 vs. 3,612 ha.</a:t>
             </a:r>
           </a:p>
         </p:txBody>
@@ -4888,12 +5052,40 @@
           </a:p>
         </p:txBody>
       </p:sp>
-      <p:sp>
-        <p:nvSpPr>
-          <p:cNvPr id="2" name="">
+      <p:pic>
+        <p:nvPicPr>
+          <p:cNvPr id="7" name="">
             <a:extLst xmlns:a="http://schemas.openxmlformats.org/drawingml/2006/main">
               <a:ext uri="{FF2B5EF4-FFF2-40B4-BE49-F238E27FC236}">
-                <a16:creationId xmlns:a16="http://schemas.microsoft.com/office/drawing/2014/main" id="{31CF5144-0BB2-49B9-946B-9F7EF1C9AEC3}"/>
+                <a16:creationId xmlns:a16="http://schemas.microsoft.com/office/drawing/2014/main" id="{07AD9825-64AF-4C0A-BDD9-631BFDF6AF8A}"/>
+              </a:ext>
+            </a:extLst>
+          </p:cNvPr>
+          <p:cNvPicPr>
+            <a:picLocks xmlns:a="http://schemas.openxmlformats.org/drawingml/2006/main" noChangeAspect="1"/>
+          </p:cNvPicPr>
+          <p:nvPr/>
+        </p:nvPicPr>
+        <p:blipFill>
+          <a:blip xmlns:r="http://schemas.openxmlformats.org/officeDocument/2006/relationships" xmlns:a="http://schemas.openxmlformats.org/drawingml/2006/main" r:embed="Rd31752c3cfb54311"/>
+          <a:stretch xmlns:a="http://schemas.openxmlformats.org/drawingml/2006/main"/>
+        </p:blipFill>
+        <p:spPr>
+          <a:xfrm xmlns:a="http://schemas.openxmlformats.org/drawingml/2006/main">
+            <a:off x="381000" y="1474509"/>
+            <a:ext cx="11430000" cy="1956357"/>
+          </a:xfrm>
+          <a:prstGeom xmlns:a="http://schemas.openxmlformats.org/drawingml/2006/main" prst="rect">
+            <a:avLst/>
+          </a:prstGeom>
+        </p:spPr>
+      </p:pic>
+      <p:sp>
+        <p:nvSpPr>
+          <p:cNvPr id="8" name="">
+            <a:extLst xmlns:a="http://schemas.openxmlformats.org/drawingml/2006/main">
+              <a:ext uri="{FF2B5EF4-FFF2-40B4-BE49-F238E27FC236}">
+                <a16:creationId xmlns:a16="http://schemas.microsoft.com/office/drawing/2014/main" id="{E79E1808-7FEE-4EA4-A163-BC96EF2F29F9}"/>
               </a:ext>
             </a:extLst>
           </p:cNvPr>
@@ -4904,8 +5096,8 @@
         </p:nvSpPr>
         <p:spPr>
           <a:xfrm xmlns:a="http://schemas.openxmlformats.org/drawingml/2006/main">
-            <a:off x="571500" y="1428750"/>
-            <a:ext cx="10668000" cy="476250"/>
+            <a:off x="571500" y="3952875"/>
+            <a:ext cx="5238750" cy="409575"/>
           </a:xfrm>
           <a:prstGeom xmlns:a="http://schemas.openxmlformats.org/drawingml/2006/main" prst="rect">
             <a:avLst/>
@@ -4919,7 +5111,7 @@
           <a:bodyPr xmlns:a="http://schemas.openxmlformats.org/drawingml/2006/main"/>
           <a:lstStyle xmlns:a="http://schemas.openxmlformats.org/drawingml/2006/main">
             <a:defPPr>
-              <a:defRPr sz="2250" b="1">
+              <a:defRPr sz="2100" b="1">
                 <a:solidFill>
                   <a:srgbClr val="167D91"/>
                 </a:solidFill>
@@ -4932,7 +5124,7 @@
           <a:p xmlns:a="http://schemas.openxmlformats.org/drawingml/2006/main">
             <a:pPr>
               <a:buNone/>
-              <a:defRPr sz="2250" b="1">
+              <a:defRPr sz="2100" b="1">
                 <a:solidFill>
                   <a:srgbClr val="167D91"/>
                 </a:solidFill>
@@ -4942,7 +5134,7 @@
               </a:defRPr>
             </a:pPr>
             <a:r>
-              <a:rPr sz="2250" b="1">
+              <a:rPr sz="2100" b="1">
                 <a:solidFill>
                   <a:srgbClr val="167D91"/>
                 </a:solidFill>
@@ -4950,528 +5142,17 @@
                 <a:ea typeface="Arial"/>
                 <a:cs typeface="Arial"/>
               </a:rPr>
-              <a:t>August–November RMSD (°C)</a:t>
+              <a:t>XY points and spatial matching</a:t>
             </a:r>
           </a:p>
         </p:txBody>
       </p:sp>
-      <p:graphicFrame>
-        <p:nvGraphicFramePr>
-          <p:cNvPr id="3" name="">
+      <p:sp>
+        <p:nvSpPr>
+          <p:cNvPr id="9" name="">
             <a:extLst xmlns:a="http://schemas.openxmlformats.org/drawingml/2006/main">
               <a:ext uri="{FF2B5EF4-FFF2-40B4-BE49-F238E27FC236}">
-                <a16:creationId xmlns:a16="http://schemas.microsoft.com/office/drawing/2014/main" id="{B187267C-7C89-45CD-9BA4-3EFB3BFA4F9A}"/>
-              </a:ext>
-            </a:extLst>
-          </p:cNvPr>
-          <p:cNvGraphicFramePr/>
-          <p:nvPr/>
-        </p:nvGraphicFramePr>
-        <p:xfrm>
-          <a:off xmlns:a="http://schemas.openxmlformats.org/drawingml/2006/main" x="571500" y="2143125"/>
-          <a:ext xmlns:a="http://schemas.openxmlformats.org/drawingml/2006/main" cx="10668000" cy="2476500"/>
-        </p:xfrm>
-        <a:graphic xmlns:a="http://schemas.openxmlformats.org/drawingml/2006/main">
-          <a:graphicData uri="http://schemas.openxmlformats.org/drawingml/2006/table">
-            <a:tbl>
-              <a:tblPr/>
-              <a:tblGrid>
-                <a:gridCol w="5905500"/>
-                <a:gridCol w="2381250"/>
-                <a:gridCol w="2381250"/>
-              </a:tblGrid>
-              <a:tr h="619125">
-                <a:tc>
-                  <a:txBody>
-                    <a:bodyPr/>
-                    <a:lstStyle/>
-                    <a:p>
-                      <a:r>
-                        <a:rPr sz="2100" b="1">
-                          <a:solidFill>
-                            <a:srgbClr val="FFFFFF"/>
-                          </a:solidFill>
-                          <a:latin typeface="Arial"/>
-                          <a:ea typeface="Arial"/>
-                          <a:cs typeface="Arial"/>
-                        </a:rPr>
-                        <a:t>Monitoring site</a:t>
-                      </a:r>
-                    </a:p>
-                  </a:txBody>
-                  <a:tcPr marL="91440" marR="91440" marT="45720" marB="45720">
-                    <a:lnL w="9525">
-                      <a:solidFill>
-                        <a:srgbClr val="D9E1E5"/>
-                      </a:solidFill>
-                      <a:prstDash val="solid"/>
-                    </a:lnL>
-                    <a:lnR w="9525">
-                      <a:solidFill>
-                        <a:srgbClr val="D9E1E5"/>
-                      </a:solidFill>
-                      <a:prstDash val="solid"/>
-                    </a:lnR>
-                    <a:lnT w="9525">
-                      <a:solidFill>
-                        <a:srgbClr val="D9E1E5"/>
-                      </a:solidFill>
-                      <a:prstDash val="solid"/>
-                    </a:lnT>
-                    <a:lnB w="9525">
-                      <a:solidFill>
-                        <a:srgbClr val="D9E1E5"/>
-                      </a:solidFill>
-                      <a:prstDash val="solid"/>
-                    </a:lnB>
-                    <a:solidFill>
-                      <a:srgbClr val="152F45"/>
-                    </a:solidFill>
-                  </a:tcPr>
-                </a:tc>
-                <a:tc>
-                  <a:txBody>
-                    <a:bodyPr/>
-                    <a:lstStyle/>
-                    <a:p>
-                      <a:r>
-                        <a:rPr sz="2100" b="1">
-                          <a:solidFill>
-                            <a:srgbClr val="FFFFFF"/>
-                          </a:solidFill>
-                          <a:latin typeface="Arial"/>
-                          <a:ea typeface="Arial"/>
-                          <a:cs typeface="Arial"/>
-                        </a:rPr>
-                        <a:t>2015</a:t>
-                      </a:r>
-                    </a:p>
-                  </a:txBody>
-                  <a:tcPr marL="91440" marR="91440" marT="45720" marB="45720">
-                    <a:lnR w="9525">
-                      <a:solidFill>
-                        <a:srgbClr val="D9E1E5"/>
-                      </a:solidFill>
-                      <a:prstDash val="solid"/>
-                    </a:lnR>
-                    <a:lnT w="9525">
-                      <a:solidFill>
-                        <a:srgbClr val="D9E1E5"/>
-                      </a:solidFill>
-                      <a:prstDash val="solid"/>
-                    </a:lnT>
-                    <a:lnB w="9525">
-                      <a:solidFill>
-                        <a:srgbClr val="D9E1E5"/>
-                      </a:solidFill>
-                      <a:prstDash val="solid"/>
-                    </a:lnB>
-                    <a:solidFill>
-                      <a:srgbClr val="152F45"/>
-                    </a:solidFill>
-                  </a:tcPr>
-                </a:tc>
-                <a:tc>
-                  <a:txBody>
-                    <a:bodyPr/>
-                    <a:lstStyle/>
-                    <a:p>
-                      <a:r>
-                        <a:rPr sz="2100" b="1">
-                          <a:solidFill>
-                            <a:srgbClr val="FFFFFF"/>
-                          </a:solidFill>
-                          <a:latin typeface="Arial"/>
-                          <a:ea typeface="Arial"/>
-                          <a:cs typeface="Arial"/>
-                        </a:rPr>
-                        <a:t>2019</a:t>
-                      </a:r>
-                    </a:p>
-                  </a:txBody>
-                  <a:tcPr marL="91440" marR="91440" marT="45720" marB="45720">
-                    <a:lnR w="9525">
-                      <a:solidFill>
-                        <a:srgbClr val="D9E1E5"/>
-                      </a:solidFill>
-                      <a:prstDash val="solid"/>
-                    </a:lnR>
-                    <a:lnT w="9525">
-                      <a:solidFill>
-                        <a:srgbClr val="D9E1E5"/>
-                      </a:solidFill>
-                      <a:prstDash val="solid"/>
-                    </a:lnT>
-                    <a:lnB w="9525">
-                      <a:solidFill>
-                        <a:srgbClr val="D9E1E5"/>
-                      </a:solidFill>
-                      <a:prstDash val="solid"/>
-                    </a:lnB>
-                    <a:solidFill>
-                      <a:srgbClr val="152F45"/>
-                    </a:solidFill>
-                  </a:tcPr>
-                </a:tc>
-              </a:tr>
-              <a:tr h="619125">
-                <a:tc>
-                  <a:txBody>
-                    <a:bodyPr/>
-                    <a:lstStyle/>
-                    <a:p>
-                      <a:r>
-                        <a:rPr sz="2100" b="0">
-                          <a:solidFill>
-                            <a:srgbClr val="263C49"/>
-                          </a:solidFill>
-                          <a:latin typeface="Arial"/>
-                          <a:ea typeface="Arial"/>
-                          <a:cs typeface="Arial"/>
-                        </a:rPr>
-                        <a:t>OCC-HAW-001</a:t>
-                      </a:r>
-                    </a:p>
-                  </a:txBody>
-                  <a:tcPr marL="91440" marR="91440" marT="45720" marB="45720">
-                    <a:lnL w="9525">
-                      <a:solidFill>
-                        <a:srgbClr val="D9E1E5"/>
-                      </a:solidFill>
-                      <a:prstDash val="solid"/>
-                    </a:lnL>
-                    <a:lnR w="9525">
-                      <a:solidFill>
-                        <a:srgbClr val="D9E1E5"/>
-                      </a:solidFill>
-                      <a:prstDash val="solid"/>
-                    </a:lnR>
-                    <a:lnB w="9525">
-                      <a:solidFill>
-                        <a:srgbClr val="D9E1E5"/>
-                      </a:solidFill>
-                      <a:prstDash val="solid"/>
-                    </a:lnB>
-                    <a:solidFill>
-                      <a:srgbClr val="FFFFFF"/>
-                    </a:solidFill>
-                  </a:tcPr>
-                </a:tc>
-                <a:tc>
-                  <a:txBody>
-                    <a:bodyPr/>
-                    <a:lstStyle/>
-                    <a:p>
-                      <a:r>
-                        <a:rPr sz="2100" b="0">
-                          <a:solidFill>
-                            <a:srgbClr val="263C49"/>
-                          </a:solidFill>
-                          <a:latin typeface="Arial"/>
-                          <a:ea typeface="Arial"/>
-                          <a:cs typeface="Arial"/>
-                        </a:rPr>
-                        <a:t>0.741</a:t>
-                      </a:r>
-                    </a:p>
-                  </a:txBody>
-                  <a:tcPr marL="91440" marR="91440" marT="45720" marB="45720">
-                    <a:lnR w="9525">
-                      <a:solidFill>
-                        <a:srgbClr val="D9E1E5"/>
-                      </a:solidFill>
-                      <a:prstDash val="solid"/>
-                    </a:lnR>
-                    <a:lnB w="9525">
-                      <a:solidFill>
-                        <a:srgbClr val="D9E1E5"/>
-                      </a:solidFill>
-                      <a:prstDash val="solid"/>
-                    </a:lnB>
-                    <a:solidFill>
-                      <a:srgbClr val="FFFFFF"/>
-                    </a:solidFill>
-                  </a:tcPr>
-                </a:tc>
-                <a:tc>
-                  <a:txBody>
-                    <a:bodyPr/>
-                    <a:lstStyle/>
-                    <a:p>
-                      <a:r>
-                        <a:rPr sz="2100" b="0">
-                          <a:solidFill>
-                            <a:srgbClr val="263C49"/>
-                          </a:solidFill>
-                          <a:latin typeface="Arial"/>
-                          <a:ea typeface="Arial"/>
-                          <a:cs typeface="Arial"/>
-                        </a:rPr>
-                        <a:t>0.334</a:t>
-                      </a:r>
-                    </a:p>
-                  </a:txBody>
-                  <a:tcPr marL="91440" marR="91440" marT="45720" marB="45720">
-                    <a:lnR w="9525">
-                      <a:solidFill>
-                        <a:srgbClr val="D9E1E5"/>
-                      </a:solidFill>
-                      <a:prstDash val="solid"/>
-                    </a:lnR>
-                    <a:lnB w="9525">
-                      <a:solidFill>
-                        <a:srgbClr val="D9E1E5"/>
-                      </a:solidFill>
-                      <a:prstDash val="solid"/>
-                    </a:lnB>
-                    <a:solidFill>
-                      <a:srgbClr val="FFFFFF"/>
-                    </a:solidFill>
-                  </a:tcPr>
-                </a:tc>
-              </a:tr>
-              <a:tr h="619125">
-                <a:tc>
-                  <a:txBody>
-                    <a:bodyPr/>
-                    <a:lstStyle/>
-                    <a:p>
-                      <a:r>
-                        <a:rPr sz="2100" b="0">
-                          <a:solidFill>
-                            <a:srgbClr val="263C49"/>
-                          </a:solidFill>
-                          <a:latin typeface="Arial"/>
-                          <a:ea typeface="Arial"/>
-                          <a:cs typeface="Arial"/>
-                        </a:rPr>
-                        <a:t>OCC-HAW-002</a:t>
-                      </a:r>
-                    </a:p>
-                  </a:txBody>
-                  <a:tcPr marL="91440" marR="91440" marT="45720" marB="45720">
-                    <a:lnL w="9525">
-                      <a:solidFill>
-                        <a:srgbClr val="D9E1E5"/>
-                      </a:solidFill>
-                      <a:prstDash val="solid"/>
-                    </a:lnL>
-                    <a:lnR w="9525">
-                      <a:solidFill>
-                        <a:srgbClr val="D9E1E5"/>
-                      </a:solidFill>
-                      <a:prstDash val="solid"/>
-                    </a:lnR>
-                    <a:lnB w="9525">
-                      <a:solidFill>
-                        <a:srgbClr val="D9E1E5"/>
-                      </a:solidFill>
-                      <a:prstDash val="solid"/>
-                    </a:lnB>
-                    <a:solidFill>
-                      <a:srgbClr val="F0F5F7"/>
-                    </a:solidFill>
-                  </a:tcPr>
-                </a:tc>
-                <a:tc>
-                  <a:txBody>
-                    <a:bodyPr/>
-                    <a:lstStyle/>
-                    <a:p>
-                      <a:r>
-                        <a:rPr sz="2100" b="0">
-                          <a:solidFill>
-                            <a:srgbClr val="263C49"/>
-                          </a:solidFill>
-                          <a:latin typeface="Arial"/>
-                          <a:ea typeface="Arial"/>
-                          <a:cs typeface="Arial"/>
-                        </a:rPr>
-                        <a:t>0.566</a:t>
-                      </a:r>
-                    </a:p>
-                  </a:txBody>
-                  <a:tcPr marL="91440" marR="91440" marT="45720" marB="45720">
-                    <a:lnR w="9525">
-                      <a:solidFill>
-                        <a:srgbClr val="D9E1E5"/>
-                      </a:solidFill>
-                      <a:prstDash val="solid"/>
-                    </a:lnR>
-                    <a:lnB w="9525">
-                      <a:solidFill>
-                        <a:srgbClr val="D9E1E5"/>
-                      </a:solidFill>
-                      <a:prstDash val="solid"/>
-                    </a:lnB>
-                    <a:solidFill>
-                      <a:srgbClr val="F0F5F7"/>
-                    </a:solidFill>
-                  </a:tcPr>
-                </a:tc>
-                <a:tc>
-                  <a:txBody>
-                    <a:bodyPr/>
-                    <a:lstStyle/>
-                    <a:p>
-                      <a:r>
-                        <a:rPr sz="2100" b="0">
-                          <a:solidFill>
-                            <a:srgbClr val="263C49"/>
-                          </a:solidFill>
-                          <a:latin typeface="Arial"/>
-                          <a:ea typeface="Arial"/>
-                          <a:cs typeface="Arial"/>
-                        </a:rPr>
-                        <a:t>0.290</a:t>
-                      </a:r>
-                    </a:p>
-                  </a:txBody>
-                  <a:tcPr marL="91440" marR="91440" marT="45720" marB="45720">
-                    <a:lnR w="9525">
-                      <a:solidFill>
-                        <a:srgbClr val="D9E1E5"/>
-                      </a:solidFill>
-                      <a:prstDash val="solid"/>
-                    </a:lnR>
-                    <a:lnB w="9525">
-                      <a:solidFill>
-                        <a:srgbClr val="D9E1E5"/>
-                      </a:solidFill>
-                      <a:prstDash val="solid"/>
-                    </a:lnB>
-                    <a:solidFill>
-                      <a:srgbClr val="F0F5F7"/>
-                    </a:solidFill>
-                  </a:tcPr>
-                </a:tc>
-              </a:tr>
-              <a:tr h="619125">
-                <a:tc>
-                  <a:txBody>
-                    <a:bodyPr/>
-                    <a:lstStyle/>
-                    <a:p>
-                      <a:r>
-                        <a:rPr sz="2100" b="0">
-                          <a:solidFill>
-                            <a:srgbClr val="263C49"/>
-                          </a:solidFill>
-                          <a:latin typeface="Arial"/>
-                          <a:ea typeface="Arial"/>
-                          <a:cs typeface="Arial"/>
-                        </a:rPr>
-                        <a:t>OCC-HAW-009</a:t>
-                      </a:r>
-                    </a:p>
-                  </a:txBody>
-                  <a:tcPr marL="91440" marR="91440" marT="45720" marB="45720">
-                    <a:lnL w="9525">
-                      <a:solidFill>
-                        <a:srgbClr val="D9E1E5"/>
-                      </a:solidFill>
-                      <a:prstDash val="solid"/>
-                    </a:lnL>
-                    <a:lnR w="9525">
-                      <a:solidFill>
-                        <a:srgbClr val="D9E1E5"/>
-                      </a:solidFill>
-                      <a:prstDash val="solid"/>
-                    </a:lnR>
-                    <a:lnB w="9525">
-                      <a:solidFill>
-                        <a:srgbClr val="D9E1E5"/>
-                      </a:solidFill>
-                      <a:prstDash val="solid"/>
-                    </a:lnB>
-                    <a:solidFill>
-                      <a:srgbClr val="FFFFFF"/>
-                    </a:solidFill>
-                  </a:tcPr>
-                </a:tc>
-                <a:tc>
-                  <a:txBody>
-                    <a:bodyPr/>
-                    <a:lstStyle/>
-                    <a:p>
-                      <a:r>
-                        <a:rPr sz="2100" b="0">
-                          <a:solidFill>
-                            <a:srgbClr val="263C49"/>
-                          </a:solidFill>
-                          <a:latin typeface="Arial"/>
-                          <a:ea typeface="Arial"/>
-                          <a:cs typeface="Arial"/>
-                        </a:rPr>
-                        <a:t>0.317</a:t>
-                      </a:r>
-                    </a:p>
-                  </a:txBody>
-                  <a:tcPr marL="91440" marR="91440" marT="45720" marB="45720">
-                    <a:lnR w="9525">
-                      <a:solidFill>
-                        <a:srgbClr val="D9E1E5"/>
-                      </a:solidFill>
-                      <a:prstDash val="solid"/>
-                    </a:lnR>
-                    <a:lnB w="9525">
-                      <a:solidFill>
-                        <a:srgbClr val="D9E1E5"/>
-                      </a:solidFill>
-                      <a:prstDash val="solid"/>
-                    </a:lnB>
-                    <a:solidFill>
-                      <a:srgbClr val="FFFFFF"/>
-                    </a:solidFill>
-                  </a:tcPr>
-                </a:tc>
-                <a:tc>
-                  <a:txBody>
-                    <a:bodyPr/>
-                    <a:lstStyle/>
-                    <a:p>
-                      <a:r>
-                        <a:rPr sz="2100" b="0">
-                          <a:solidFill>
-                            <a:srgbClr val="263C49"/>
-                          </a:solidFill>
-                          <a:latin typeface="Arial"/>
-                          <a:ea typeface="Arial"/>
-                          <a:cs typeface="Arial"/>
-                        </a:rPr>
-                        <a:t>0.210</a:t>
-                      </a:r>
-                    </a:p>
-                  </a:txBody>
-                  <a:tcPr marL="91440" marR="91440" marT="45720" marB="45720">
-                    <a:lnR w="9525">
-                      <a:solidFill>
-                        <a:srgbClr val="D9E1E5"/>
-                      </a:solidFill>
-                      <a:prstDash val="solid"/>
-                    </a:lnR>
-                    <a:lnB w="9525">
-                      <a:solidFill>
-                        <a:srgbClr val="D9E1E5"/>
-                      </a:solidFill>
-                      <a:prstDash val="solid"/>
-                    </a:lnB>
-                    <a:solidFill>
-                      <a:srgbClr val="FFFFFF"/>
-                    </a:solidFill>
-                  </a:tcPr>
-                </a:tc>
-              </a:tr>
-            </a:tbl>
-          </a:graphicData>
-        </a:graphic>
-      </p:graphicFrame>
-      <p:sp>
-        <p:nvSpPr>
-          <p:cNvPr id="4" name="">
-            <a:extLst xmlns:a="http://schemas.openxmlformats.org/drawingml/2006/main">
-              <a:ext uri="{FF2B5EF4-FFF2-40B4-BE49-F238E27FC236}">
-                <a16:creationId xmlns:a16="http://schemas.microsoft.com/office/drawing/2014/main" id="{3C9A55ED-079F-4018-AD49-B44632CED32F}"/>
+                <a16:creationId xmlns:a16="http://schemas.microsoft.com/office/drawing/2014/main" id="{5EBE02CD-E501-4A68-9340-F16C3CCFFE26}"/>
               </a:ext>
             </a:extLst>
           </p:cNvPr>
@@ -5482,8 +5163,8 @@
         </p:nvSpPr>
         <p:spPr>
           <a:xfrm xmlns:a="http://schemas.openxmlformats.org/drawingml/2006/main">
-            <a:off x="571500" y="5048250"/>
-            <a:ext cx="10572750" cy="857250"/>
+            <a:off x="571500" y="4429125"/>
+            <a:ext cx="5238750" cy="1381125"/>
           </a:xfrm>
           <a:prstGeom xmlns:a="http://schemas.openxmlformats.org/drawingml/2006/main" prst="rect">
             <a:avLst/>
@@ -5497,7 +5178,7 @@
           <a:bodyPr xmlns:a="http://schemas.openxmlformats.org/drawingml/2006/main"/>
           <a:lstStyle xmlns:a="http://schemas.openxmlformats.org/drawingml/2006/main">
             <a:defPPr>
-              <a:defRPr sz="2250" b="0">
+              <a:defRPr sz="1875" b="0">
                 <a:solidFill>
                   <a:srgbClr val="263C49"/>
                 </a:solidFill>
@@ -5510,7 +5191,7 @@
           <a:p xmlns:a="http://schemas.openxmlformats.org/drawingml/2006/main">
             <a:pPr>
               <a:buNone/>
-              <a:defRPr sz="2250" b="0">
+              <a:defRPr sz="1875" b="0">
                 <a:solidFill>
                   <a:srgbClr val="263C49"/>
                 </a:solidFill>
@@ -5520,7 +5201,7 @@
               </a:defRPr>
             </a:pPr>
             <a:r>
-              <a:rPr sz="2250" b="0">
+              <a:rPr sz="1875" b="0">
                 <a:solidFill>
                   <a:srgbClr val="263C49"/>
                 </a:solidFill>
@@ -5528,17 +5209,17 @@
                 <a:ea typeface="Arial"/>
                 <a:cs typeface="Arial"/>
               </a:rPr>
-              <a:t>Satellite and nighttime logger temperatures agreed more closely in 2019 at these sites.</a:t>
+              <a:t>Create WGS84 points from logger coordinates with XY Table To Point. Spatial Join deployments to CRW cells, then join cell keys to observations.</a:t>
             </a:r>
           </a:p>
         </p:txBody>
       </p:sp>
       <p:sp>
         <p:nvSpPr>
-          <p:cNvPr id="5" name="">
+          <p:cNvPr id="10" name="">
             <a:extLst xmlns:a="http://schemas.openxmlformats.org/drawingml/2006/main">
               <a:ext uri="{FF2B5EF4-FFF2-40B4-BE49-F238E27FC236}">
-                <a16:creationId xmlns:a16="http://schemas.microsoft.com/office/drawing/2014/main" id="{8368FEA0-3478-4DB9-BC6C-A7241A272640}"/>
+                <a16:creationId xmlns:a16="http://schemas.microsoft.com/office/drawing/2014/main" id="{E01450A2-2CED-495F-ACFB-67A9FE8C1808}"/>
               </a:ext>
             </a:extLst>
           </p:cNvPr>
@@ -5549,8 +5230,8 @@
         </p:nvSpPr>
         <p:spPr>
           <a:xfrm xmlns:a="http://schemas.openxmlformats.org/drawingml/2006/main">
-            <a:off x="571500" y="6096000"/>
-            <a:ext cx="10668000" cy="428625"/>
+            <a:off x="6477000" y="3952875"/>
+            <a:ext cx="5238750" cy="409575"/>
           </a:xfrm>
           <a:prstGeom xmlns:a="http://schemas.openxmlformats.org/drawingml/2006/main" prst="rect">
             <a:avLst/>
@@ -5564,9 +5245,9 @@
           <a:bodyPr xmlns:a="http://schemas.openxmlformats.org/drawingml/2006/main"/>
           <a:lstStyle xmlns:a="http://schemas.openxmlformats.org/drawingml/2006/main">
             <a:defPPr>
-              <a:defRPr sz="1800" b="0">
-                <a:solidFill>
-                  <a:srgbClr val="263C49"/>
+              <a:defRPr sz="2100" b="1">
+                <a:solidFill>
+                  <a:srgbClr val="167D91"/>
                 </a:solidFill>
                 <a:latin typeface="Arial"/>
                 <a:ea typeface="Arial"/>
@@ -5577,7 +5258,61 @@
           <a:p xmlns:a="http://schemas.openxmlformats.org/drawingml/2006/main">
             <a:pPr>
               <a:buNone/>
-              <a:defRPr sz="1800" b="0">
+              <a:defRPr sz="2100" b="1">
+                <a:solidFill>
+                  <a:srgbClr val="167D91"/>
+                </a:solidFill>
+                <a:latin typeface="Arial"/>
+                <a:ea typeface="Arial"/>
+                <a:cs typeface="Arial"/>
+              </a:defRPr>
+            </a:pPr>
+            <a:r>
+              <a:rPr sz="2100" b="1">
+                <a:solidFill>
+                  <a:srgbClr val="167D91"/>
+                </a:solidFill>
+                <a:latin typeface="Arial"/>
+                <a:ea typeface="Arial"/>
+                <a:cs typeface="Arial"/>
+              </a:rPr>
+              <a:t>Time matching and statistics</a:t>
+            </a:r>
+          </a:p>
+        </p:txBody>
+      </p:sp>
+      <p:sp>
+        <p:nvSpPr>
+          <p:cNvPr id="11" name="">
+            <a:extLst xmlns:a="http://schemas.openxmlformats.org/drawingml/2006/main">
+              <a:ext uri="{FF2B5EF4-FFF2-40B4-BE49-F238E27FC236}">
+                <a16:creationId xmlns:a16="http://schemas.microsoft.com/office/drawing/2014/main" id="{12E88A3A-A0CF-4490-AB94-97A79C85E382}"/>
+              </a:ext>
+            </a:extLst>
+          </p:cNvPr>
+          <p:cNvSpPr>
+            <a:spLocks xmlns:a="http://schemas.openxmlformats.org/drawingml/2006/main" noGrp="1"/>
+          </p:cNvSpPr>
+          <p:nvPr/>
+        </p:nvSpPr>
+        <p:spPr>
+          <a:xfrm xmlns:a="http://schemas.openxmlformats.org/drawingml/2006/main">
+            <a:off x="6477000" y="4429125"/>
+            <a:ext cx="5238750" cy="1381125"/>
+          </a:xfrm>
+          <a:prstGeom xmlns:a="http://schemas.openxmlformats.org/drawingml/2006/main" prst="rect">
+            <a:avLst/>
+          </a:prstGeom>
+          <a:noFill xmlns:a="http://schemas.openxmlformats.org/drawingml/2006/main"/>
+          <a:ln xmlns:a="http://schemas.openxmlformats.org/drawingml/2006/main" w="0">
+            <a:noFill/>
+          </a:ln>
+        </p:spPr>
+        <p:txBody>
+          <a:bodyPr xmlns:a="http://schemas.openxmlformats.org/drawingml/2006/main"/>
+          <a:lstStyle xmlns:a="http://schemas.openxmlformats.org/drawingml/2006/main">
+            <a:defPPr>
+              <a:defRPr sz="1875" b="0">
                 <a:solidFill>
                   <a:srgbClr val="263C49"/>
                 </a:solidFill>
@@ -5585,9 +5320,22 @@
                 <a:ea typeface="Arial"/>
                 <a:cs typeface="Arial"/>
               </a:defRPr>
+            </a:defPPr>
+          </a:lstStyle>
+          <a:p xmlns:a="http://schemas.openxmlformats.org/drawingml/2006/main">
+            <a:pPr>
+              <a:buNone/>
+              <a:defRPr sz="1875" b="0">
+                <a:solidFill>
+                  <a:srgbClr val="263C49"/>
+                </a:solidFill>
+                <a:latin typeface="Arial"/>
+                <a:ea typeface="Arial"/>
+                <a:cs typeface="Arial"/>
+              </a:defRPr>
             </a:pPr>
             <a:r>
-              <a:rPr sz="1800" b="0">
+              <a:rPr sz="1875" b="0">
                 <a:solidFill>
                   <a:srgbClr val="263C49"/>
                 </a:solidFill>
@@ -5595,7 +5343,74 @@
                 <a:ea typeface="Arial"/>
                 <a:cs typeface="Arial"/>
               </a:rPr>
-              <a:t>Each comparison uses 122 complete nights per site and year.</a:t>
+              <a:t>Average complete 00:00–06:00 HST nights. Join satellite SST by cell and date. Summarize bias and RMSD by site, depth, year, and season.</a:t>
+            </a:r>
+          </a:p>
+        </p:txBody>
+      </p:sp>
+      <p:sp>
+        <p:nvSpPr>
+          <p:cNvPr id="12" name="">
+            <a:extLst xmlns:a="http://schemas.openxmlformats.org/drawingml/2006/main">
+              <a:ext uri="{FF2B5EF4-FFF2-40B4-BE49-F238E27FC236}">
+                <a16:creationId xmlns:a16="http://schemas.microsoft.com/office/drawing/2014/main" id="{BBF0C562-1093-45F0-8E1D-7FFFF4183371}"/>
+              </a:ext>
+            </a:extLst>
+          </p:cNvPr>
+          <p:cNvSpPr>
+            <a:spLocks xmlns:a="http://schemas.openxmlformats.org/drawingml/2006/main" noGrp="1"/>
+          </p:cNvSpPr>
+          <p:nvPr/>
+        </p:nvSpPr>
+        <p:spPr>
+          <a:xfrm xmlns:a="http://schemas.openxmlformats.org/drawingml/2006/main">
+            <a:off x="571500" y="6038850"/>
+            <a:ext cx="11049000" cy="590550"/>
+          </a:xfrm>
+          <a:prstGeom xmlns:a="http://schemas.openxmlformats.org/drawingml/2006/main" prst="rect">
+            <a:avLst/>
+          </a:prstGeom>
+          <a:noFill xmlns:a="http://schemas.openxmlformats.org/drawingml/2006/main"/>
+          <a:ln xmlns:a="http://schemas.openxmlformats.org/drawingml/2006/main" w="0">
+            <a:noFill/>
+          </a:ln>
+        </p:spPr>
+        <p:txBody>
+          <a:bodyPr xmlns:a="http://schemas.openxmlformats.org/drawingml/2006/main"/>
+          <a:lstStyle xmlns:a="http://schemas.openxmlformats.org/drawingml/2006/main">
+            <a:defPPr>
+              <a:defRPr sz="2100" b="0">
+                <a:solidFill>
+                  <a:srgbClr val="167D91"/>
+                </a:solidFill>
+                <a:latin typeface="Arial"/>
+                <a:ea typeface="Arial"/>
+                <a:cs typeface="Arial"/>
+              </a:defRPr>
+            </a:defPPr>
+          </a:lstStyle>
+          <a:p xmlns:a="http://schemas.openxmlformats.org/drawingml/2006/main">
+            <a:pPr>
+              <a:buNone/>
+              <a:defRPr sz="2100" b="0">
+                <a:solidFill>
+                  <a:srgbClr val="167D91"/>
+                </a:solidFill>
+                <a:latin typeface="Arial"/>
+                <a:ea typeface="Arial"/>
+                <a:cs typeface="Arial"/>
+              </a:defRPr>
+            </a:pPr>
+            <a:r>
+              <a:rPr sz="2100" b="0">
+                <a:solidFill>
+                  <a:srgbClr val="167D91"/>
+                </a:solidFill>
+                <a:latin typeface="Arial"/>
+                <a:ea typeface="Arial"/>
+                <a:cs typeface="Arial"/>
+              </a:rPr>
+              <a:t>RMSD is lower in 2019 at all three sites. Each site/year uses 122 complete nights.</a:t>
             </a:r>
           </a:p>
         </p:txBody>
@@ -5701,7 +5516,7 @@
           <p:cNvPr id="2" name="Chart">
             <a:extLst xmlns:a="http://schemas.openxmlformats.org/drawingml/2006/main">
               <a:ext uri="{FF2B5EF4-FFF2-40B4-BE49-F238E27FC236}">
-                <a16:creationId xmlns:a16="http://schemas.microsoft.com/office/drawing/2014/main" id="{D8DF71EE-46D0-42E2-804F-F1DA68852718}"/>
+                <a16:creationId xmlns:a16="http://schemas.microsoft.com/office/drawing/2014/main" id="{CE0E6774-18E4-451C-863A-DAD1FDE5920C}"/>
               </a:ext>
             </a:extLst>
           </p:cNvPr>
@@ -5714,16 +5529,16 @@
         </p:xfrm>
         <a:graphic xmlns:a="http://schemas.openxmlformats.org/drawingml/2006/main">
           <a:graphicData uri="http://schemas.openxmlformats.org/drawingml/2006/chart">
-            <c:chart xmlns:r="http://schemas.openxmlformats.org/officeDocument/2006/relationships" xmlns:c="http://schemas.openxmlformats.org/drawingml/2006/chart" r:id="R8bcd10a1b566463b"/>
+            <c:chart xmlns:r="http://schemas.openxmlformats.org/officeDocument/2006/relationships" xmlns:c="http://schemas.openxmlformats.org/drawingml/2006/chart" r:id="R3454e4de8c24448e"/>
           </a:graphicData>
         </a:graphic>
       </p:graphicFrame>
       <p:sp>
         <p:nvSpPr>
-          <p:cNvPr id="3" name="">
+          <p:cNvPr id="8" name="">
             <a:extLst xmlns:a="http://schemas.openxmlformats.org/drawingml/2006/main">
               <a:ext uri="{FF2B5EF4-FFF2-40B4-BE49-F238E27FC236}">
-                <a16:creationId xmlns:a16="http://schemas.microsoft.com/office/drawing/2014/main" id="{859E2CE2-82E2-4F94-A53A-CB242A836069}"/>
+                <a16:creationId xmlns:a16="http://schemas.microsoft.com/office/drawing/2014/main" id="{BC6F01F1-C75D-4C4D-89FC-F358243B053B}"/>
               </a:ext>
             </a:extLst>
           </p:cNvPr>
@@ -5735,7 +5550,7 @@
         <p:spPr>
           <a:xfrm xmlns:a="http://schemas.openxmlformats.org/drawingml/2006/main">
             <a:off x="666750" y="6096000"/>
-            <a:ext cx="6858000" cy="400050"/>
+            <a:ext cx="6858000" cy="428625"/>
           </a:xfrm>
           <a:prstGeom xmlns:a="http://schemas.openxmlformats.org/drawingml/2006/main" prst="rect">
             <a:avLst/>
@@ -5749,7 +5564,7 @@
           <a:bodyPr xmlns:a="http://schemas.openxmlformats.org/drawingml/2006/main"/>
           <a:lstStyle xmlns:a="http://schemas.openxmlformats.org/drawingml/2006/main">
             <a:defPPr>
-              <a:defRPr sz="1800" b="0">
+              <a:defRPr sz="1875" b="0">
                 <a:solidFill>
                   <a:srgbClr val="263C49"/>
                 </a:solidFill>
@@ -5762,7 +5577,7 @@
           <a:p xmlns:a="http://schemas.openxmlformats.org/drawingml/2006/main">
             <a:pPr>
               <a:buNone/>
-              <a:defRPr sz="1800" b="0">
+              <a:defRPr sz="1875" b="0">
                 <a:solidFill>
                   <a:srgbClr val="263C49"/>
                 </a:solidFill>
@@ -5772,7 +5587,7 @@
               </a:defRPr>
             </a:pPr>
             <a:r>
-              <a:rPr sz="1800" b="0">
+              <a:rPr sz="1875" b="0">
                 <a:solidFill>
                   <a:srgbClr val="263C49"/>
                 </a:solidFill>
@@ -5780,17 +5595,17 @@
                 <a:ea typeface="Arial"/>
                 <a:cs typeface="Arial"/>
               </a:rPr>
-              <a:t>Seven-day SST forecast MAE (°C)</a:t>
+              <a:t>Held-out test MAE (°C), 2015–2025</a:t>
             </a:r>
           </a:p>
         </p:txBody>
       </p:sp>
       <p:sp>
         <p:nvSpPr>
-          <p:cNvPr id="4" name="">
+          <p:cNvPr id="9" name="">
             <a:extLst xmlns:a="http://schemas.openxmlformats.org/drawingml/2006/main">
               <a:ext uri="{FF2B5EF4-FFF2-40B4-BE49-F238E27FC236}">
-                <a16:creationId xmlns:a16="http://schemas.microsoft.com/office/drawing/2014/main" id="{7057B7CF-6415-4110-B9A3-2850828E66FF}"/>
+                <a16:creationId xmlns:a16="http://schemas.microsoft.com/office/drawing/2014/main" id="{434F5791-7AB8-4192-8F57-624013314E25}"/>
               </a:ext>
             </a:extLst>
           </p:cNvPr>
@@ -5801,8 +5616,8 @@
         </p:nvSpPr>
         <p:spPr>
           <a:xfrm xmlns:a="http://schemas.openxmlformats.org/drawingml/2006/main">
-            <a:off x="8048625" y="1809750"/>
-            <a:ext cx="3476625" cy="476250"/>
+            <a:off x="7953375" y="1476375"/>
+            <a:ext cx="3714750" cy="409575"/>
           </a:xfrm>
           <a:prstGeom xmlns:a="http://schemas.openxmlformats.org/drawingml/2006/main" prst="rect">
             <a:avLst/>
@@ -5816,7 +5631,7 @@
           <a:bodyPr xmlns:a="http://schemas.openxmlformats.org/drawingml/2006/main"/>
           <a:lstStyle xmlns:a="http://schemas.openxmlformats.org/drawingml/2006/main">
             <a:defPPr>
-              <a:defRPr sz="2325" b="1">
+              <a:defRPr sz="2175" b="1">
                 <a:solidFill>
                   <a:srgbClr val="167D91"/>
                 </a:solidFill>
@@ -5829,7 +5644,7 @@
           <a:p xmlns:a="http://schemas.openxmlformats.org/drawingml/2006/main">
             <a:pPr>
               <a:buNone/>
-              <a:defRPr sz="2325" b="1">
+              <a:defRPr sz="2175" b="1">
                 <a:solidFill>
                   <a:srgbClr val="167D91"/>
                 </a:solidFill>
@@ -5839,7 +5654,7 @@
               </a:defRPr>
             </a:pPr>
             <a:r>
-              <a:rPr sz="2325" b="1">
+              <a:rPr sz="2175" b="1">
                 <a:solidFill>
                   <a:srgbClr val="167D91"/>
                 </a:solidFill>
@@ -5847,17 +5662,17 @@
                 <a:ea typeface="Arial"/>
                 <a:cs typeface="Arial"/>
               </a:rPr>
-              <a:t>Held-out test</a:t>
+              <a:t>Train: 2003–2013</a:t>
             </a:r>
           </a:p>
         </p:txBody>
       </p:sp>
       <p:sp>
         <p:nvSpPr>
-          <p:cNvPr id="5" name="">
+          <p:cNvPr id="10" name="">
             <a:extLst xmlns:a="http://schemas.openxmlformats.org/drawingml/2006/main">
               <a:ext uri="{FF2B5EF4-FFF2-40B4-BE49-F238E27FC236}">
-                <a16:creationId xmlns:a16="http://schemas.microsoft.com/office/drawing/2014/main" id="{CF24B670-CB0C-49F1-999B-3BCBF143CFE7}"/>
+                <a16:creationId xmlns:a16="http://schemas.microsoft.com/office/drawing/2014/main" id="{7D90A416-D895-4844-8E4B-423A4E739552}"/>
               </a:ext>
             </a:extLst>
           </p:cNvPr>
@@ -5868,8 +5683,8 @@
         </p:nvSpPr>
         <p:spPr>
           <a:xfrm xmlns:a="http://schemas.openxmlformats.org/drawingml/2006/main">
-            <a:off x="8048625" y="2476500"/>
-            <a:ext cx="3476625" cy="1333500"/>
+            <a:off x="7953375" y="1952625"/>
+            <a:ext cx="3714750" cy="1000125"/>
           </a:xfrm>
           <a:prstGeom xmlns:a="http://schemas.openxmlformats.org/drawingml/2006/main" prst="rect">
             <a:avLst/>
@@ -5883,7 +5698,7 @@
           <a:bodyPr xmlns:a="http://schemas.openxmlformats.org/drawingml/2006/main"/>
           <a:lstStyle xmlns:a="http://schemas.openxmlformats.org/drawingml/2006/main">
             <a:defPPr>
-              <a:defRPr sz="2250" b="0">
+              <a:defRPr sz="1950" b="0">
                 <a:solidFill>
                   <a:srgbClr val="263C49"/>
                 </a:solidFill>
@@ -5896,7 +5711,7 @@
           <a:p xmlns:a="http://schemas.openxmlformats.org/drawingml/2006/main">
             <a:pPr>
               <a:buNone/>
-              <a:defRPr sz="2250" b="0">
+              <a:defRPr sz="1950" b="0">
                 <a:solidFill>
                   <a:srgbClr val="263C49"/>
                 </a:solidFill>
@@ -5906,7 +5721,7 @@
               </a:defRPr>
             </a:pPr>
             <a:r>
-              <a:rPr sz="2250" b="0">
+              <a:rPr sz="1950" b="0">
                 <a:solidFill>
                   <a:srgbClr val="263C49"/>
                 </a:solidFill>
@@ -5914,65 +5729,17 @@
                 <a:ea typeface="Arial"/>
                 <a:cs typeface="Arial"/>
               </a:rPr>
-              <a:t>2015–2025</a:t>
-            </a:r>
-          </a:p>
-          <a:p xmlns:a="http://schemas.openxmlformats.org/drawingml/2006/main">
-            <a:pPr>
-              <a:buNone/>
-              <a:defRPr sz="2250" b="0">
-                <a:solidFill>
-                  <a:srgbClr val="263C49"/>
-                </a:solidFill>
-                <a:latin typeface="Arial"/>
-                <a:ea typeface="Arial"/>
-                <a:cs typeface="Arial"/>
-              </a:defRPr>
-            </a:pPr>
-            <a:r>
-              <a:rPr sz="2250" b="0">
-                <a:solidFill>
-                  <a:srgbClr val="263C49"/>
-                </a:solidFill>
-                <a:latin typeface="Arial"/>
-                <a:ea typeface="Arial"/>
-                <a:cs typeface="Arial"/>
-              </a:rPr>
-              <a:t>11,754 forecasts</a:t>
-            </a:r>
-          </a:p>
-          <a:p xmlns:a="http://schemas.openxmlformats.org/drawingml/2006/main">
-            <a:pPr>
-              <a:buNone/>
-              <a:defRPr sz="2250" b="0">
-                <a:solidFill>
-                  <a:srgbClr val="263C49"/>
-                </a:solidFill>
-                <a:latin typeface="Arial"/>
-                <a:ea typeface="Arial"/>
-                <a:cs typeface="Arial"/>
-              </a:defRPr>
-            </a:pPr>
-            <a:r>
-              <a:rPr sz="2250" b="0">
-                <a:solidFill>
-                  <a:srgbClr val="263C49"/>
-                </a:solidFill>
-                <a:latin typeface="Arial"/>
-                <a:ea typeface="Arial"/>
-                <a:cs typeface="Arial"/>
-              </a:rPr>
-              <a:t>3 selected cells</a:t>
+              <a:t>11,949 examples. Fit RF candidates using past SST, season, and cell.</a:t>
             </a:r>
           </a:p>
         </p:txBody>
       </p:sp>
       <p:sp>
         <p:nvSpPr>
-          <p:cNvPr id="6" name="">
+          <p:cNvPr id="11" name="">
             <a:extLst xmlns:a="http://schemas.openxmlformats.org/drawingml/2006/main">
               <a:ext uri="{FF2B5EF4-FFF2-40B4-BE49-F238E27FC236}">
-                <a16:creationId xmlns:a16="http://schemas.microsoft.com/office/drawing/2014/main" id="{0D760CD9-D380-4482-ABB5-1D97DD1CF991}"/>
+                <a16:creationId xmlns:a16="http://schemas.microsoft.com/office/drawing/2014/main" id="{88ABCAC7-9DAD-4B93-8FE3-1AB54B9E86C9}"/>
               </a:ext>
             </a:extLst>
           </p:cNvPr>
@@ -5983,8 +5750,8 @@
         </p:nvSpPr>
         <p:spPr>
           <a:xfrm xmlns:a="http://schemas.openxmlformats.org/drawingml/2006/main">
-            <a:off x="8048625" y="4238625"/>
-            <a:ext cx="3476625" cy="1619250"/>
+            <a:off x="7953375" y="3143250"/>
+            <a:ext cx="3714750" cy="409575"/>
           </a:xfrm>
           <a:prstGeom xmlns:a="http://schemas.openxmlformats.org/drawingml/2006/main" prst="rect">
             <a:avLst/>
@@ -5998,9 +5765,9 @@
           <a:bodyPr xmlns:a="http://schemas.openxmlformats.org/drawingml/2006/main"/>
           <a:lstStyle xmlns:a="http://schemas.openxmlformats.org/drawingml/2006/main">
             <a:defPPr>
-              <a:defRPr sz="2100" b="0">
-                <a:solidFill>
-                  <a:srgbClr val="263C49"/>
+              <a:defRPr sz="2175" b="1">
+                <a:solidFill>
+                  <a:srgbClr val="167D91"/>
                 </a:solidFill>
                 <a:latin typeface="Arial"/>
                 <a:ea typeface="Arial"/>
@@ -6011,7 +5778,61 @@
           <a:p xmlns:a="http://schemas.openxmlformats.org/drawingml/2006/main">
             <a:pPr>
               <a:buNone/>
-              <a:defRPr sz="2100" b="0">
+              <a:defRPr sz="2175" b="1">
+                <a:solidFill>
+                  <a:srgbClr val="167D91"/>
+                </a:solidFill>
+                <a:latin typeface="Arial"/>
+                <a:ea typeface="Arial"/>
+                <a:cs typeface="Arial"/>
+              </a:defRPr>
+            </a:pPr>
+            <a:r>
+              <a:rPr sz="2175" b="1">
+                <a:solidFill>
+                  <a:srgbClr val="167D91"/>
+                </a:solidFill>
+                <a:latin typeface="Arial"/>
+                <a:ea typeface="Arial"/>
+                <a:cs typeface="Arial"/>
+              </a:rPr>
+              <a:t>Validate: 2014</a:t>
+            </a:r>
+          </a:p>
+        </p:txBody>
+      </p:sp>
+      <p:sp>
+        <p:nvSpPr>
+          <p:cNvPr id="12" name="">
+            <a:extLst xmlns:a="http://schemas.openxmlformats.org/drawingml/2006/main">
+              <a:ext uri="{FF2B5EF4-FFF2-40B4-BE49-F238E27FC236}">
+                <a16:creationId xmlns:a16="http://schemas.microsoft.com/office/drawing/2014/main" id="{A04BDDA0-6EE0-47DA-9532-3BCACF5B27DE}"/>
+              </a:ext>
+            </a:extLst>
+          </p:cNvPr>
+          <p:cNvSpPr>
+            <a:spLocks xmlns:a="http://schemas.openxmlformats.org/drawingml/2006/main" noGrp="1"/>
+          </p:cNvSpPr>
+          <p:nvPr/>
+        </p:nvSpPr>
+        <p:spPr>
+          <a:xfrm xmlns:a="http://schemas.openxmlformats.org/drawingml/2006/main">
+            <a:off x="7953375" y="3619500"/>
+            <a:ext cx="3714750" cy="1238250"/>
+          </a:xfrm>
+          <a:prstGeom xmlns:a="http://schemas.openxmlformats.org/drawingml/2006/main" prst="rect">
+            <a:avLst/>
+          </a:prstGeom>
+          <a:noFill xmlns:a="http://schemas.openxmlformats.org/drawingml/2006/main"/>
+          <a:ln xmlns:a="http://schemas.openxmlformats.org/drawingml/2006/main" w="0">
+            <a:noFill/>
+          </a:ln>
+        </p:spPr>
+        <p:txBody>
+          <a:bodyPr xmlns:a="http://schemas.openxmlformats.org/drawingml/2006/main"/>
+          <a:lstStyle xmlns:a="http://schemas.openxmlformats.org/drawingml/2006/main">
+            <a:defPPr>
+              <a:defRPr sz="1950" b="0">
                 <a:solidFill>
                   <a:srgbClr val="263C49"/>
                 </a:solidFill>
@@ -6019,9 +5840,22 @@
                 <a:ea typeface="Arial"/>
                 <a:cs typeface="Arial"/>
               </a:defRPr>
+            </a:defPPr>
+          </a:lstStyle>
+          <a:p xmlns:a="http://schemas.openxmlformats.org/drawingml/2006/main">
+            <a:pPr>
+              <a:buNone/>
+              <a:defRPr sz="1950" b="0">
+                <a:solidFill>
+                  <a:srgbClr val="263C49"/>
+                </a:solidFill>
+                <a:latin typeface="Arial"/>
+                <a:ea typeface="Arial"/>
+                <a:cs typeface="Arial"/>
+              </a:defRPr>
             </a:pPr>
             <a:r>
-              <a:rPr sz="2100" b="0">
+              <a:rPr sz="1950" b="0">
                 <a:solidFill>
                   <a:srgbClr val="263C49"/>
                 </a:solidFill>
@@ -6029,7 +5863,141 @@
                 <a:ea typeface="Arial"/>
                 <a:cs typeface="Arial"/>
               </a:rPr>
-              <a:t>RF skill varied by cell and year. Strong heat-stress years exposed larger forecast errors.</a:t>
+              <a:t>1,074 forecasts. Select depth 16 and leaf size 20. RF MAE: 0.2116°C vs. persistence: 0.2202°C.</a:t>
+            </a:r>
+          </a:p>
+        </p:txBody>
+      </p:sp>
+      <p:sp>
+        <p:nvSpPr>
+          <p:cNvPr id="13" name="">
+            <a:extLst xmlns:a="http://schemas.openxmlformats.org/drawingml/2006/main">
+              <a:ext uri="{FF2B5EF4-FFF2-40B4-BE49-F238E27FC236}">
+                <a16:creationId xmlns:a16="http://schemas.microsoft.com/office/drawing/2014/main" id="{17AA3A65-9695-4BEA-A959-6AF53414106A}"/>
+              </a:ext>
+            </a:extLst>
+          </p:cNvPr>
+          <p:cNvSpPr>
+            <a:spLocks xmlns:a="http://schemas.openxmlformats.org/drawingml/2006/main" noGrp="1"/>
+          </p:cNvSpPr>
+          <p:nvPr/>
+        </p:nvSpPr>
+        <p:spPr>
+          <a:xfrm xmlns:a="http://schemas.openxmlformats.org/drawingml/2006/main">
+            <a:off x="7953375" y="5095875"/>
+            <a:ext cx="3714750" cy="409575"/>
+          </a:xfrm>
+          <a:prstGeom xmlns:a="http://schemas.openxmlformats.org/drawingml/2006/main" prst="rect">
+            <a:avLst/>
+          </a:prstGeom>
+          <a:noFill xmlns:a="http://schemas.openxmlformats.org/drawingml/2006/main"/>
+          <a:ln xmlns:a="http://schemas.openxmlformats.org/drawingml/2006/main" w="0">
+            <a:noFill/>
+          </a:ln>
+        </p:spPr>
+        <p:txBody>
+          <a:bodyPr xmlns:a="http://schemas.openxmlformats.org/drawingml/2006/main"/>
+          <a:lstStyle xmlns:a="http://schemas.openxmlformats.org/drawingml/2006/main">
+            <a:defPPr>
+              <a:defRPr sz="2025" b="1">
+                <a:solidFill>
+                  <a:srgbClr val="167D91"/>
+                </a:solidFill>
+                <a:latin typeface="Arial"/>
+                <a:ea typeface="Arial"/>
+                <a:cs typeface="Arial"/>
+              </a:defRPr>
+            </a:defPPr>
+          </a:lstStyle>
+          <a:p xmlns:a="http://schemas.openxmlformats.org/drawingml/2006/main">
+            <a:pPr>
+              <a:buNone/>
+              <a:defRPr sz="2025" b="1">
+                <a:solidFill>
+                  <a:srgbClr val="167D91"/>
+                </a:solidFill>
+                <a:latin typeface="Arial"/>
+                <a:ea typeface="Arial"/>
+                <a:cs typeface="Arial"/>
+              </a:defRPr>
+            </a:pPr>
+            <a:r>
+              <a:rPr sz="2025" b="1">
+                <a:solidFill>
+                  <a:srgbClr val="167D91"/>
+                </a:solidFill>
+                <a:latin typeface="Arial"/>
+                <a:ea typeface="Arial"/>
+                <a:cs typeface="Arial"/>
+              </a:rPr>
+              <a:t>Refit, then test: 2015–2025</a:t>
+            </a:r>
+          </a:p>
+        </p:txBody>
+      </p:sp>
+      <p:sp>
+        <p:nvSpPr>
+          <p:cNvPr id="14" name="">
+            <a:extLst xmlns:a="http://schemas.openxmlformats.org/drawingml/2006/main">
+              <a:ext uri="{FF2B5EF4-FFF2-40B4-BE49-F238E27FC236}">
+                <a16:creationId xmlns:a16="http://schemas.microsoft.com/office/drawing/2014/main" id="{9EA15038-42BA-4B49-BF20-905196AE2F7D}"/>
+              </a:ext>
+            </a:extLst>
+          </p:cNvPr>
+          <p:cNvSpPr>
+            <a:spLocks xmlns:a="http://schemas.openxmlformats.org/drawingml/2006/main" noGrp="1"/>
+          </p:cNvSpPr>
+          <p:nvPr/>
+        </p:nvSpPr>
+        <p:spPr>
+          <a:xfrm xmlns:a="http://schemas.openxmlformats.org/drawingml/2006/main">
+            <a:off x="7953375" y="5572125"/>
+            <a:ext cx="3714750" cy="904875"/>
+          </a:xfrm>
+          <a:prstGeom xmlns:a="http://schemas.openxmlformats.org/drawingml/2006/main" prst="rect">
+            <a:avLst/>
+          </a:prstGeom>
+          <a:noFill xmlns:a="http://schemas.openxmlformats.org/drawingml/2006/main"/>
+          <a:ln xmlns:a="http://schemas.openxmlformats.org/drawingml/2006/main" w="0">
+            <a:noFill/>
+          </a:ln>
+        </p:spPr>
+        <p:txBody>
+          <a:bodyPr xmlns:a="http://schemas.openxmlformats.org/drawingml/2006/main"/>
+          <a:lstStyle xmlns:a="http://schemas.openxmlformats.org/drawingml/2006/main">
+            <a:defPPr>
+              <a:defRPr sz="1950" b="0">
+                <a:solidFill>
+                  <a:srgbClr val="263C49"/>
+                </a:solidFill>
+                <a:latin typeface="Arial"/>
+                <a:ea typeface="Arial"/>
+                <a:cs typeface="Arial"/>
+              </a:defRPr>
+            </a:defPPr>
+          </a:lstStyle>
+          <a:p xmlns:a="http://schemas.openxmlformats.org/drawingml/2006/main">
+            <a:pPr>
+              <a:buNone/>
+              <a:defRPr sz="1950" b="0">
+                <a:solidFill>
+                  <a:srgbClr val="263C49"/>
+                </a:solidFill>
+                <a:latin typeface="Arial"/>
+                <a:ea typeface="Arial"/>
+                <a:cs typeface="Arial"/>
+              </a:defRPr>
+            </a:pPr>
+            <a:r>
+              <a:rPr sz="1950" b="0">
+                <a:solidFill>
+                  <a:srgbClr val="263C49"/>
+                </a:solidFill>
+                <a:latin typeface="Arial"/>
+                <a:ea typeface="Arial"/>
+                <a:cs typeface="Arial"/>
+              </a:rPr>
+              <a:t>Refit through 2014. Test 11,754 forecasts across three cells.</a:t>
             </a:r>
           </a:p>
         </p:txBody>
@@ -6125,17 +6093,45 @@
                 <a:ea typeface="Arial"/>
                 <a:cs typeface="Arial"/>
               </a:rPr>
-              <a:t>What the results support</a:t>
+              <a:t>Heat anomalies expose larger RF errors</a:t>
             </a:r>
           </a:p>
         </p:txBody>
       </p:sp>
-      <p:sp>
-        <p:nvSpPr>
-          <p:cNvPr id="2" name="">
+      <p:pic>
+        <p:nvPicPr>
+          <p:cNvPr id="8" name="">
             <a:extLst xmlns:a="http://schemas.openxmlformats.org/drawingml/2006/main">
               <a:ext uri="{FF2B5EF4-FFF2-40B4-BE49-F238E27FC236}">
-                <a16:creationId xmlns:a16="http://schemas.microsoft.com/office/drawing/2014/main" id="{BE5676ED-8826-4AFB-B7B3-0E89A667C266}"/>
+                <a16:creationId xmlns:a16="http://schemas.microsoft.com/office/drawing/2014/main" id="{C329F119-0873-4465-8EA2-9CD270E15C44}"/>
+              </a:ext>
+            </a:extLst>
+          </p:cNvPr>
+          <p:cNvPicPr>
+            <a:picLocks xmlns:a="http://schemas.openxmlformats.org/drawingml/2006/main" noChangeAspect="1"/>
+          </p:cNvPicPr>
+          <p:nvPr/>
+        </p:nvPicPr>
+        <p:blipFill>
+          <a:blip xmlns:r="http://schemas.openxmlformats.org/officeDocument/2006/relationships" xmlns:a="http://schemas.openxmlformats.org/drawingml/2006/main" r:embed="R77e69ffc12064408"/>
+          <a:stretch xmlns:a="http://schemas.openxmlformats.org/drawingml/2006/main"/>
+        </p:blipFill>
+        <p:spPr>
+          <a:xfrm xmlns:a="http://schemas.openxmlformats.org/drawingml/2006/main">
+            <a:off x="491658" y="1257300"/>
+            <a:ext cx="6779559" cy="5238750"/>
+          </a:xfrm>
+          <a:prstGeom xmlns:a="http://schemas.openxmlformats.org/drawingml/2006/main" prst="rect">
+            <a:avLst/>
+          </a:prstGeom>
+        </p:spPr>
+      </p:pic>
+      <p:sp>
+        <p:nvSpPr>
+          <p:cNvPr id="9" name="">
+            <a:extLst xmlns:a="http://schemas.openxmlformats.org/drawingml/2006/main">
+              <a:ext uri="{FF2B5EF4-FFF2-40B4-BE49-F238E27FC236}">
+                <a16:creationId xmlns:a16="http://schemas.microsoft.com/office/drawing/2014/main" id="{EF81A942-C31C-4689-BCEF-F4933F08A382}"/>
               </a:ext>
             </a:extLst>
           </p:cNvPr>
@@ -6146,8 +6142,8 @@
         </p:nvSpPr>
         <p:spPr>
           <a:xfrm xmlns:a="http://schemas.openxmlformats.org/drawingml/2006/main">
-            <a:off x="571500" y="1524000"/>
-            <a:ext cx="6286500" cy="1000125"/>
+            <a:off x="7905750" y="1524000"/>
+            <a:ext cx="3810000" cy="409575"/>
           </a:xfrm>
           <a:prstGeom xmlns:a="http://schemas.openxmlformats.org/drawingml/2006/main" prst="rect">
             <a:avLst/>
@@ -6161,9 +6157,9 @@
           <a:bodyPr xmlns:a="http://schemas.openxmlformats.org/drawingml/2006/main"/>
           <a:lstStyle xmlns:a="http://schemas.openxmlformats.org/drawingml/2006/main">
             <a:defPPr>
-              <a:defRPr sz="2250" b="0">
-                <a:solidFill>
-                  <a:srgbClr val="263C49"/>
+              <a:defRPr sz="2100" b="1">
+                <a:solidFill>
+                  <a:srgbClr val="167D91"/>
                 </a:solidFill>
                 <a:latin typeface="Arial"/>
                 <a:ea typeface="Arial"/>
@@ -6174,9 +6170,9 @@
           <a:p xmlns:a="http://schemas.openxmlformats.org/drawingml/2006/main">
             <a:pPr>
               <a:buNone/>
-              <a:defRPr sz="2250" b="0">
-                <a:solidFill>
-                  <a:srgbClr val="263C49"/>
+              <a:defRPr sz="2100" b="1">
+                <a:solidFill>
+                  <a:srgbClr val="167D91"/>
                 </a:solidFill>
                 <a:latin typeface="Arial"/>
                 <a:ea typeface="Arial"/>
@@ -6184,25 +6180,25 @@
               </a:defRPr>
             </a:pPr>
             <a:r>
-              <a:rPr sz="2250" b="0">
-                <a:solidFill>
-                  <a:srgbClr val="263C49"/>
+              <a:rPr sz="2100" b="1">
+                <a:solidFill>
+                  <a:srgbClr val="167D91"/>
                 </a:solidFill>
                 <a:latin typeface="Arial"/>
                 <a:ea typeface="Arial"/>
                 <a:cs typeface="Arial"/>
               </a:rPr>
-              <a:t>Heat duration matters alongside temperature. The 2015–2019 contrast depends on the metric.</a:t>
+              <a:t>Lower stress: DHW &lt;4</a:t>
             </a:r>
           </a:p>
         </p:txBody>
       </p:sp>
       <p:sp>
         <p:nvSpPr>
-          <p:cNvPr id="3" name="">
+          <p:cNvPr id="10" name="">
             <a:extLst xmlns:a="http://schemas.openxmlformats.org/drawingml/2006/main">
               <a:ext uri="{FF2B5EF4-FFF2-40B4-BE49-F238E27FC236}">
-                <a16:creationId xmlns:a16="http://schemas.microsoft.com/office/drawing/2014/main" id="{41320579-E9E0-4A7A-8E63-F59E62DE1E40}"/>
+                <a16:creationId xmlns:a16="http://schemas.microsoft.com/office/drawing/2014/main" id="{44A812F3-B432-4175-9E1D-37FB342609AA}"/>
               </a:ext>
             </a:extLst>
           </p:cNvPr>
@@ -6213,8 +6209,8 @@
         </p:nvSpPr>
         <p:spPr>
           <a:xfrm xmlns:a="http://schemas.openxmlformats.org/drawingml/2006/main">
-            <a:off x="571500" y="2857500"/>
-            <a:ext cx="6286500" cy="1000125"/>
+            <a:off x="7905750" y="2019300"/>
+            <a:ext cx="3810000" cy="1381125"/>
           </a:xfrm>
           <a:prstGeom xmlns:a="http://schemas.openxmlformats.org/drawingml/2006/main" prst="rect">
             <a:avLst/>
@@ -6228,7 +6224,7 @@
           <a:bodyPr xmlns:a="http://schemas.openxmlformats.org/drawingml/2006/main"/>
           <a:lstStyle xmlns:a="http://schemas.openxmlformats.org/drawingml/2006/main">
             <a:defPPr>
-              <a:defRPr sz="2250" b="0">
+              <a:defRPr sz="1950" b="0">
                 <a:solidFill>
                   <a:srgbClr val="263C49"/>
                 </a:solidFill>
@@ -6241,7 +6237,7 @@
           <a:p xmlns:a="http://schemas.openxmlformats.org/drawingml/2006/main">
             <a:pPr>
               <a:buNone/>
-              <a:defRPr sz="2250" b="0">
+              <a:defRPr sz="1950" b="0">
                 <a:solidFill>
                   <a:srgbClr val="263C49"/>
                 </a:solidFill>
@@ -6251,7 +6247,7 @@
               </a:defRPr>
             </a:pPr>
             <a:r>
-              <a:rPr sz="2250" b="0">
+              <a:rPr sz="1950" b="0">
                 <a:solidFill>
                   <a:srgbClr val="263C49"/>
                 </a:solidFill>
@@ -6259,17 +6255,89 @@
                 <a:ea typeface="Arial"/>
                 <a:cs typeface="Arial"/>
               </a:rPr>
-              <a:t>Local loggers show how satellite and underwater temperatures vary by site and season.</a:t>
+              <a:t>RF MAE: 0.2214°C</a:t>
+            </a:r>
+          </a:p>
+          <a:p xmlns:a="http://schemas.openxmlformats.org/drawingml/2006/main">
+            <a:pPr>
+              <a:buNone/>
+              <a:defRPr sz="1950" b="0">
+                <a:solidFill>
+                  <a:srgbClr val="263C49"/>
+                </a:solidFill>
+                <a:latin typeface="Arial"/>
+                <a:ea typeface="Arial"/>
+                <a:cs typeface="Arial"/>
+              </a:defRPr>
+            </a:pPr>
+            <a:r>
+              <a:rPr sz="1950" b="0">
+                <a:solidFill>
+                  <a:srgbClr val="263C49"/>
+                </a:solidFill>
+                <a:latin typeface="Arial"/>
+                <a:ea typeface="Arial"/>
+                <a:cs typeface="Arial"/>
+              </a:rPr>
+              <a:t>Persistence: 0.2209°C</a:t>
+            </a:r>
+          </a:p>
+          <a:p xmlns:a="http://schemas.openxmlformats.org/drawingml/2006/main">
+            <a:pPr>
+              <a:buNone/>
+              <a:defRPr sz="1950" b="0">
+                <a:solidFill>
+                  <a:srgbClr val="263C49"/>
+                </a:solidFill>
+                <a:latin typeface="Arial"/>
+                <a:ea typeface="Arial"/>
+                <a:cs typeface="Arial"/>
+              </a:defRPr>
+            </a:pPr>
+            <a:r>
+              <a:rPr sz="1950" b="0">
+                <a:solidFill>
+                  <a:srgbClr val="263C49"/>
+                </a:solidFill>
+                <a:latin typeface="Arial"/>
+                <a:ea typeface="Arial"/>
+                <a:cs typeface="Arial"/>
+              </a:rPr>
+              <a:t>Nearly identical errors</a:t>
+            </a:r>
+          </a:p>
+          <a:p xmlns:a="http://schemas.openxmlformats.org/drawingml/2006/main">
+            <a:pPr>
+              <a:buNone/>
+              <a:defRPr sz="1950" b="0">
+                <a:solidFill>
+                  <a:srgbClr val="263C49"/>
+                </a:solidFill>
+                <a:latin typeface="Arial"/>
+                <a:ea typeface="Arial"/>
+                <a:cs typeface="Arial"/>
+              </a:defRPr>
+            </a:pPr>
+            <a:r>
+              <a:rPr sz="1950" b="0">
+                <a:solidFill>
+                  <a:srgbClr val="263C49"/>
+                </a:solidFill>
+                <a:latin typeface="Arial"/>
+                <a:ea typeface="Arial"/>
+                <a:cs typeface="Arial"/>
+              </a:rPr>
+              <a:t>11,168 forecasts</a:t>
             </a:r>
           </a:p>
         </p:txBody>
       </p:sp>
       <p:sp>
         <p:nvSpPr>
-          <p:cNvPr id="4" name="">
+          <p:cNvPr id="11" name="">
             <a:extLst xmlns:a="http://schemas.openxmlformats.org/drawingml/2006/main">
               <a:ext uri="{FF2B5EF4-FFF2-40B4-BE49-F238E27FC236}">
-                <a16:creationId xmlns:a16="http://schemas.microsoft.com/office/drawing/2014/main" id="{9B72B89E-050F-41F7-92F8-060BC92693D9}"/>
+                <a16:creationId xmlns:a16="http://schemas.microsoft.com/office/drawing/2014/main" id="{5A225F96-C3B7-4A28-AAE6-64A9C3B4121F}"/>
               </a:ext>
             </a:extLst>
           </p:cNvPr>
@@ -6280,8 +6348,8 @@
         </p:nvSpPr>
         <p:spPr>
           <a:xfrm xmlns:a="http://schemas.openxmlformats.org/drawingml/2006/main">
-            <a:off x="571500" y="4191000"/>
-            <a:ext cx="6286500" cy="1143000"/>
+            <a:off x="7905750" y="3667125"/>
+            <a:ext cx="3810000" cy="409575"/>
           </a:xfrm>
           <a:prstGeom xmlns:a="http://schemas.openxmlformats.org/drawingml/2006/main" prst="rect">
             <a:avLst/>
@@ -6295,9 +6363,9 @@
           <a:bodyPr xmlns:a="http://schemas.openxmlformats.org/drawingml/2006/main"/>
           <a:lstStyle xmlns:a="http://schemas.openxmlformats.org/drawingml/2006/main">
             <a:defPPr>
-              <a:defRPr sz="2250" b="0">
-                <a:solidFill>
-                  <a:srgbClr val="263C49"/>
+              <a:defRPr sz="2100" b="1">
+                <a:solidFill>
+                  <a:srgbClr val="167D91"/>
                 </a:solidFill>
                 <a:latin typeface="Arial"/>
                 <a:ea typeface="Arial"/>
@@ -6308,9 +6376,9 @@
           <a:p xmlns:a="http://schemas.openxmlformats.org/drawingml/2006/main">
             <a:pPr>
               <a:buNone/>
-              <a:defRPr sz="2250" b="0">
-                <a:solidFill>
-                  <a:srgbClr val="263C49"/>
+              <a:defRPr sz="2100" b="1">
+                <a:solidFill>
+                  <a:srgbClr val="167D91"/>
                 </a:solidFill>
                 <a:latin typeface="Arial"/>
                 <a:ea typeface="Arial"/>
@@ -6318,25 +6386,25 @@
               </a:defRPr>
             </a:pPr>
             <a:r>
-              <a:rPr sz="2250" b="0">
-                <a:solidFill>
-                  <a:srgbClr val="263C49"/>
+              <a:rPr sz="2100" b="1">
+                <a:solidFill>
+                  <a:srgbClr val="167D91"/>
                 </a:solidFill>
                 <a:latin typeface="Arial"/>
                 <a:ea typeface="Arial"/>
                 <a:cs typeface="Arial"/>
               </a:rPr>
-              <a:t>A simple baseline remains essential. Future work could test anomaly-focused models and transfer to Florida.</a:t>
+              <a:t>High stress: DHW ≥8</a:t>
             </a:r>
           </a:p>
         </p:txBody>
       </p:sp>
       <p:sp>
         <p:nvSpPr>
-          <p:cNvPr id="5" name="">
+          <p:cNvPr id="12" name="">
             <a:extLst xmlns:a="http://schemas.openxmlformats.org/drawingml/2006/main">
               <a:ext uri="{FF2B5EF4-FFF2-40B4-BE49-F238E27FC236}">
-                <a16:creationId xmlns:a16="http://schemas.microsoft.com/office/drawing/2014/main" id="{DF864F22-5A70-4421-8FD6-39ECCD277BE1}"/>
+                <a16:creationId xmlns:a16="http://schemas.microsoft.com/office/drawing/2014/main" id="{F3CD1D34-41EE-49C0-A1C6-124486688729}"/>
               </a:ext>
             </a:extLst>
           </p:cNvPr>
@@ -6347,8 +6415,8 @@
         </p:nvSpPr>
         <p:spPr>
           <a:xfrm xmlns:a="http://schemas.openxmlformats.org/drawingml/2006/main">
-            <a:off x="571500" y="5810250"/>
-            <a:ext cx="11049000" cy="666750"/>
+            <a:off x="7905750" y="4162425"/>
+            <a:ext cx="3810000" cy="1381125"/>
           </a:xfrm>
           <a:prstGeom xmlns:a="http://schemas.openxmlformats.org/drawingml/2006/main" prst="rect">
             <a:avLst/>
@@ -6362,9 +6430,9 @@
           <a:bodyPr xmlns:a="http://schemas.openxmlformats.org/drawingml/2006/main"/>
           <a:lstStyle xmlns:a="http://schemas.openxmlformats.org/drawingml/2006/main">
             <a:defPPr>
-              <a:defRPr sz="1800" b="0">
-                <a:solidFill>
-                  <a:srgbClr val="167D91"/>
+              <a:defRPr sz="1950" b="0">
+                <a:solidFill>
+                  <a:srgbClr val="263C49"/>
                 </a:solidFill>
                 <a:latin typeface="Arial"/>
                 <a:ea typeface="Arial"/>
@@ -6375,9 +6443,9 @@
           <a:p xmlns:a="http://schemas.openxmlformats.org/drawingml/2006/main">
             <a:pPr>
               <a:buNone/>
-              <a:defRPr sz="1800" b="0">
-                <a:solidFill>
-                  <a:srgbClr val="167D91"/>
+              <a:defRPr sz="1950" b="0">
+                <a:solidFill>
+                  <a:srgbClr val="263C49"/>
                 </a:solidFill>
                 <a:latin typeface="Arial"/>
                 <a:ea typeface="Arial"/>
@@ -6385,23 +6453,23 @@
               </a:defRPr>
             </a:pPr>
             <a:r>
-              <a:rPr sz="1800" b="0">
-                <a:solidFill>
-                  <a:srgbClr val="167D91"/>
+              <a:rPr sz="1950" b="0">
+                <a:solidFill>
+                  <a:srgbClr val="263C49"/>
                 </a:solidFill>
                 <a:latin typeface="Arial"/>
                 <a:ea typeface="Arial"/>
                 <a:cs typeface="Arial"/>
               </a:rPr>
-              <a:t>Process log and Python notebook</a:t>
+              <a:t>RF MAE: 0.4594°C</a:t>
             </a:r>
           </a:p>
           <a:p xmlns:a="http://schemas.openxmlformats.org/drawingml/2006/main">
             <a:pPr>
               <a:buNone/>
-              <a:defRPr sz="1800" b="0">
-                <a:solidFill>
-                  <a:srgbClr val="167D91"/>
+              <a:defRPr sz="1950" b="0">
+                <a:solidFill>
+                  <a:srgbClr val="263C49"/>
                 </a:solidFill>
                 <a:latin typeface="Arial"/>
                 <a:ea typeface="Arial"/>
@@ -6409,47 +6477,200 @@
               </a:defRPr>
             </a:pPr>
             <a:r>
-              <a:rPr sz="1800" b="0">
-                <a:solidFill>
-                  <a:srgbClr val="167D91"/>
+              <a:rPr sz="1950" b="0">
+                <a:solidFill>
+                  <a:srgbClr val="263C49"/>
                 </a:solidFill>
                 <a:latin typeface="Arial"/>
                 <a:ea typeface="Arial"/>
                 <a:cs typeface="Arial"/>
               </a:rPr>
-              <a:t>github.com/drwbkr1/West-Hawaii-Heat-Stress-ASM540</a:t>
+              <a:t>Persistence: 0.2779°C</a:t>
+            </a:r>
+          </a:p>
+          <a:p xmlns:a="http://schemas.openxmlformats.org/drawingml/2006/main">
+            <a:pPr>
+              <a:buNone/>
+              <a:defRPr sz="1950" b="0">
+                <a:solidFill>
+                  <a:srgbClr val="263C49"/>
+                </a:solidFill>
+                <a:latin typeface="Arial"/>
+                <a:ea typeface="Arial"/>
+                <a:cs typeface="Arial"/>
+              </a:defRPr>
+            </a:pPr>
+            <a:r>
+              <a:rPr sz="1950" b="0">
+                <a:solidFill>
+                  <a:srgbClr val="263C49"/>
+                </a:solidFill>
+                <a:latin typeface="Arial"/>
+                <a:ea typeface="Arial"/>
+                <a:cs typeface="Arial"/>
+              </a:rPr>
+              <a:t>RF error is about 65% higher</a:t>
+            </a:r>
+          </a:p>
+          <a:p xmlns:a="http://schemas.openxmlformats.org/drawingml/2006/main">
+            <a:pPr>
+              <a:buNone/>
+              <a:defRPr sz="1950" b="0">
+                <a:solidFill>
+                  <a:srgbClr val="263C49"/>
+                </a:solidFill>
+                <a:latin typeface="Arial"/>
+                <a:ea typeface="Arial"/>
+                <a:cs typeface="Arial"/>
+              </a:defRPr>
+            </a:pPr>
+            <a:r>
+              <a:rPr sz="1950" b="0">
+                <a:solidFill>
+                  <a:srgbClr val="263C49"/>
+                </a:solidFill>
+                <a:latin typeface="Arial"/>
+                <a:ea typeface="Arial"/>
+                <a:cs typeface="Arial"/>
+              </a:rPr>
+              <a:t>327 forecasts</a:t>
             </a:r>
           </a:p>
         </p:txBody>
       </p:sp>
-      <p:pic>
-        <p:nvPicPr>
-          <p:cNvPr id="6" name="">
+      <p:sp>
+        <p:nvSpPr>
+          <p:cNvPr id="13" name="">
             <a:extLst xmlns:a="http://schemas.openxmlformats.org/drawingml/2006/main">
               <a:ext uri="{FF2B5EF4-FFF2-40B4-BE49-F238E27FC236}">
-                <a16:creationId xmlns:a16="http://schemas.microsoft.com/office/drawing/2014/main" id="{CC63C171-5F41-458F-BF43-3FE5C49BBEAB}"/>
+                <a16:creationId xmlns:a16="http://schemas.microsoft.com/office/drawing/2014/main" id="{0DF35F1A-6A5F-4446-B64E-8F899DAB246B}"/>
               </a:ext>
             </a:extLst>
           </p:cNvPr>
-          <p:cNvPicPr>
-            <a:picLocks xmlns:a="http://schemas.openxmlformats.org/drawingml/2006/main" noChangeAspect="1"/>
-          </p:cNvPicPr>
+          <p:cNvSpPr>
+            <a:spLocks xmlns:a="http://schemas.openxmlformats.org/drawingml/2006/main" noGrp="1"/>
+          </p:cNvSpPr>
           <p:nvPr/>
-        </p:nvPicPr>
-        <p:blipFill>
-          <a:blip xmlns:r="http://schemas.openxmlformats.org/officeDocument/2006/relationships" xmlns:a="http://schemas.openxmlformats.org/drawingml/2006/main" r:embed="R7aa9c698999f40a6"/>
-          <a:stretch xmlns:a="http://schemas.openxmlformats.org/drawingml/2006/main"/>
-        </p:blipFill>
+        </p:nvSpPr>
         <p:spPr>
           <a:xfrm xmlns:a="http://schemas.openxmlformats.org/drawingml/2006/main">
-            <a:off x="7334250" y="1706923"/>
-            <a:ext cx="4333875" cy="3348903"/>
+            <a:off x="7905750" y="5762625"/>
+            <a:ext cx="3810000" cy="828675"/>
           </a:xfrm>
           <a:prstGeom xmlns:a="http://schemas.openxmlformats.org/drawingml/2006/main" prst="rect">
             <a:avLst/>
           </a:prstGeom>
+          <a:noFill xmlns:a="http://schemas.openxmlformats.org/drawingml/2006/main"/>
+          <a:ln xmlns:a="http://schemas.openxmlformats.org/drawingml/2006/main" w="0">
+            <a:noFill/>
+          </a:ln>
         </p:spPr>
-      </p:pic>
+        <p:txBody>
+          <a:bodyPr xmlns:a="http://schemas.openxmlformats.org/drawingml/2006/main"/>
+          <a:lstStyle xmlns:a="http://schemas.openxmlformats.org/drawingml/2006/main">
+            <a:defPPr>
+              <a:defRPr sz="1950" b="0">
+                <a:solidFill>
+                  <a:srgbClr val="263C49"/>
+                </a:solidFill>
+                <a:latin typeface="Arial"/>
+                <a:ea typeface="Arial"/>
+                <a:cs typeface="Arial"/>
+              </a:defRPr>
+            </a:defPPr>
+          </a:lstStyle>
+          <a:p xmlns:a="http://schemas.openxmlformats.org/drawingml/2006/main">
+            <a:pPr>
+              <a:buNone/>
+              <a:defRPr sz="1950" b="0">
+                <a:solidFill>
+                  <a:srgbClr val="263C49"/>
+                </a:solidFill>
+                <a:latin typeface="Arial"/>
+                <a:ea typeface="Arial"/>
+                <a:cs typeface="Arial"/>
+              </a:defRPr>
+            </a:pPr>
+            <a:r>
+              <a:rPr sz="1950" b="0">
+                <a:solidFill>
+                  <a:srgbClr val="263C49"/>
+                </a:solidFill>
+                <a:latin typeface="Arial"/>
+                <a:ea typeface="Arial"/>
+                <a:cs typeface="Arial"/>
+              </a:rPr>
+              <a:t>In 2015, RF error was about 63% higher than persistence in both southern cells.</a:t>
+            </a:r>
+          </a:p>
+        </p:txBody>
+      </p:sp>
+      <p:sp>
+        <p:nvSpPr>
+          <p:cNvPr id="14" name="">
+            <a:extLst xmlns:a="http://schemas.openxmlformats.org/drawingml/2006/main">
+              <a:ext uri="{FF2B5EF4-FFF2-40B4-BE49-F238E27FC236}">
+                <a16:creationId xmlns:a16="http://schemas.microsoft.com/office/drawing/2014/main" id="{3F3C4DD7-1346-4BC3-AE1E-02EDC0737F16}"/>
+              </a:ext>
+            </a:extLst>
+          </p:cNvPr>
+          <p:cNvSpPr>
+            <a:spLocks xmlns:a="http://schemas.openxmlformats.org/drawingml/2006/main" noGrp="1"/>
+          </p:cNvSpPr>
+          <p:nvPr/>
+        </p:nvSpPr>
+        <p:spPr>
+          <a:xfrm xmlns:a="http://schemas.openxmlformats.org/drawingml/2006/main">
+            <a:off x="571500" y="1028700"/>
+            <a:ext cx="11144250" cy="304800"/>
+          </a:xfrm>
+          <a:prstGeom xmlns:a="http://schemas.openxmlformats.org/drawingml/2006/main" prst="rect">
+            <a:avLst/>
+          </a:prstGeom>
+          <a:noFill xmlns:a="http://schemas.openxmlformats.org/drawingml/2006/main"/>
+          <a:ln xmlns:a="http://schemas.openxmlformats.org/drawingml/2006/main" w="0">
+            <a:noFill/>
+          </a:ln>
+        </p:spPr>
+        <p:txBody>
+          <a:bodyPr xmlns:a="http://schemas.openxmlformats.org/drawingml/2006/main"/>
+          <a:lstStyle xmlns:a="http://schemas.openxmlformats.org/drawingml/2006/main">
+            <a:defPPr>
+              <a:defRPr sz="1650">
+                <a:solidFill>
+                  <a:srgbClr val="263C49"/>
+                </a:solidFill>
+                <a:latin typeface="Arial"/>
+                <a:ea typeface="Arial"/>
+                <a:cs typeface="Arial"/>
+              </a:defRPr>
+            </a:defPPr>
+          </a:lstStyle>
+          <a:p xmlns:a="http://schemas.openxmlformats.org/drawingml/2006/main">
+            <a:pPr>
+              <a:defRPr sz="1650">
+                <a:solidFill>
+                  <a:srgbClr val="263C49"/>
+                </a:solidFill>
+                <a:latin typeface="Arial"/>
+                <a:ea typeface="Arial"/>
+                <a:cs typeface="Arial"/>
+              </a:defRPr>
+            </a:pPr>
+            <a:r>
+              <a:rPr sz="1650">
+                <a:solidFill>
+                  <a:srgbClr val="263C49"/>
+                </a:solidFill>
+                <a:latin typeface="Arial"/>
+                <a:ea typeface="Arial"/>
+                <a:cs typeface="Arial"/>
+              </a:rPr>
+              <a:t>Error statistics pool all three cells. Animation shows the two southern cells, 2015–2025.</a:t>
+            </a:r>
+          </a:p>
+        </p:txBody>
+      </p:sp>
     </p:spTree>
     <p:extLst>
       <p:ext uri="{BB962C8B-B14F-4D97-AF65-F5344CB8AC3E}">

</xml_diff>

<commit_message>
Finalize seven-slide project presentation
</commit_message>
<xml_diff>
--- a/GISProjectDrewBaker/Documentation/GISPresentationDrewBaker.pptx
+++ b/GISProjectDrewBaker/Documentation/GISPresentationDrewBaker.pptx
@@ -2,18 +2,19 @@
 <file path=ppt/presentation.xml><?xml version="1.0" encoding="utf-8"?>
 <p:presentation xmlns:p="http://schemas.openxmlformats.org/presentationml/2006/main">
   <p:sldMasterIdLst>
-    <p:sldMasterId xmlns:r="http://schemas.openxmlformats.org/officeDocument/2006/relationships" id="2147483648" r:id="R4bc514cc72f94168"/>
+    <p:sldMasterId xmlns:r="http://schemas.openxmlformats.org/officeDocument/2006/relationships" id="2147483648" r:id="R2d2c63b5caac45f6"/>
   </p:sldMasterIdLst>
   <p:notesMasterIdLst>
-    <p:notesMasterId xmlns:r="http://schemas.openxmlformats.org/officeDocument/2006/relationships" r:id="R58250559d34e441a"/>
+    <p:notesMasterId xmlns:r="http://schemas.openxmlformats.org/officeDocument/2006/relationships" r:id="Rafcd23d65ba34088"/>
   </p:notesMasterIdLst>
   <p:sldIdLst>
-    <p:sldId xmlns:r="http://schemas.openxmlformats.org/officeDocument/2006/relationships" id="256" r:id="Rf879ede7e35f4684"/>
-    <p:sldId xmlns:r="http://schemas.openxmlformats.org/officeDocument/2006/relationships" id="257" r:id="R26d851868314496f"/>
-    <p:sldId xmlns:r="http://schemas.openxmlformats.org/officeDocument/2006/relationships" id="258" r:id="Rbf9dfa7382b84714"/>
-    <p:sldId xmlns:r="http://schemas.openxmlformats.org/officeDocument/2006/relationships" id="259" r:id="Re8ee5990899a4e28"/>
-    <p:sldId xmlns:r="http://schemas.openxmlformats.org/officeDocument/2006/relationships" id="260" r:id="Rb31255b437c84b4e"/>
-    <p:sldId xmlns:r="http://schemas.openxmlformats.org/officeDocument/2006/relationships" id="261" r:id="R2928e4056cf04ccd"/>
+    <p:sldId xmlns:r="http://schemas.openxmlformats.org/officeDocument/2006/relationships" id="256" r:id="R518aee93a5a24d76"/>
+    <p:sldId xmlns:r="http://schemas.openxmlformats.org/officeDocument/2006/relationships" id="257" r:id="R0fbbc83541a14e6b"/>
+    <p:sldId xmlns:r="http://schemas.openxmlformats.org/officeDocument/2006/relationships" id="258" r:id="R049e8d679d3a4a1b"/>
+    <p:sldId xmlns:r="http://schemas.openxmlformats.org/officeDocument/2006/relationships" id="259" r:id="R831479eccf3848ff"/>
+    <p:sldId xmlns:r="http://schemas.openxmlformats.org/officeDocument/2006/relationships" id="260" r:id="Rf29660fa043742f8"/>
+    <p:sldId xmlns:r="http://schemas.openxmlformats.org/officeDocument/2006/relationships" id="261" r:id="R26ee96f621124dc0"/>
+    <p:sldId xmlns:r="http://schemas.openxmlformats.org/officeDocument/2006/relationships" id="262" r:id="R38809290cf4b4c3e"/>
   </p:sldIdLst>
   <p:sldSz cx="12192000" cy="6858000"/>
   <p:notesSz cx="6858000" cy="9144000"/>
@@ -447,17 +448,17 @@
           <a:lstStyle xmlns:a="http://schemas.openxmlformats.org/drawingml/2006/main"/>
           <a:p xmlns:a="http://schemas.openxmlformats.org/drawingml/2006/main">
             <a:r>
-              <a:t>I examine how thermal exposure differed between 2015 and 2019, how satellite SST compared with underwater loggers, and whether random forests improved seven-day SST forecasts.</a:t>
-            </a:r>
-          </a:p>
-          <a:p xmlns:a="http://schemas.openxmlformats.org/drawingml/2006/main">
-            <a:r>
-              <a:t>NOAA Coral Reef Watch via PacIOOS: https://pae-paha.pacioos.hawaii.edu/erddap/griddap/dhw_5km.html</a:t>
-            </a:r>
-          </a:p>
-          <a:p xmlns:a="http://schemas.openxmlformats.org/drawingml/2006/main">
-            <a:r>
-              <a:t>NOAA NCEI: https://www.ncei.noaa.gov/erddap/tabledap/CRCP_Subsurface_Temp_Hawaii.html</a:t>
+              <a:t>Northern West Hawaiʻi near Upolu Point, with 2007 benthic habitat and NOAA logger sites OCC-HAW-001 and OCC-HAW-002.</a:t>
+            </a:r>
+          </a:p>
+          <a:p xmlns:a="http://schemas.openxmlformats.org/drawingml/2006/main">
+            <a:r>
+              <a:t>Map view from the Where to Begin sidecar: https://storymaps.arcgis.com/stories/7e6551719d15418a997e2517c2bc24cc</a:t>
+            </a:r>
+          </a:p>
+          <a:p xmlns:a="http://schemas.openxmlformats.org/drawingml/2006/main">
+            <a:r>
+              <a:t>NOAA NCEI underwater records: https://www.ncei.noaa.gov/erddap/tabledap/CRCP_Subsurface_Temp_Hawaii.html</a:t>
             </a:r>
           </a:p>
           <a:p xmlns:a="http://schemas.openxmlformats.org/drawingml/2006/main">
@@ -467,7 +468,7 @@
           </a:p>
           <a:p xmlns:a="http://schemas.openxmlformats.org/drawingml/2006/main">
             <a:r>
-              <a:t>Project results: https://github.com/drwbkr1/West-Hawaii-Heat-Stress-ASM540/tree/main/Analysis</a:t>
+              <a:t>The regional comparison focuses on 2015 and 2019. Forecasting evaluates 2015–2025 after development on 2003–2014.</a:t>
             </a:r>
           </a:p>
         </p:txBody>
@@ -958,6 +959,106 @@
           <a:p xmlns:a="http://schemas.openxmlformats.org/drawingml/2006/main">
             <a:r>
               <a:t>Notebook: https://github.com/drwbkr1/West-Hawaii-Heat-Stress-ASM540/blob/main/Analysis/Q3/Q3_SST_Forecasting.ipynb</a:t>
+            </a:r>
+          </a:p>
+        </p:txBody>
+      </p:sp>
+      <p:sp>
+        <p:nvSpPr>
+          <p:cNvPr id="4" name="Slide Number Placeholder 3"/>
+          <p:cNvSpPr>
+            <a:spLocks xmlns:a="http://schemas.openxmlformats.org/drawingml/2006/main" noGrp="1"/>
+          </p:cNvSpPr>
+          <p:nvPr>
+            <p:ph type="sldNum" idx="5"/>
+          </p:nvPr>
+        </p:nvSpPr>
+        <p:spPr/>
+        <p:txBody>
+          <a:bodyPr xmlns:a="http://schemas.openxmlformats.org/drawingml/2006/main"/>
+          <a:lstStyle xmlns:a="http://schemas.openxmlformats.org/drawingml/2006/main"/>
+          <a:p xmlns:a="http://schemas.openxmlformats.org/drawingml/2006/main"/>
+        </p:txBody>
+      </p:sp>
+    </p:spTree>
+  </p:cSld>
+  <p:clrMapOvr>
+    <a:masterClrMapping xmlns:a="http://schemas.openxmlformats.org/drawingml/2006/main"/>
+  </p:clrMapOvr>
+</p:notes>
+</file>
+
+<file path=ppt/notesSlides/notesSlide7.xml><?xml version="1.0" encoding="utf-8"?>
+<p:notes xmlns:p="http://schemas.openxmlformats.org/presentationml/2006/main">
+  <p:cSld>
+    <p:spTree>
+      <p:nvGrpSpPr>
+        <p:cNvPr id="1" name=""/>
+        <p:cNvGrpSpPr/>
+        <p:nvPr/>
+      </p:nvGrpSpPr>
+      <p:grpSpPr>
+        <a:xfrm xmlns:a="http://schemas.openxmlformats.org/drawingml/2006/main"/>
+      </p:grpSpPr>
+      <p:sp>
+        <p:nvSpPr>
+          <p:cNvPr id="2" name="Slide Image Placeholder 1"/>
+          <p:cNvSpPr>
+            <a:spLocks xmlns:a="http://schemas.openxmlformats.org/drawingml/2006/main" noGrp="1"/>
+          </p:cNvSpPr>
+          <p:nvPr>
+            <p:ph type="sldImg" idx="0"/>
+          </p:nvPr>
+        </p:nvSpPr>
+        <p:spPr/>
+      </p:sp>
+      <p:sp>
+        <p:nvSpPr>
+          <p:cNvPr id="3" name="Notes Placeholder 2"/>
+          <p:cNvSpPr>
+            <a:spLocks xmlns:a="http://schemas.openxmlformats.org/drawingml/2006/main" noGrp="1"/>
+          </p:cNvSpPr>
+          <p:nvPr>
+            <p:ph type="body" idx="1"/>
+          </p:nvPr>
+        </p:nvSpPr>
+        <p:spPr/>
+        <p:txBody>
+          <a:bodyPr xmlns:a="http://schemas.openxmlformats.org/drawingml/2006/main"/>
+          <a:lstStyle xmlns:a="http://schemas.openxmlformats.org/drawingml/2006/main"/>
+          <a:p xmlns:a="http://schemas.openxmlformats.org/drawingml/2006/main">
+            <a:r>
+              <a:t>Q1: greater median peak DHW and more mapped reef area at DHW ≥8 in 2015 than 2019. Q2: lower August–November RMSD in 2019 at all three compared sites. Q3: persistence achieved the lowest overall held-out test MAE, and RF errors rose during high-DHW conditions. Further study could include anomaly-focused models, rolling evaluation across hot years, predictors such as currents and wind, expanded underwater monitoring, and newer habitat mapping.</a:t>
+            </a:r>
+          </a:p>
+          <a:p xmlns:a="http://schemas.openxmlformats.org/drawingml/2006/main">
+            <a:r>
+              <a:t>Sources and download locations:</a:t>
+            </a:r>
+          </a:p>
+          <a:p xmlns:a="http://schemas.openxmlformats.org/drawingml/2006/main">
+            <a:r>
+              <a:t>NOAA Coral Reef Watch via PacIOOS: https://pae-paha.pacioos.hawaii.edu/erddap/griddap/dhw_5km.html</a:t>
+            </a:r>
+          </a:p>
+          <a:p xmlns:a="http://schemas.openxmlformats.org/drawingml/2006/main">
+            <a:r>
+              <a:t>NOAA NCEI: https://www.ncei.noaa.gov/erddap/tabledap/CRCP_Subsurface_Temp_Hawaii.html</a:t>
+            </a:r>
+          </a:p>
+          <a:p xmlns:a="http://schemas.openxmlformats.org/drawingml/2006/main">
+            <a:r>
+              <a:t>NOAA NCCOS: https://products.coastalscience.noaa.gov/collections/benthic/e97hawaii/data2007.aspx</a:t>
+            </a:r>
+          </a:p>
+          <a:p xmlns:a="http://schemas.openxmlformats.org/drawingml/2006/main">
+            <a:r>
+              <a:t>Process log: https://github.com/drwbkr1/West-Hawaii-Heat-Stress-ASM540/blob/main/Documentation/PROCESS_LOG.md</a:t>
+            </a:r>
+          </a:p>
+          <a:p xmlns:a="http://schemas.openxmlformats.org/drawingml/2006/main">
+            <a:r>
+              <a:t>Python notebook: https://github.com/drwbkr1/West-Hawaii-Heat-Stress-ASM540/blob/main/Analysis/Q3/Q3_SST_Forecasting.ipynb</a:t>
             </a:r>
           </a:p>
         </p:txBody>
@@ -2770,12 +2871,12 @@
   </p:cSld>
   <p:clrMap bg1="lt1" tx1="dk1" bg2="lt2" tx2="dk2" accent1="accent1" accent2="accent2" accent3="accent3" accent4="accent4" accent5="accent5" accent6="accent6" hlink="hlink" folHlink="folHlink"/>
   <p:sldLayoutIdLst>
-    <p:sldLayoutId xmlns:r="http://schemas.openxmlformats.org/officeDocument/2006/relationships" id="2147483649" r:id="R0210c505b3494c25"/>
-    <p:sldLayoutId xmlns:r="http://schemas.openxmlformats.org/officeDocument/2006/relationships" id="2147483650" r:id="Rbe66e302c7e6479d"/>
-    <p:sldLayoutId xmlns:r="http://schemas.openxmlformats.org/officeDocument/2006/relationships" id="2147483651" r:id="Rdbe7972b15b7457b"/>
-    <p:sldLayoutId xmlns:r="http://schemas.openxmlformats.org/officeDocument/2006/relationships" id="2147483652" r:id="R9b3b5159d7e34db0"/>
-    <p:sldLayoutId xmlns:r="http://schemas.openxmlformats.org/officeDocument/2006/relationships" id="2147483653" r:id="Rc8bae8308b4a4210"/>
-    <p:sldLayoutId xmlns:r="http://schemas.openxmlformats.org/officeDocument/2006/relationships" id="2147483654" r:id="Rec2e61500fef410b"/>
+    <p:sldLayoutId xmlns:r="http://schemas.openxmlformats.org/officeDocument/2006/relationships" id="2147483649" r:id="R6c44b37b32be4dfd"/>
+    <p:sldLayoutId xmlns:r="http://schemas.openxmlformats.org/officeDocument/2006/relationships" id="2147483650" r:id="R3cb410b0f6144c01"/>
+    <p:sldLayoutId xmlns:r="http://schemas.openxmlformats.org/officeDocument/2006/relationships" id="2147483651" r:id="Rc3449289e3ed477e"/>
+    <p:sldLayoutId xmlns:r="http://schemas.openxmlformats.org/officeDocument/2006/relationships" id="2147483652" r:id="Rd80c33eb5863495b"/>
+    <p:sldLayoutId xmlns:r="http://schemas.openxmlformats.org/officeDocument/2006/relationships" id="2147483653" r:id="R7a04a49f87e54a1a"/>
+    <p:sldLayoutId xmlns:r="http://schemas.openxmlformats.org/officeDocument/2006/relationships" id="2147483654" r:id="R5fe67b63e5c24da4"/>
   </p:sldLayoutIdLst>
   <p:txStyles>
     <p:titleStyle>
@@ -3497,24 +3598,89 @@
       <p:grpSpPr>
         <a:xfrm xmlns:a="http://schemas.openxmlformats.org/drawingml/2006/main"/>
       </p:grpSpPr>
-      <p:sp>
-        <p:nvSpPr>
-          <p:cNvPr id="4" name="">
+      <p:pic>
+        <p:nvPicPr>
+          <p:cNvPr id="7" name="">
             <a:extLst xmlns:a="http://schemas.openxmlformats.org/drawingml/2006/main">
               <a:ext uri="{FF2B5EF4-FFF2-40B4-BE49-F238E27FC236}">
-                <a16:creationId xmlns:a16="http://schemas.microsoft.com/office/drawing/2014/main" id="{05BA9921-F9CB-4DD6-BE19-6542A73424B4}"/>
+                <a16:creationId xmlns:a16="http://schemas.microsoft.com/office/drawing/2014/main" id="{31D5957E-6C66-49CA-9EF9-02F5BC42E4EB}"/>
               </a:ext>
             </a:extLst>
           </p:cNvPr>
-          <p:cNvSpPr>
-            <a:spLocks xmlns:a="http://schemas.openxmlformats.org/drawingml/2006/main" noGrp="1"/>
-          </p:cNvSpPr>
+          <p:cNvPicPr>
+            <a:picLocks xmlns:a="http://schemas.openxmlformats.org/drawingml/2006/main" noChangeAspect="1"/>
+          </p:cNvPicPr>
           <p:nvPr/>
-        </p:nvSpPr>
+        </p:nvPicPr>
+        <p:blipFill>
+          <a:blip xmlns:r="http://schemas.openxmlformats.org/officeDocument/2006/relationships" xmlns:a="http://schemas.openxmlformats.org/drawingml/2006/main" r:embed="R573f00f4a6d9498f"/>
+          <a:srcRect xmlns:a="http://schemas.openxmlformats.org/drawingml/2006/main" l="0" t="12500" r="0" b="3500"/>
+          <a:stretch xmlns:a="http://schemas.openxmlformats.org/drawingml/2006/main"/>
+        </p:blipFill>
         <p:spPr>
           <a:xfrm xmlns:a="http://schemas.openxmlformats.org/drawingml/2006/main">
-            <a:off x="619125" y="952500"/>
-            <a:ext cx="6477000" cy="1905000"/>
+            <a:off x="0" y="0"/>
+            <a:ext cx="12192000" cy="6858000"/>
+          </a:xfrm>
+          <a:prstGeom xmlns:a="http://schemas.openxmlformats.org/drawingml/2006/main" prst="rect">
+            <a:avLst/>
+          </a:prstGeom>
+        </p:spPr>
+      </p:pic>
+      <p:sp>
+        <p:nvSpPr>
+          <p:cNvPr id="2" name="Floating introduction panel">
+            <a:extLst xmlns:a="http://schemas.openxmlformats.org/drawingml/2006/main">
+              <a:ext uri="{FF2B5EF4-FFF2-40B4-BE49-F238E27FC236}">
+                <a16:creationId xmlns:a16="http://schemas.microsoft.com/office/drawing/2014/main" id="{21B3470F-7012-406A-A887-DFDE0CFBBF42}"/>
+              </a:ext>
+            </a:extLst>
+          </p:cNvPr>
+          <p:cNvSpPr>
+            <a:spLocks xmlns:a="http://schemas.openxmlformats.org/drawingml/2006/main" noGrp="1"/>
+          </p:cNvSpPr>
+          <p:nvPr/>
+        </p:nvSpPr>
+        <p:spPr>
+          <a:xfrm xmlns:a="http://schemas.openxmlformats.org/drawingml/2006/main">
+            <a:off x="590550" y="1304925"/>
+            <a:ext cx="4953000" cy="4724400"/>
+          </a:xfrm>
+          <a:prstGeom xmlns:a="http://schemas.openxmlformats.org/drawingml/2006/main" prst="rect">
+            <a:avLst/>
+          </a:prstGeom>
+          <a:solidFill xmlns:a="http://schemas.openxmlformats.org/drawingml/2006/main">
+            <a:srgbClr val="F8FCFA"/>
+          </a:solidFill>
+          <a:ln xmlns:a="http://schemas.openxmlformats.org/drawingml/2006/main" w="0">
+            <a:noFill/>
+          </a:ln>
+        </p:spPr>
+        <p:style>
+          <a:lnRef xmlns:a="http://schemas.openxmlformats.org/drawingml/2006/main" idx="0"/>
+          <a:fillRef xmlns:a="http://schemas.openxmlformats.org/drawingml/2006/main" idx="0"/>
+          <a:effectRef xmlns:a="http://schemas.openxmlformats.org/drawingml/2006/main" idx="6"/>
+          <a:fontRef xmlns:a="http://schemas.openxmlformats.org/drawingml/2006/main" idx="major"/>
+        </p:style>
+      </p:sp>
+      <p:sp>
+        <p:nvSpPr>
+          <p:cNvPr id="3" name="">
+            <a:extLst xmlns:a="http://schemas.openxmlformats.org/drawingml/2006/main">
+              <a:ext uri="{FF2B5EF4-FFF2-40B4-BE49-F238E27FC236}">
+                <a16:creationId xmlns:a16="http://schemas.microsoft.com/office/drawing/2014/main" id="{54080D7F-4349-4C24-8EB8-74AD31559E97}"/>
+              </a:ext>
+            </a:extLst>
+          </p:cNvPr>
+          <p:cNvSpPr>
+            <a:spLocks xmlns:a="http://schemas.openxmlformats.org/drawingml/2006/main" noGrp="1"/>
+          </p:cNvSpPr>
+          <p:nvPr/>
+        </p:nvSpPr>
+        <p:spPr>
+          <a:xfrm xmlns:a="http://schemas.openxmlformats.org/drawingml/2006/main">
+            <a:off x="914400" y="1809750"/>
+            <a:ext cx="4333875" cy="1476375"/>
           </a:xfrm>
           <a:prstGeom xmlns:a="http://schemas.openxmlformats.org/drawingml/2006/main" prst="rect">
             <a:avLst/>
@@ -3528,7 +3694,7 @@
           <a:bodyPr xmlns:a="http://schemas.openxmlformats.org/drawingml/2006/main"/>
           <a:lstStyle xmlns:a="http://schemas.openxmlformats.org/drawingml/2006/main">
             <a:defPPr>
-              <a:defRPr sz="4800" b="1">
+              <a:defRPr sz="4350" b="1">
                 <a:solidFill>
                   <a:srgbClr val="152F45"/>
                 </a:solidFill>
@@ -3540,8 +3706,7 @@
           </a:lstStyle>
           <a:p xmlns:a="http://schemas.openxmlformats.org/drawingml/2006/main">
             <a:pPr>
-              <a:buNone/>
-              <a:defRPr sz="4800" b="1">
+              <a:defRPr sz="4350" b="1">
                 <a:solidFill>
                   <a:srgbClr val="152F45"/>
                 </a:solidFill>
@@ -3551,7 +3716,7 @@
               </a:defRPr>
             </a:pPr>
             <a:r>
-              <a:rPr sz="4800" b="1">
+              <a:rPr sz="4350" b="1">
                 <a:solidFill>
                   <a:srgbClr val="152F45"/>
                 </a:solidFill>
@@ -3564,8 +3729,7 @@
           </a:p>
           <a:p xmlns:a="http://schemas.openxmlformats.org/drawingml/2006/main">
             <a:pPr>
-              <a:buNone/>
-              <a:defRPr sz="4800" b="1">
+              <a:defRPr sz="4350" b="1">
                 <a:solidFill>
                   <a:srgbClr val="152F45"/>
                 </a:solidFill>
@@ -3575,7 +3739,7 @@
               </a:defRPr>
             </a:pPr>
             <a:r>
-              <a:rPr sz="4800" b="1">
+              <a:rPr sz="4350" b="1">
                 <a:solidFill>
                   <a:srgbClr val="152F45"/>
                 </a:solidFill>
@@ -3590,10 +3754,10 @@
       </p:sp>
       <p:sp>
         <p:nvSpPr>
-          <p:cNvPr id="2" name="">
+          <p:cNvPr id="4" name="">
             <a:extLst xmlns:a="http://schemas.openxmlformats.org/drawingml/2006/main">
               <a:ext uri="{FF2B5EF4-FFF2-40B4-BE49-F238E27FC236}">
-                <a16:creationId xmlns:a16="http://schemas.microsoft.com/office/drawing/2014/main" id="{765067D9-B9FF-49DE-8E36-82A6B3359B54}"/>
+                <a16:creationId xmlns:a16="http://schemas.microsoft.com/office/drawing/2014/main" id="{A00D8CF6-0394-4B9A-90F1-14CC3B49B3B9}"/>
               </a:ext>
             </a:extLst>
           </p:cNvPr>
@@ -3604,8 +3768,8 @@
         </p:nvSpPr>
         <p:spPr>
           <a:xfrm xmlns:a="http://schemas.openxmlformats.org/drawingml/2006/main">
-            <a:off x="657225" y="3143250"/>
-            <a:ext cx="6191250" cy="1190625"/>
+            <a:off x="933450" y="3524250"/>
+            <a:ext cx="4286250" cy="1238250"/>
           </a:xfrm>
           <a:prstGeom xmlns:a="http://schemas.openxmlformats.org/drawingml/2006/main" prst="rect">
             <a:avLst/>
@@ -3619,7 +3783,7 @@
           <a:bodyPr xmlns:a="http://schemas.openxmlformats.org/drawingml/2006/main"/>
           <a:lstStyle xmlns:a="http://schemas.openxmlformats.org/drawingml/2006/main">
             <a:defPPr>
-              <a:defRPr sz="2250" b="0">
+              <a:defRPr sz="2100" b="0">
                 <a:solidFill>
                   <a:srgbClr val="263C49"/>
                 </a:solidFill>
@@ -3631,8 +3795,7 @@
           </a:lstStyle>
           <a:p xmlns:a="http://schemas.openxmlformats.org/drawingml/2006/main">
             <a:pPr>
-              <a:buNone/>
-              <a:defRPr sz="2250" b="0">
+              <a:defRPr sz="2100" b="0">
                 <a:solidFill>
                   <a:srgbClr val="263C49"/>
                 </a:solidFill>
@@ -3642,7 +3805,7 @@
               </a:defRPr>
             </a:pPr>
             <a:r>
-              <a:rPr sz="2250" b="0">
+              <a:rPr sz="2100" b="0">
                 <a:solidFill>
                   <a:srgbClr val="263C49"/>
                 </a:solidFill>
@@ -3650,13 +3813,12 @@
                 <a:ea typeface="Arial"/>
                 <a:cs typeface="Arial"/>
               </a:rPr>
-              <a:t>Satellite exposure, underwater temperatures,</a:t>
+              <a:t>Comparing and forecasting from</a:t>
             </a:r>
           </a:p>
           <a:p xmlns:a="http://schemas.openxmlformats.org/drawingml/2006/main">
             <a:pPr>
-              <a:buNone/>
-              <a:defRPr sz="2250" b="0">
+              <a:defRPr sz="2100" b="0">
                 <a:solidFill>
                   <a:srgbClr val="263C49"/>
                 </a:solidFill>
@@ -3666,7 +3828,7 @@
               </a:defRPr>
             </a:pPr>
             <a:r>
-              <a:rPr sz="2250" b="0">
+              <a:rPr sz="2100" b="0">
                 <a:solidFill>
                   <a:srgbClr val="263C49"/>
                 </a:solidFill>
@@ -3674,17 +3836,40 @@
                 <a:ea typeface="Arial"/>
                 <a:cs typeface="Arial"/>
               </a:rPr>
-              <a:t>and a seven-day forecasting test</a:t>
+              <a:t>the 2015 and 2019</a:t>
+            </a:r>
+          </a:p>
+          <a:p xmlns:a="http://schemas.openxmlformats.org/drawingml/2006/main">
+            <a:pPr>
+              <a:defRPr sz="2100" b="0">
+                <a:solidFill>
+                  <a:srgbClr val="263C49"/>
+                </a:solidFill>
+                <a:latin typeface="Arial"/>
+                <a:ea typeface="Arial"/>
+                <a:cs typeface="Arial"/>
+              </a:defRPr>
+            </a:pPr>
+            <a:r>
+              <a:rPr sz="2100" b="0">
+                <a:solidFill>
+                  <a:srgbClr val="263C49"/>
+                </a:solidFill>
+                <a:latin typeface="Arial"/>
+                <a:ea typeface="Arial"/>
+                <a:cs typeface="Arial"/>
+              </a:rPr>
+              <a:t>heating anomalies</a:t>
             </a:r>
           </a:p>
         </p:txBody>
       </p:sp>
       <p:sp>
         <p:nvSpPr>
-          <p:cNvPr id="3" name="">
+          <p:cNvPr id="5" name="">
             <a:extLst xmlns:a="http://schemas.openxmlformats.org/drawingml/2006/main">
               <a:ext uri="{FF2B5EF4-FFF2-40B4-BE49-F238E27FC236}">
-                <a16:creationId xmlns:a16="http://schemas.microsoft.com/office/drawing/2014/main" id="{90CF408D-B4F6-43BE-A887-34F9A3A79A79}"/>
+                <a16:creationId xmlns:a16="http://schemas.microsoft.com/office/drawing/2014/main" id="{381E6CA2-629E-4B57-831D-3C5C8198BD17}"/>
               </a:ext>
             </a:extLst>
           </p:cNvPr>
@@ -3695,8 +3880,8 @@
         </p:nvSpPr>
         <p:spPr>
           <a:xfrm xmlns:a="http://schemas.openxmlformats.org/drawingml/2006/main">
-            <a:off x="666750" y="5381625"/>
-            <a:ext cx="6477000" cy="857250"/>
+            <a:off x="933450" y="5124450"/>
+            <a:ext cx="4286250" cy="685800"/>
           </a:xfrm>
           <a:prstGeom xmlns:a="http://schemas.openxmlformats.org/drawingml/2006/main" prst="rect">
             <a:avLst/>
@@ -3722,7 +3907,6 @@
           </a:lstStyle>
           <a:p xmlns:a="http://schemas.openxmlformats.org/drawingml/2006/main">
             <a:pPr>
-              <a:buNone/>
               <a:defRPr sz="1875" b="0">
                 <a:solidFill>
                   <a:srgbClr val="167D91"/>
@@ -3746,7 +3930,6 @@
           </a:p>
           <a:p xmlns:a="http://schemas.openxmlformats.org/drawingml/2006/main">
             <a:pPr>
-              <a:buNone/>
               <a:defRPr sz="1875" b="0">
                 <a:solidFill>
                   <a:srgbClr val="167D91"/>
@@ -3765,7 +3948,73 @@
                 <a:ea typeface="Arial"/>
                 <a:cs typeface="Arial"/>
               </a:rPr>
-              <a:t>ASM54000, October 2026</a:t>
+              <a:t>ASM54000</a:t>
+            </a:r>
+          </a:p>
+        </p:txBody>
+      </p:sp>
+      <p:sp>
+        <p:nvSpPr>
+          <p:cNvPr id="6" name="">
+            <a:extLst xmlns:a="http://schemas.openxmlformats.org/drawingml/2006/main">
+              <a:ext uri="{FF2B5EF4-FFF2-40B4-BE49-F238E27FC236}">
+                <a16:creationId xmlns:a16="http://schemas.microsoft.com/office/drawing/2014/main" id="{FB24A4FC-E0A7-4135-9961-733EC3D6AF93}"/>
+              </a:ext>
+            </a:extLst>
+          </p:cNvPr>
+          <p:cNvSpPr>
+            <a:spLocks xmlns:a="http://schemas.openxmlformats.org/drawingml/2006/main" noGrp="1"/>
+          </p:cNvSpPr>
+          <p:nvPr/>
+        </p:nvSpPr>
+        <p:spPr>
+          <a:xfrm xmlns:a="http://schemas.openxmlformats.org/drawingml/2006/main">
+            <a:off x="209550" y="6572250"/>
+            <a:ext cx="11715750" cy="238125"/>
+          </a:xfrm>
+          <a:prstGeom xmlns:a="http://schemas.openxmlformats.org/drawingml/2006/main" prst="rect">
+            <a:avLst/>
+          </a:prstGeom>
+          <a:noFill xmlns:a="http://schemas.openxmlformats.org/drawingml/2006/main"/>
+          <a:ln xmlns:a="http://schemas.openxmlformats.org/drawingml/2006/main" w="0">
+            <a:noFill/>
+          </a:ln>
+        </p:spPr>
+        <p:txBody>
+          <a:bodyPr xmlns:a="http://schemas.openxmlformats.org/drawingml/2006/main"/>
+          <a:lstStyle xmlns:a="http://schemas.openxmlformats.org/drawingml/2006/main">
+            <a:defPPr>
+              <a:defRPr sz="1125" b="0">
+                <a:solidFill>
+                  <a:srgbClr val="263C49"/>
+                </a:solidFill>
+                <a:latin typeface="Arial"/>
+                <a:ea typeface="Arial"/>
+                <a:cs typeface="Arial"/>
+              </a:defRPr>
+            </a:defPPr>
+          </a:lstStyle>
+          <a:p xmlns:a="http://schemas.openxmlformats.org/drawingml/2006/main">
+            <a:pPr>
+              <a:defRPr sz="1125" b="0">
+                <a:solidFill>
+                  <a:srgbClr val="263C49"/>
+                </a:solidFill>
+                <a:latin typeface="Arial"/>
+                <a:ea typeface="Arial"/>
+                <a:cs typeface="Arial"/>
+              </a:defRPr>
+            </a:pPr>
+            <a:r>
+              <a:rPr sz="1125" b="0">
+                <a:solidFill>
+                  <a:srgbClr val="263C49"/>
+                </a:solidFill>
+                <a:latin typeface="Arial"/>
+                <a:ea typeface="Arial"/>
+                <a:cs typeface="Arial"/>
+              </a:rPr>
+              <a:t>Basemap: Esri, HERE, Garmin, USGS, METI/NASA, NGA, EPA, USDA. Data: NOAA.</a:t>
             </a:r>
           </a:p>
         </p:txBody>
@@ -3871,7 +4120,7 @@
           <p:cNvPr id="8" name="">
             <a:extLst xmlns:a="http://schemas.openxmlformats.org/drawingml/2006/main">
               <a:ext uri="{FF2B5EF4-FFF2-40B4-BE49-F238E27FC236}">
-                <a16:creationId xmlns:a16="http://schemas.microsoft.com/office/drawing/2014/main" id="{846F7E99-528A-4A6B-9AE3-9673207ABE33}"/>
+                <a16:creationId xmlns:a16="http://schemas.microsoft.com/office/drawing/2014/main" id="{E9DF57EA-385A-44E2-8315-D7569F425F33}"/>
               </a:ext>
             </a:extLst>
           </p:cNvPr>
@@ -3881,7 +4130,7 @@
           <p:nvPr/>
         </p:nvPicPr>
         <p:blipFill>
-          <a:blip xmlns:r="http://schemas.openxmlformats.org/officeDocument/2006/relationships" xmlns:a="http://schemas.openxmlformats.org/drawingml/2006/main" r:embed="Ra8e41c0111b3415c"/>
+          <a:blip xmlns:r="http://schemas.openxmlformats.org/officeDocument/2006/relationships" xmlns:a="http://schemas.openxmlformats.org/drawingml/2006/main" r:embed="R2b0ba315ee2348e1"/>
           <a:stretch xmlns:a="http://schemas.openxmlformats.org/drawingml/2006/main"/>
         </p:blipFill>
         <p:spPr>
@@ -4157,7 +4406,7 @@
                 <a:ea typeface="Arial"/>
                 <a:cs typeface="Arial"/>
               </a:rPr>
-              <a:t>Compare 2015 and 2019 peak DHW (°C-weeks), days at DHW ≥4 / ≥8, and exposed reef area (ha).</a:t>
+              <a:t>Compare Degree Heating Weeks (DHW) in 2015 and 2019 and map exposed reef area.</a:t>
             </a:r>
           </a:p>
         </p:txBody>
@@ -4291,7 +4540,7 @@
                 <a:ea typeface="Arial"/>
                 <a:cs typeface="Arial"/>
               </a:rPr>
-              <a:t>Compare nighttime logger means with satellite SST. Measure bias and RMSD (°C) by site, depth, and season.</a:t>
+              <a:t>Compare satellite sea surface temperature (SST) with loggers using bias and root mean square difference (RMSD).</a:t>
             </a:r>
           </a:p>
         </p:txBody>
@@ -4425,7 +4674,7 @@
                 <a:ea typeface="Arial"/>
                 <a:cs typeface="Arial"/>
               </a:rPr>
-              <a:t>Forecast satellite SST seven days ahead at three cells. Compare MAE and RMSE (°C) with persistence and seasonal averages.</a:t>
+              <a:t>Random forest learns from past SST and seasonal patterns. Benchmarks use today’s SST (persistence) and historical seasonal averages.</a:t>
             </a:r>
           </a:p>
         </p:txBody>
@@ -4531,7 +4780,7 @@
           <p:cNvPr id="2" name="">
             <a:extLst xmlns:a="http://schemas.openxmlformats.org/drawingml/2006/main">
               <a:ext uri="{FF2B5EF4-FFF2-40B4-BE49-F238E27FC236}">
-                <a16:creationId xmlns:a16="http://schemas.microsoft.com/office/drawing/2014/main" id="{16FF666C-8738-4274-8B3D-5B4D61EB2186}"/>
+                <a16:creationId xmlns:a16="http://schemas.microsoft.com/office/drawing/2014/main" id="{03515DD2-996E-44B0-8F58-719729B256BD}"/>
               </a:ext>
             </a:extLst>
           </p:cNvPr>
@@ -4541,7 +4790,7 @@
           <p:nvPr/>
         </p:nvPicPr>
         <p:blipFill>
-          <a:blip xmlns:r="http://schemas.openxmlformats.org/officeDocument/2006/relationships" xmlns:a="http://schemas.openxmlformats.org/drawingml/2006/main" r:embed="R81baaf4465384c2b"/>
+          <a:blip xmlns:r="http://schemas.openxmlformats.org/officeDocument/2006/relationships" xmlns:a="http://schemas.openxmlformats.org/drawingml/2006/main" r:embed="Rc0606fd18ce34baf"/>
           <a:stretch xmlns:a="http://schemas.openxmlformats.org/drawingml/2006/main"/>
         </p:blipFill>
         <p:spPr>
@@ -4951,7 +5200,7 @@
                 <a:ea typeface="Arial"/>
                 <a:cs typeface="Arial"/>
               </a:rPr>
-              <a:t>Pair 135 valid water cells. Median peak DHW: 11.64 vs. 10.39 °C-weeks. Reef area at DHW ≥8: 4,731 vs. 3,612 ha.</a:t>
+              <a:t>Median peak DHW: 11.64 vs. 10.39 °C-weeks. Reef area at DHW ≥8: 4,731 vs. 3,612 ha.</a:t>
             </a:r>
           </a:p>
         </p:txBody>
@@ -5057,7 +5306,7 @@
           <p:cNvPr id="7" name="">
             <a:extLst xmlns:a="http://schemas.openxmlformats.org/drawingml/2006/main">
               <a:ext uri="{FF2B5EF4-FFF2-40B4-BE49-F238E27FC236}">
-                <a16:creationId xmlns:a16="http://schemas.microsoft.com/office/drawing/2014/main" id="{07AD9825-64AF-4C0A-BDD9-631BFDF6AF8A}"/>
+                <a16:creationId xmlns:a16="http://schemas.microsoft.com/office/drawing/2014/main" id="{F4048686-5EF3-4D5F-B0B4-5FC91D8663FB}"/>
               </a:ext>
             </a:extLst>
           </p:cNvPr>
@@ -5067,7 +5316,7 @@
           <p:nvPr/>
         </p:nvPicPr>
         <p:blipFill>
-          <a:blip xmlns:r="http://schemas.openxmlformats.org/officeDocument/2006/relationships" xmlns:a="http://schemas.openxmlformats.org/drawingml/2006/main" r:embed="Rd31752c3cfb54311"/>
+          <a:blip xmlns:r="http://schemas.openxmlformats.org/officeDocument/2006/relationships" xmlns:a="http://schemas.openxmlformats.org/drawingml/2006/main" r:embed="R7930e5eae2e64d04"/>
           <a:stretch xmlns:a="http://schemas.openxmlformats.org/drawingml/2006/main"/>
         </p:blipFill>
         <p:spPr>
@@ -5410,7 +5659,7 @@
                 <a:ea typeface="Arial"/>
                 <a:cs typeface="Arial"/>
               </a:rPr>
-              <a:t>RMSD is lower in 2019 at all three sites. Each site/year uses 122 complete nights.</a:t>
+              <a:t>RMSD measures temperature mismatch in °C, giving larger differences more weight. Lower values mean closer agreement.</a:t>
             </a:r>
           </a:p>
         </p:txBody>
@@ -5516,7 +5765,7 @@
           <p:cNvPr id="2" name="Chart">
             <a:extLst xmlns:a="http://schemas.openxmlformats.org/drawingml/2006/main">
               <a:ext uri="{FF2B5EF4-FFF2-40B4-BE49-F238E27FC236}">
-                <a16:creationId xmlns:a16="http://schemas.microsoft.com/office/drawing/2014/main" id="{CE0E6774-18E4-451C-863A-DAD1FDE5920C}"/>
+                <a16:creationId xmlns:a16="http://schemas.microsoft.com/office/drawing/2014/main" id="{AB8BF462-8073-47A2-823B-52BD7F6EC500}"/>
               </a:ext>
             </a:extLst>
           </p:cNvPr>
@@ -5529,7 +5778,7 @@
         </p:xfrm>
         <a:graphic xmlns:a="http://schemas.openxmlformats.org/drawingml/2006/main">
           <a:graphicData uri="http://schemas.openxmlformats.org/drawingml/2006/chart">
-            <c:chart xmlns:r="http://schemas.openxmlformats.org/officeDocument/2006/relationships" xmlns:c="http://schemas.openxmlformats.org/drawingml/2006/chart" r:id="R3454e4de8c24448e"/>
+            <c:chart xmlns:r="http://schemas.openxmlformats.org/officeDocument/2006/relationships" xmlns:c="http://schemas.openxmlformats.org/drawingml/2006/chart" r:id="Rd4c94572ae7945be"/>
           </a:graphicData>
         </a:graphic>
       </p:graphicFrame>
@@ -5739,7 +5988,7 @@
           <p:cNvPr id="11" name="">
             <a:extLst xmlns:a="http://schemas.openxmlformats.org/drawingml/2006/main">
               <a:ext uri="{FF2B5EF4-FFF2-40B4-BE49-F238E27FC236}">
-                <a16:creationId xmlns:a16="http://schemas.microsoft.com/office/drawing/2014/main" id="{88ABCAC7-9DAD-4B93-8FE3-1AB54B9E86C9}"/>
+                <a16:creationId xmlns:a16="http://schemas.microsoft.com/office/drawing/2014/main" id="{F5646752-08D1-421A-BCED-E5F13EF73D9A}"/>
               </a:ext>
             </a:extLst>
           </p:cNvPr>
@@ -5750,7 +5999,7 @@
         </p:nvSpPr>
         <p:spPr>
           <a:xfrm xmlns:a="http://schemas.openxmlformats.org/drawingml/2006/main">
-            <a:off x="7953375" y="3143250"/>
+            <a:off x="7953375" y="3048000"/>
             <a:ext cx="3714750" cy="409575"/>
           </a:xfrm>
           <a:prstGeom xmlns:a="http://schemas.openxmlformats.org/drawingml/2006/main" prst="rect">
@@ -5777,7 +6026,6 @@
           </a:lstStyle>
           <a:p xmlns:a="http://schemas.openxmlformats.org/drawingml/2006/main">
             <a:pPr>
-              <a:buNone/>
               <a:defRPr sz="2175" b="1">
                 <a:solidFill>
                   <a:srgbClr val="167D91"/>
@@ -5806,7 +6054,7 @@
           <p:cNvPr id="12" name="">
             <a:extLst xmlns:a="http://schemas.openxmlformats.org/drawingml/2006/main">
               <a:ext uri="{FF2B5EF4-FFF2-40B4-BE49-F238E27FC236}">
-                <a16:creationId xmlns:a16="http://schemas.microsoft.com/office/drawing/2014/main" id="{A04BDDA0-6EE0-47DA-9532-3BCACF5B27DE}"/>
+                <a16:creationId xmlns:a16="http://schemas.microsoft.com/office/drawing/2014/main" id="{DB3442B3-3D81-4462-BE68-56FDF3B8A7D8}"/>
               </a:ext>
             </a:extLst>
           </p:cNvPr>
@@ -5817,8 +6065,8 @@
         </p:nvSpPr>
         <p:spPr>
           <a:xfrm xmlns:a="http://schemas.openxmlformats.org/drawingml/2006/main">
-            <a:off x="7953375" y="3619500"/>
-            <a:ext cx="3714750" cy="1238250"/>
+            <a:off x="7953375" y="3524250"/>
+            <a:ext cx="3714750" cy="1000125"/>
           </a:xfrm>
           <a:prstGeom xmlns:a="http://schemas.openxmlformats.org/drawingml/2006/main" prst="rect">
             <a:avLst/>
@@ -5844,7 +6092,6 @@
           </a:lstStyle>
           <a:p xmlns:a="http://schemas.openxmlformats.org/drawingml/2006/main">
             <a:pPr>
-              <a:buNone/>
               <a:defRPr sz="1950" b="0">
                 <a:solidFill>
                   <a:srgbClr val="263C49"/>
@@ -5863,7 +6110,7 @@
                 <a:ea typeface="Arial"/>
                 <a:cs typeface="Arial"/>
               </a:rPr>
-              <a:t>1,074 forecasts. Select depth 16 and leaf size 20. RF MAE: 0.2116°C vs. persistence: 0.2202°C.</a:t>
+              <a:t>1,074 forecasts. Optimal parameters: depth 16 and minimum leaf size 20.</a:t>
             </a:r>
           </a:p>
         </p:txBody>
@@ -5873,7 +6120,7 @@
           <p:cNvPr id="13" name="">
             <a:extLst xmlns:a="http://schemas.openxmlformats.org/drawingml/2006/main">
               <a:ext uri="{FF2B5EF4-FFF2-40B4-BE49-F238E27FC236}">
-                <a16:creationId xmlns:a16="http://schemas.microsoft.com/office/drawing/2014/main" id="{17AA3A65-9695-4BEA-A959-6AF53414106A}"/>
+                <a16:creationId xmlns:a16="http://schemas.microsoft.com/office/drawing/2014/main" id="{589ABD79-770D-47E0-906C-01FE03D08EA5}"/>
               </a:ext>
             </a:extLst>
           </p:cNvPr>
@@ -5884,7 +6131,7 @@
         </p:nvSpPr>
         <p:spPr>
           <a:xfrm xmlns:a="http://schemas.openxmlformats.org/drawingml/2006/main">
-            <a:off x="7953375" y="5095875"/>
+            <a:off x="7953375" y="4714875"/>
             <a:ext cx="3714750" cy="409575"/>
           </a:xfrm>
           <a:prstGeom xmlns:a="http://schemas.openxmlformats.org/drawingml/2006/main" prst="rect">
@@ -5911,7 +6158,6 @@
           </a:lstStyle>
           <a:p xmlns:a="http://schemas.openxmlformats.org/drawingml/2006/main">
             <a:pPr>
-              <a:buNone/>
               <a:defRPr sz="2025" b="1">
                 <a:solidFill>
                   <a:srgbClr val="167D91"/>
@@ -5940,7 +6186,7 @@
           <p:cNvPr id="14" name="">
             <a:extLst xmlns:a="http://schemas.openxmlformats.org/drawingml/2006/main">
               <a:ext uri="{FF2B5EF4-FFF2-40B4-BE49-F238E27FC236}">
-                <a16:creationId xmlns:a16="http://schemas.microsoft.com/office/drawing/2014/main" id="{9EA15038-42BA-4B49-BF20-905196AE2F7D}"/>
+                <a16:creationId xmlns:a16="http://schemas.microsoft.com/office/drawing/2014/main" id="{17641D33-640B-4238-82DC-EE23FABFE9B1}"/>
               </a:ext>
             </a:extLst>
           </p:cNvPr>
@@ -5951,8 +6197,8 @@
         </p:nvSpPr>
         <p:spPr>
           <a:xfrm xmlns:a="http://schemas.openxmlformats.org/drawingml/2006/main">
-            <a:off x="7953375" y="5572125"/>
-            <a:ext cx="3714750" cy="904875"/>
+            <a:off x="7953375" y="5191125"/>
+            <a:ext cx="3714750" cy="1524000"/>
           </a:xfrm>
           <a:prstGeom xmlns:a="http://schemas.openxmlformats.org/drawingml/2006/main" prst="rect">
             <a:avLst/>
@@ -5966,7 +6212,7 @@
           <a:bodyPr xmlns:a="http://schemas.openxmlformats.org/drawingml/2006/main"/>
           <a:lstStyle xmlns:a="http://schemas.openxmlformats.org/drawingml/2006/main">
             <a:defPPr>
-              <a:defRPr sz="1950" b="0">
+              <a:defRPr sz="1875" b="0">
                 <a:solidFill>
                   <a:srgbClr val="263C49"/>
                 </a:solidFill>
@@ -5978,8 +6224,7 @@
           </a:lstStyle>
           <a:p xmlns:a="http://schemas.openxmlformats.org/drawingml/2006/main">
             <a:pPr>
-              <a:buNone/>
-              <a:defRPr sz="1950" b="0">
+              <a:defRPr sz="1875" b="0">
                 <a:solidFill>
                   <a:srgbClr val="263C49"/>
                 </a:solidFill>
@@ -5989,7 +6234,7 @@
               </a:defRPr>
             </a:pPr>
             <a:r>
-              <a:rPr sz="1950" b="0">
+              <a:rPr sz="1875" b="0">
                 <a:solidFill>
                   <a:srgbClr val="263C49"/>
                 </a:solidFill>
@@ -5998,6 +6243,29 @@
                 <a:cs typeface="Arial"/>
               </a:rPr>
               <a:t>Refit through 2014. Test 11,754 forecasts across three cells.</a:t>
+            </a:r>
+          </a:p>
+          <a:p xmlns:a="http://schemas.openxmlformats.org/drawingml/2006/main">
+            <a:pPr>
+              <a:defRPr sz="1875" b="0">
+                <a:solidFill>
+                  <a:srgbClr val="263C49"/>
+                </a:solidFill>
+                <a:latin typeface="Arial"/>
+                <a:ea typeface="Arial"/>
+                <a:cs typeface="Arial"/>
+              </a:defRPr>
+            </a:pPr>
+            <a:r>
+              <a:rPr sz="1875" b="0">
+                <a:solidFill>
+                  <a:srgbClr val="263C49"/>
+                </a:solidFill>
+                <a:latin typeface="Arial"/>
+                <a:ea typeface="Arial"/>
+                <a:cs typeface="Arial"/>
+              </a:rPr>
+              <a:t>Test MAE (°C): RF 0.2350, persistence 0.2228, seasonal 0.5656.</a:t>
             </a:r>
           </a:p>
         </p:txBody>
@@ -6103,7 +6371,7 @@
           <p:cNvPr id="8" name="">
             <a:extLst xmlns:a="http://schemas.openxmlformats.org/drawingml/2006/main">
               <a:ext uri="{FF2B5EF4-FFF2-40B4-BE49-F238E27FC236}">
-                <a16:creationId xmlns:a16="http://schemas.microsoft.com/office/drawing/2014/main" id="{C329F119-0873-4465-8EA2-9CD270E15C44}"/>
+                <a16:creationId xmlns:a16="http://schemas.microsoft.com/office/drawing/2014/main" id="{CCFD30B4-D74C-43EA-8F03-E38B757C166B}"/>
               </a:ext>
             </a:extLst>
           </p:cNvPr>
@@ -6113,7 +6381,7 @@
           <p:nvPr/>
         </p:nvPicPr>
         <p:blipFill>
-          <a:blip xmlns:r="http://schemas.openxmlformats.org/officeDocument/2006/relationships" xmlns:a="http://schemas.openxmlformats.org/drawingml/2006/main" r:embed="R77e69ffc12064408"/>
+          <a:blip xmlns:r="http://schemas.openxmlformats.org/officeDocument/2006/relationships" xmlns:a="http://schemas.openxmlformats.org/drawingml/2006/main" r:embed="Re27c7f1c35844190"/>
           <a:stretch xmlns:a="http://schemas.openxmlformats.org/drawingml/2006/main"/>
         </p:blipFill>
         <p:spPr>
@@ -6600,7 +6868,7 @@
                 <a:ea typeface="Arial"/>
                 <a:cs typeface="Arial"/>
               </a:rPr>
-              <a:t>In 2015, RF error was about 63% higher than persistence in both southern cells.</a:t>
+              <a:t>RF handles lower-stress conditions well. Hotter extremes bring larger errors.</a:t>
             </a:r>
           </a:p>
         </p:txBody>
@@ -6648,6 +6916,7 @@
           </a:lstStyle>
           <a:p xmlns:a="http://schemas.openxmlformats.org/drawingml/2006/main">
             <a:pPr>
+              <a:buNone/>
               <a:defRPr sz="1650">
                 <a:solidFill>
                   <a:srgbClr val="263C49"/>
@@ -6675,6 +6944,543 @@
     <p:extLst>
       <p:ext uri="{BB962C8B-B14F-4D97-AF65-F5344CB8AC3E}">
         <p14:creationId xmlns:p14="http://schemas.microsoft.com/office/powerpoint/2010/main" val="790142010"/>
+      </p:ext>
+    </p:extLst>
+  </p:cSld>
+</p:sld>
+</file>
+
+<file path=ppt/slides/slide7.xml><?xml version="1.0" encoding="utf-8"?>
+<p:sld xmlns:p="http://schemas.openxmlformats.org/presentationml/2006/main">
+  <p:cSld>
+    <p:bg>
+      <p:bgPr>
+        <a:solidFill xmlns:a="http://schemas.openxmlformats.org/drawingml/2006/main">
+          <a:srgbClr val="FFFFFF"/>
+        </a:solidFill>
+      </p:bgPr>
+    </p:bg>
+    <p:spTree>
+      <p:nvGrpSpPr>
+        <p:cNvPr id="1" name=""/>
+        <p:cNvGrpSpPr/>
+        <p:nvPr/>
+      </p:nvGrpSpPr>
+      <p:grpSpPr>
+        <a:xfrm xmlns:a="http://schemas.openxmlformats.org/drawingml/2006/main"/>
+      </p:grpSpPr>
+      <p:sp>
+        <p:nvSpPr>
+          <p:cNvPr id="8" name="">
+            <a:extLst xmlns:a="http://schemas.openxmlformats.org/drawingml/2006/main">
+              <a:ext uri="{FF2B5EF4-FFF2-40B4-BE49-F238E27FC236}">
+                <a16:creationId xmlns:a16="http://schemas.microsoft.com/office/drawing/2014/main" id="{0E614C6F-10FD-4BB2-A4AB-5FE929E47EDA}"/>
+              </a:ext>
+            </a:extLst>
+          </p:cNvPr>
+          <p:cNvSpPr>
+            <a:spLocks xmlns:a="http://schemas.openxmlformats.org/drawingml/2006/main" noGrp="1"/>
+          </p:cNvSpPr>
+          <p:nvPr/>
+        </p:nvSpPr>
+        <p:spPr>
+          <a:xfrm xmlns:a="http://schemas.openxmlformats.org/drawingml/2006/main">
+            <a:off x="514350" y="361950"/>
+            <a:ext cx="11144250" cy="876300"/>
+          </a:xfrm>
+          <a:prstGeom xmlns:a="http://schemas.openxmlformats.org/drawingml/2006/main" prst="rect">
+            <a:avLst/>
+          </a:prstGeom>
+          <a:noFill xmlns:a="http://schemas.openxmlformats.org/drawingml/2006/main"/>
+          <a:ln xmlns:a="http://schemas.openxmlformats.org/drawingml/2006/main" w="0">
+            <a:noFill/>
+          </a:ln>
+        </p:spPr>
+        <p:txBody>
+          <a:bodyPr xmlns:a="http://schemas.openxmlformats.org/drawingml/2006/main"/>
+          <a:lstStyle xmlns:a="http://schemas.openxmlformats.org/drawingml/2006/main">
+            <a:defPPr>
+              <a:defRPr sz="3150" b="1">
+                <a:solidFill>
+                  <a:srgbClr val="152F45"/>
+                </a:solidFill>
+                <a:latin typeface="Arial"/>
+                <a:ea typeface="Arial"/>
+                <a:cs typeface="Arial"/>
+              </a:defRPr>
+            </a:defPPr>
+          </a:lstStyle>
+          <a:p xmlns:a="http://schemas.openxmlformats.org/drawingml/2006/main">
+            <a:pPr>
+              <a:defRPr sz="3150" b="1">
+                <a:solidFill>
+                  <a:srgbClr val="152F45"/>
+                </a:solidFill>
+                <a:latin typeface="Arial"/>
+                <a:ea typeface="Arial"/>
+                <a:cs typeface="Arial"/>
+              </a:defRPr>
+            </a:pPr>
+            <a:r>
+              <a:rPr sz="3150" b="1">
+                <a:solidFill>
+                  <a:srgbClr val="152F45"/>
+                </a:solidFill>
+                <a:latin typeface="Arial"/>
+                <a:ea typeface="Arial"/>
+                <a:cs typeface="Arial"/>
+              </a:rPr>
+              <a:t>Conclusions and further study</a:t>
+            </a:r>
+          </a:p>
+        </p:txBody>
+      </p:sp>
+      <p:sp>
+        <p:nvSpPr>
+          <p:cNvPr id="2" name="">
+            <a:extLst xmlns:a="http://schemas.openxmlformats.org/drawingml/2006/main">
+              <a:ext uri="{FF2B5EF4-FFF2-40B4-BE49-F238E27FC236}">
+                <a16:creationId xmlns:a16="http://schemas.microsoft.com/office/drawing/2014/main" id="{D916D9DD-F98F-47D5-AC5E-1F49558EBC68}"/>
+              </a:ext>
+            </a:extLst>
+          </p:cNvPr>
+          <p:cNvSpPr>
+            <a:spLocks xmlns:a="http://schemas.openxmlformats.org/drawingml/2006/main" noGrp="1"/>
+          </p:cNvSpPr>
+          <p:nvPr/>
+        </p:nvSpPr>
+        <p:spPr>
+          <a:xfrm xmlns:a="http://schemas.openxmlformats.org/drawingml/2006/main">
+            <a:off x="571500" y="1476375"/>
+            <a:ext cx="11049000" cy="409575"/>
+          </a:xfrm>
+          <a:prstGeom xmlns:a="http://schemas.openxmlformats.org/drawingml/2006/main" prst="rect">
+            <a:avLst/>
+          </a:prstGeom>
+          <a:noFill xmlns:a="http://schemas.openxmlformats.org/drawingml/2006/main"/>
+          <a:ln xmlns:a="http://schemas.openxmlformats.org/drawingml/2006/main" w="0">
+            <a:noFill/>
+          </a:ln>
+        </p:spPr>
+        <p:txBody>
+          <a:bodyPr xmlns:a="http://schemas.openxmlformats.org/drawingml/2006/main"/>
+          <a:lstStyle xmlns:a="http://schemas.openxmlformats.org/drawingml/2006/main">
+            <a:defPPr>
+              <a:defRPr sz="2250" b="1">
+                <a:solidFill>
+                  <a:srgbClr val="167D91"/>
+                </a:solidFill>
+                <a:latin typeface="Arial"/>
+                <a:ea typeface="Arial"/>
+                <a:cs typeface="Arial"/>
+              </a:defRPr>
+            </a:defPPr>
+          </a:lstStyle>
+          <a:p xmlns:a="http://schemas.openxmlformats.org/drawingml/2006/main">
+            <a:pPr>
+              <a:defRPr sz="2250" b="1">
+                <a:solidFill>
+                  <a:srgbClr val="167D91"/>
+                </a:solidFill>
+                <a:latin typeface="Arial"/>
+                <a:ea typeface="Arial"/>
+                <a:cs typeface="Arial"/>
+              </a:defRPr>
+            </a:pPr>
+            <a:r>
+              <a:rPr sz="2250" b="1">
+                <a:solidFill>
+                  <a:srgbClr val="167D91"/>
+                </a:solidFill>
+                <a:latin typeface="Arial"/>
+                <a:ea typeface="Arial"/>
+                <a:cs typeface="Arial"/>
+              </a:rPr>
+              <a:t>Conclusions</a:t>
+            </a:r>
+          </a:p>
+        </p:txBody>
+      </p:sp>
+      <p:sp>
+        <p:nvSpPr>
+          <p:cNvPr id="3" name="">
+            <a:extLst xmlns:a="http://schemas.openxmlformats.org/drawingml/2006/main">
+              <a:ext uri="{FF2B5EF4-FFF2-40B4-BE49-F238E27FC236}">
+                <a16:creationId xmlns:a16="http://schemas.microsoft.com/office/drawing/2014/main" id="{E22A0CDE-B06E-457A-9237-650D2E283CD4}"/>
+              </a:ext>
+            </a:extLst>
+          </p:cNvPr>
+          <p:cNvSpPr>
+            <a:spLocks xmlns:a="http://schemas.openxmlformats.org/drawingml/2006/main" noGrp="1"/>
+          </p:cNvSpPr>
+          <p:nvPr/>
+        </p:nvSpPr>
+        <p:spPr>
+          <a:xfrm xmlns:a="http://schemas.openxmlformats.org/drawingml/2006/main">
+            <a:off x="571500" y="1981200"/>
+            <a:ext cx="11049000" cy="1000125"/>
+          </a:xfrm>
+          <a:prstGeom xmlns:a="http://schemas.openxmlformats.org/drawingml/2006/main" prst="rect">
+            <a:avLst/>
+          </a:prstGeom>
+          <a:noFill xmlns:a="http://schemas.openxmlformats.org/drawingml/2006/main"/>
+          <a:ln xmlns:a="http://schemas.openxmlformats.org/drawingml/2006/main" w="0">
+            <a:noFill/>
+          </a:ln>
+        </p:spPr>
+        <p:txBody>
+          <a:bodyPr xmlns:a="http://schemas.openxmlformats.org/drawingml/2006/main"/>
+          <a:lstStyle xmlns:a="http://schemas.openxmlformats.org/drawingml/2006/main">
+            <a:defPPr>
+              <a:defRPr sz="2100" b="0">
+                <a:solidFill>
+                  <a:srgbClr val="263C49"/>
+                </a:solidFill>
+                <a:latin typeface="Arial"/>
+                <a:ea typeface="Arial"/>
+                <a:cs typeface="Arial"/>
+              </a:defRPr>
+            </a:defPPr>
+          </a:lstStyle>
+          <a:p xmlns:a="http://schemas.openxmlformats.org/drawingml/2006/main">
+            <a:pPr>
+              <a:defRPr sz="2100" b="0">
+                <a:solidFill>
+                  <a:srgbClr val="263C49"/>
+                </a:solidFill>
+                <a:latin typeface="Arial"/>
+                <a:ea typeface="Arial"/>
+                <a:cs typeface="Arial"/>
+              </a:defRPr>
+            </a:pPr>
+            <a:r>
+              <a:rPr sz="2100" b="0">
+                <a:solidFill>
+                  <a:srgbClr val="263C49"/>
+                </a:solidFill>
+                <a:latin typeface="Arial"/>
+                <a:ea typeface="Arial"/>
+                <a:cs typeface="Arial"/>
+              </a:rPr>
+              <a:t>2015 carried more accumulated heat stress. Late-season satellite–logger agreement was closer in 2019 than in 2015. Persistence remained the strongest overall forecast benchmark.</a:t>
+            </a:r>
+          </a:p>
+        </p:txBody>
+      </p:sp>
+      <p:sp>
+        <p:nvSpPr>
+          <p:cNvPr id="4" name="">
+            <a:extLst xmlns:a="http://schemas.openxmlformats.org/drawingml/2006/main">
+              <a:ext uri="{FF2B5EF4-FFF2-40B4-BE49-F238E27FC236}">
+                <a16:creationId xmlns:a16="http://schemas.microsoft.com/office/drawing/2014/main" id="{672F09C6-E5D6-41F5-A0F2-A31D0B2DC6BB}"/>
+              </a:ext>
+            </a:extLst>
+          </p:cNvPr>
+          <p:cNvSpPr>
+            <a:spLocks xmlns:a="http://schemas.openxmlformats.org/drawingml/2006/main" noGrp="1"/>
+          </p:cNvSpPr>
+          <p:nvPr/>
+        </p:nvSpPr>
+        <p:spPr>
+          <a:xfrm xmlns:a="http://schemas.openxmlformats.org/drawingml/2006/main">
+            <a:off x="571500" y="3238500"/>
+            <a:ext cx="11049000" cy="409575"/>
+          </a:xfrm>
+          <a:prstGeom xmlns:a="http://schemas.openxmlformats.org/drawingml/2006/main" prst="rect">
+            <a:avLst/>
+          </a:prstGeom>
+          <a:noFill xmlns:a="http://schemas.openxmlformats.org/drawingml/2006/main"/>
+          <a:ln xmlns:a="http://schemas.openxmlformats.org/drawingml/2006/main" w="0">
+            <a:noFill/>
+          </a:ln>
+        </p:spPr>
+        <p:txBody>
+          <a:bodyPr xmlns:a="http://schemas.openxmlformats.org/drawingml/2006/main"/>
+          <a:lstStyle xmlns:a="http://schemas.openxmlformats.org/drawingml/2006/main">
+            <a:defPPr>
+              <a:defRPr sz="2250" b="1">
+                <a:solidFill>
+                  <a:srgbClr val="167D91"/>
+                </a:solidFill>
+                <a:latin typeface="Arial"/>
+                <a:ea typeface="Arial"/>
+                <a:cs typeface="Arial"/>
+              </a:defRPr>
+            </a:defPPr>
+          </a:lstStyle>
+          <a:p xmlns:a="http://schemas.openxmlformats.org/drawingml/2006/main">
+            <a:pPr>
+              <a:defRPr sz="2250" b="1">
+                <a:solidFill>
+                  <a:srgbClr val="167D91"/>
+                </a:solidFill>
+                <a:latin typeface="Arial"/>
+                <a:ea typeface="Arial"/>
+                <a:cs typeface="Arial"/>
+              </a:defRPr>
+            </a:pPr>
+            <a:r>
+              <a:rPr sz="2250" b="1">
+                <a:solidFill>
+                  <a:srgbClr val="167D91"/>
+                </a:solidFill>
+                <a:latin typeface="Arial"/>
+                <a:ea typeface="Arial"/>
+                <a:cs typeface="Arial"/>
+              </a:rPr>
+              <a:t>Further study</a:t>
+            </a:r>
+          </a:p>
+        </p:txBody>
+      </p:sp>
+      <p:sp>
+        <p:nvSpPr>
+          <p:cNvPr id="5" name="">
+            <a:extLst xmlns:a="http://schemas.openxmlformats.org/drawingml/2006/main">
+              <a:ext uri="{FF2B5EF4-FFF2-40B4-BE49-F238E27FC236}">
+                <a16:creationId xmlns:a16="http://schemas.microsoft.com/office/drawing/2014/main" id="{7F6CB3D0-FABB-4648-AE08-E64288F66F35}"/>
+              </a:ext>
+            </a:extLst>
+          </p:cNvPr>
+          <p:cNvSpPr>
+            <a:spLocks xmlns:a="http://schemas.openxmlformats.org/drawingml/2006/main" noGrp="1"/>
+          </p:cNvSpPr>
+          <p:nvPr/>
+        </p:nvSpPr>
+        <p:spPr>
+          <a:xfrm xmlns:a="http://schemas.openxmlformats.org/drawingml/2006/main">
+            <a:off x="571500" y="3743325"/>
+            <a:ext cx="11049000" cy="1000125"/>
+          </a:xfrm>
+          <a:prstGeom xmlns:a="http://schemas.openxmlformats.org/drawingml/2006/main" prst="rect">
+            <a:avLst/>
+          </a:prstGeom>
+          <a:noFill xmlns:a="http://schemas.openxmlformats.org/drawingml/2006/main"/>
+          <a:ln xmlns:a="http://schemas.openxmlformats.org/drawingml/2006/main" w="0">
+            <a:noFill/>
+          </a:ln>
+        </p:spPr>
+        <p:txBody>
+          <a:bodyPr xmlns:a="http://schemas.openxmlformats.org/drawingml/2006/main"/>
+          <a:lstStyle xmlns:a="http://schemas.openxmlformats.org/drawingml/2006/main">
+            <a:defPPr>
+              <a:defRPr sz="2100" b="0">
+                <a:solidFill>
+                  <a:srgbClr val="263C49"/>
+                </a:solidFill>
+                <a:latin typeface="Arial"/>
+                <a:ea typeface="Arial"/>
+                <a:cs typeface="Arial"/>
+              </a:defRPr>
+            </a:defPPr>
+          </a:lstStyle>
+          <a:p xmlns:a="http://schemas.openxmlformats.org/drawingml/2006/main">
+            <a:pPr>
+              <a:defRPr sz="2100" b="0">
+                <a:solidFill>
+                  <a:srgbClr val="263C49"/>
+                </a:solidFill>
+                <a:latin typeface="Arial"/>
+                <a:ea typeface="Arial"/>
+                <a:cs typeface="Arial"/>
+              </a:defRPr>
+            </a:pPr>
+            <a:r>
+              <a:rPr sz="2100" b="0">
+                <a:solidFill>
+                  <a:srgbClr val="263C49"/>
+                </a:solidFill>
+                <a:latin typeface="Arial"/>
+                <a:ea typeface="Arial"/>
+                <a:cs typeface="Arial"/>
+              </a:rPr>
+              <a:t>Test models designed for heat anomalies and use rolling validation across hot years. Add predictors for ocean conditions, more logger sites, and newer habitat maps to improve local comparisons.</a:t>
+            </a:r>
+          </a:p>
+        </p:txBody>
+      </p:sp>
+      <p:sp>
+        <p:nvSpPr>
+          <p:cNvPr id="6" name="">
+            <a:extLst xmlns:a="http://schemas.openxmlformats.org/drawingml/2006/main">
+              <a:ext uri="{FF2B5EF4-FFF2-40B4-BE49-F238E27FC236}">
+                <a16:creationId xmlns:a16="http://schemas.microsoft.com/office/drawing/2014/main" id="{A30DEC07-0F60-430D-9880-5C98ADABE358}"/>
+              </a:ext>
+            </a:extLst>
+          </p:cNvPr>
+          <p:cNvSpPr>
+            <a:spLocks xmlns:a="http://schemas.openxmlformats.org/drawingml/2006/main" noGrp="1"/>
+          </p:cNvSpPr>
+          <p:nvPr/>
+        </p:nvSpPr>
+        <p:spPr>
+          <a:xfrm xmlns:a="http://schemas.openxmlformats.org/drawingml/2006/main">
+            <a:off x="571500" y="5095875"/>
+            <a:ext cx="11049000" cy="381000"/>
+          </a:xfrm>
+          <a:prstGeom xmlns:a="http://schemas.openxmlformats.org/drawingml/2006/main" prst="rect">
+            <a:avLst/>
+          </a:prstGeom>
+          <a:noFill xmlns:a="http://schemas.openxmlformats.org/drawingml/2006/main"/>
+          <a:ln xmlns:a="http://schemas.openxmlformats.org/drawingml/2006/main" w="0">
+            <a:noFill/>
+          </a:ln>
+        </p:spPr>
+        <p:txBody>
+          <a:bodyPr xmlns:a="http://schemas.openxmlformats.org/drawingml/2006/main"/>
+          <a:lstStyle xmlns:a="http://schemas.openxmlformats.org/drawingml/2006/main">
+            <a:defPPr>
+              <a:defRPr sz="2025" b="1">
+                <a:solidFill>
+                  <a:srgbClr val="167D91"/>
+                </a:solidFill>
+                <a:latin typeface="Arial"/>
+                <a:ea typeface="Arial"/>
+                <a:cs typeface="Arial"/>
+              </a:defRPr>
+            </a:defPPr>
+          </a:lstStyle>
+          <a:p xmlns:a="http://schemas.openxmlformats.org/drawingml/2006/main">
+            <a:pPr>
+              <a:defRPr sz="2025" b="1">
+                <a:solidFill>
+                  <a:srgbClr val="167D91"/>
+                </a:solidFill>
+                <a:latin typeface="Arial"/>
+                <a:ea typeface="Arial"/>
+                <a:cs typeface="Arial"/>
+              </a:defRPr>
+            </a:pPr>
+            <a:r>
+              <a:rPr sz="2025" b="1">
+                <a:solidFill>
+                  <a:srgbClr val="167D91"/>
+                </a:solidFill>
+                <a:latin typeface="Arial"/>
+                <a:ea typeface="Arial"/>
+                <a:cs typeface="Arial"/>
+              </a:rPr>
+              <a:t>Sources</a:t>
+            </a:r>
+          </a:p>
+        </p:txBody>
+      </p:sp>
+      <p:sp>
+        <p:nvSpPr>
+          <p:cNvPr id="7" name="">
+            <a:extLst xmlns:a="http://schemas.openxmlformats.org/drawingml/2006/main">
+              <a:ext uri="{FF2B5EF4-FFF2-40B4-BE49-F238E27FC236}">
+                <a16:creationId xmlns:a16="http://schemas.microsoft.com/office/drawing/2014/main" id="{ABA5F3E4-158A-40B7-85CA-391BD1980776}"/>
+              </a:ext>
+            </a:extLst>
+          </p:cNvPr>
+          <p:cNvSpPr>
+            <a:spLocks xmlns:a="http://schemas.openxmlformats.org/drawingml/2006/main" noGrp="1"/>
+          </p:cNvSpPr>
+          <p:nvPr/>
+        </p:nvSpPr>
+        <p:spPr>
+          <a:xfrm xmlns:a="http://schemas.openxmlformats.org/drawingml/2006/main">
+            <a:off x="571500" y="5543550"/>
+            <a:ext cx="11049000" cy="1000125"/>
+          </a:xfrm>
+          <a:prstGeom xmlns:a="http://schemas.openxmlformats.org/drawingml/2006/main" prst="rect">
+            <a:avLst/>
+          </a:prstGeom>
+          <a:noFill xmlns:a="http://schemas.openxmlformats.org/drawingml/2006/main"/>
+          <a:ln xmlns:a="http://schemas.openxmlformats.org/drawingml/2006/main" w="0">
+            <a:noFill/>
+          </a:ln>
+        </p:spPr>
+        <p:txBody>
+          <a:bodyPr xmlns:a="http://schemas.openxmlformats.org/drawingml/2006/main"/>
+          <a:lstStyle xmlns:a="http://schemas.openxmlformats.org/drawingml/2006/main">
+            <a:defPPr>
+              <a:defRPr sz="1725" b="0">
+                <a:solidFill>
+                  <a:srgbClr val="263C49"/>
+                </a:solidFill>
+                <a:latin typeface="Arial"/>
+                <a:ea typeface="Arial"/>
+                <a:cs typeface="Arial"/>
+              </a:defRPr>
+            </a:defPPr>
+          </a:lstStyle>
+          <a:p xmlns:a="http://schemas.openxmlformats.org/drawingml/2006/main">
+            <a:pPr>
+              <a:defRPr sz="1725" b="0">
+                <a:solidFill>
+                  <a:srgbClr val="263C49"/>
+                </a:solidFill>
+                <a:latin typeface="Arial"/>
+                <a:ea typeface="Arial"/>
+                <a:cs typeface="Arial"/>
+              </a:defRPr>
+            </a:pPr>
+            <a:r>
+              <a:rPr sz="1725" b="0">
+                <a:solidFill>
+                  <a:srgbClr val="263C49"/>
+                </a:solidFill>
+                <a:latin typeface="Arial"/>
+                <a:ea typeface="Arial"/>
+                <a:cs typeface="Arial"/>
+              </a:rPr>
+              <a:t>NOAA Coral Reef Watch / PacIOOS. Satellite SST and DHW.</a:t>
+            </a:r>
+          </a:p>
+          <a:p xmlns:a="http://schemas.openxmlformats.org/drawingml/2006/main">
+            <a:pPr>
+              <a:defRPr sz="1725" b="0">
+                <a:solidFill>
+                  <a:srgbClr val="263C49"/>
+                </a:solidFill>
+                <a:latin typeface="Arial"/>
+                <a:ea typeface="Arial"/>
+                <a:cs typeface="Arial"/>
+              </a:defRPr>
+            </a:pPr>
+            <a:r>
+              <a:rPr sz="1725" b="0">
+                <a:solidFill>
+                  <a:srgbClr val="263C49"/>
+                </a:solidFill>
+                <a:latin typeface="Arial"/>
+                <a:ea typeface="Arial"/>
+                <a:cs typeface="Arial"/>
+              </a:rPr>
+              <a:t>NOAA NCEI. Hawaiʻi underwater temperature records.</a:t>
+            </a:r>
+          </a:p>
+          <a:p xmlns:a="http://schemas.openxmlformats.org/drawingml/2006/main">
+            <a:pPr>
+              <a:defRPr sz="1725" b="0">
+                <a:solidFill>
+                  <a:srgbClr val="263C49"/>
+                </a:solidFill>
+                <a:latin typeface="Arial"/>
+                <a:ea typeface="Arial"/>
+                <a:cs typeface="Arial"/>
+              </a:defRPr>
+            </a:pPr>
+            <a:r>
+              <a:rPr sz="1725" b="0">
+                <a:solidFill>
+                  <a:srgbClr val="263C49"/>
+                </a:solidFill>
+                <a:latin typeface="Arial"/>
+                <a:ea typeface="Arial"/>
+                <a:cs typeface="Arial"/>
+              </a:rPr>
+              <a:t>NOAA NCCOS. 2007 Hawaiʻi benthic habitat maps.</a:t>
+            </a:r>
+          </a:p>
+        </p:txBody>
+      </p:sp>
+    </p:spTree>
+    <p:extLst>
+      <p:ext uri="{BB962C8B-B14F-4D97-AF65-F5344CB8AC3E}">
+        <p14:creationId xmlns:p14="http://schemas.microsoft.com/office/powerpoint/2010/main" val="640281729"/>
       </p:ext>
     </p:extLst>
   </p:cSld>

</xml_diff>

<commit_message>
Finalize process log and remove presentation notes
</commit_message>
<xml_diff>
--- a/GISProjectDrewBaker/Documentation/GISPresentationDrewBaker.pptx
+++ b/GISProjectDrewBaker/Documentation/GISPresentationDrewBaker.pptx
@@ -1,1091 +1,21 @@
 
 <file path=ppt/presentation.xml><?xml version="1.0" encoding="utf-8"?>
-<p:presentation xmlns:p="http://schemas.openxmlformats.org/presentationml/2006/main">
+<p:presentation xmlns:p="http://schemas.openxmlformats.org/presentationml/2006/main" xmlns:r="http://schemas.openxmlformats.org/officeDocument/2006/relationships">
   <p:sldMasterIdLst>
-    <p:sldMasterId xmlns:r="http://schemas.openxmlformats.org/officeDocument/2006/relationships" id="2147483648" r:id="R2d2c63b5caac45f6"/>
+    <p:sldMasterId id="2147483648" r:id="R2d2c63b5caac45f6"/>
   </p:sldMasterIdLst>
-  <p:notesMasterIdLst>
-    <p:notesMasterId xmlns:r="http://schemas.openxmlformats.org/officeDocument/2006/relationships" r:id="Rafcd23d65ba34088"/>
-  </p:notesMasterIdLst>
   <p:sldIdLst>
-    <p:sldId xmlns:r="http://schemas.openxmlformats.org/officeDocument/2006/relationships" id="256" r:id="R518aee93a5a24d76"/>
-    <p:sldId xmlns:r="http://schemas.openxmlformats.org/officeDocument/2006/relationships" id="257" r:id="R0fbbc83541a14e6b"/>
-    <p:sldId xmlns:r="http://schemas.openxmlformats.org/officeDocument/2006/relationships" id="258" r:id="R049e8d679d3a4a1b"/>
-    <p:sldId xmlns:r="http://schemas.openxmlformats.org/officeDocument/2006/relationships" id="259" r:id="R831479eccf3848ff"/>
-    <p:sldId xmlns:r="http://schemas.openxmlformats.org/officeDocument/2006/relationships" id="260" r:id="Rf29660fa043742f8"/>
-    <p:sldId xmlns:r="http://schemas.openxmlformats.org/officeDocument/2006/relationships" id="261" r:id="R26ee96f621124dc0"/>
-    <p:sldId xmlns:r="http://schemas.openxmlformats.org/officeDocument/2006/relationships" id="262" r:id="R38809290cf4b4c3e"/>
+    <p:sldId id="256" r:id="R518aee93a5a24d76"/>
+    <p:sldId id="257" r:id="R0fbbc83541a14e6b"/>
+    <p:sldId id="258" r:id="R049e8d679d3a4a1b"/>
+    <p:sldId id="259" r:id="R831479eccf3848ff"/>
+    <p:sldId id="260" r:id="Rf29660fa043742f8"/>
+    <p:sldId id="261" r:id="R26ee96f621124dc0"/>
+    <p:sldId id="262" r:id="R38809290cf4b4c3e"/>
   </p:sldIdLst>
   <p:sldSz cx="12192000" cy="6858000"/>
   <p:notesSz cx="6858000" cy="9144000"/>
 </p:presentation>
-</file>
-
-<file path=ppt/notesMasters/notesMaster1.xml><?xml version="1.0" encoding="utf-8"?>
-<p:notesMaster xmlns:p="http://schemas.openxmlformats.org/presentationml/2006/main">
-  <p:cSld>
-    <p:bg>
-      <p:bgRef idx="1001">
-        <a:schemeClr xmlns:a="http://schemas.openxmlformats.org/drawingml/2006/main" val="bg1"/>
-      </p:bgRef>
-    </p:bg>
-    <p:spTree>
-      <p:nvGrpSpPr>
-        <p:cNvPr id="1" name=""/>
-        <p:cNvGrpSpPr/>
-        <p:nvPr/>
-      </p:nvGrpSpPr>
-      <p:grpSpPr>
-        <a:xfrm xmlns:a="http://schemas.openxmlformats.org/drawingml/2006/main"/>
-      </p:grpSpPr>
-      <p:sp>
-        <p:nvSpPr>
-          <p:cNvPr id="2" name="Header Placeholder"/>
-          <p:cNvSpPr/>
-          <p:nvPr>
-            <p:ph type="hdr" sz="quarter"/>
-          </p:nvPr>
-        </p:nvSpPr>
-        <p:spPr>
-          <a:prstGeom xmlns:a="http://schemas.openxmlformats.org/drawingml/2006/main" prst="rect">
-            <a:avLst/>
-          </a:prstGeom>
-        </p:spPr>
-        <p:txBody>
-          <a:bodyPr xmlns:a="http://schemas.openxmlformats.org/drawingml/2006/main"/>
-          <a:lstStyle xmlns:a="http://schemas.openxmlformats.org/drawingml/2006/main"/>
-          <a:p xmlns:a="http://schemas.openxmlformats.org/drawingml/2006/main"/>
-        </p:txBody>
-      </p:sp>
-      <p:sp>
-        <p:nvSpPr>
-          <p:cNvPr id="3" name="Date Placeholder"/>
-          <p:cNvSpPr/>
-          <p:nvPr>
-            <p:ph type="dt" sz="quarter" idx="1"/>
-          </p:nvPr>
-        </p:nvSpPr>
-        <p:spPr>
-          <a:prstGeom xmlns:a="http://schemas.openxmlformats.org/drawingml/2006/main" prst="rect">
-            <a:avLst/>
-          </a:prstGeom>
-        </p:spPr>
-        <p:txBody>
-          <a:bodyPr xmlns:a="http://schemas.openxmlformats.org/drawingml/2006/main"/>
-          <a:lstStyle xmlns:a="http://schemas.openxmlformats.org/drawingml/2006/main"/>
-          <a:p xmlns:a="http://schemas.openxmlformats.org/drawingml/2006/main"/>
-        </p:txBody>
-      </p:sp>
-      <p:sp>
-        <p:nvSpPr>
-          <p:cNvPr id="4" name="Slide Image Placeholder"/>
-          <p:cNvSpPr/>
-          <p:nvPr>
-            <p:ph type="sldImg" idx="2"/>
-          </p:nvPr>
-        </p:nvSpPr>
-        <p:spPr>
-          <a:prstGeom xmlns:a="http://schemas.openxmlformats.org/drawingml/2006/main" prst="rect">
-            <a:avLst/>
-          </a:prstGeom>
-        </p:spPr>
-        <p:txBody>
-          <a:bodyPr xmlns:a="http://schemas.openxmlformats.org/drawingml/2006/main"/>
-          <a:lstStyle xmlns:a="http://schemas.openxmlformats.org/drawingml/2006/main"/>
-          <a:p xmlns:a="http://schemas.openxmlformats.org/drawingml/2006/main"/>
-        </p:txBody>
-      </p:sp>
-      <p:sp>
-        <p:nvSpPr>
-          <p:cNvPr id="5" name="Notes Placeholder"/>
-          <p:cNvSpPr/>
-          <p:nvPr>
-            <p:ph type="body" sz="quarter" idx="3"/>
-          </p:nvPr>
-        </p:nvSpPr>
-        <p:spPr>
-          <a:prstGeom xmlns:a="http://schemas.openxmlformats.org/drawingml/2006/main" prst="rect">
-            <a:avLst/>
-          </a:prstGeom>
-        </p:spPr>
-        <p:txBody>
-          <a:bodyPr xmlns:a="http://schemas.openxmlformats.org/drawingml/2006/main"/>
-          <a:lstStyle xmlns:a="http://schemas.openxmlformats.org/drawingml/2006/main"/>
-          <a:p xmlns:a="http://schemas.openxmlformats.org/drawingml/2006/main"/>
-        </p:txBody>
-      </p:sp>
-      <p:sp>
-        <p:nvSpPr>
-          <p:cNvPr id="6" name="Footer Placeholder"/>
-          <p:cNvSpPr/>
-          <p:nvPr>
-            <p:ph type="ftr" sz="quarter" idx="4"/>
-          </p:nvPr>
-        </p:nvSpPr>
-        <p:spPr>
-          <a:prstGeom xmlns:a="http://schemas.openxmlformats.org/drawingml/2006/main" prst="rect">
-            <a:avLst/>
-          </a:prstGeom>
-        </p:spPr>
-        <p:txBody>
-          <a:bodyPr xmlns:a="http://schemas.openxmlformats.org/drawingml/2006/main"/>
-          <a:lstStyle xmlns:a="http://schemas.openxmlformats.org/drawingml/2006/main"/>
-          <a:p xmlns:a="http://schemas.openxmlformats.org/drawingml/2006/main"/>
-        </p:txBody>
-      </p:sp>
-      <p:sp>
-        <p:nvSpPr>
-          <p:cNvPr id="7" name="Slide Number Placeholder"/>
-          <p:cNvSpPr/>
-          <p:nvPr>
-            <p:ph type="sldNum" sz="quarter" idx="5"/>
-          </p:nvPr>
-        </p:nvSpPr>
-        <p:spPr>
-          <a:prstGeom xmlns:a="http://schemas.openxmlformats.org/drawingml/2006/main" prst="rect">
-            <a:avLst/>
-          </a:prstGeom>
-        </p:spPr>
-        <p:txBody>
-          <a:bodyPr xmlns:a="http://schemas.openxmlformats.org/drawingml/2006/main"/>
-          <a:lstStyle xmlns:a="http://schemas.openxmlformats.org/drawingml/2006/main"/>
-          <a:p xmlns:a="http://schemas.openxmlformats.org/drawingml/2006/main"/>
-        </p:txBody>
-      </p:sp>
-    </p:spTree>
-  </p:cSld>
-  <p:clrMap bg1="lt1" tx1="dk1" bg2="lt2" tx2="dk2" accent1="accent1" accent2="accent2" accent3="accent3" accent4="accent4" accent5="accent5" accent6="accent6" hlink="hlink" folHlink="folHlink"/>
-  <p:notesStyle>
-    <a:lvl1pPr xmlns:a="http://schemas.openxmlformats.org/drawingml/2006/main" marL="0" algn="l" defTabSz="914400" rtl="0" eaLnBrk="1" latinLnBrk="0" hangingPunct="1">
-      <a:defRPr sz="1200" kern="1200"/>
-    </a:lvl1pPr>
-  </p:notesStyle>
-</p:notesMaster>
-</file>
-
-<file path=ppt/notesMasters/theme/theme3.xml><?xml version="1.0" encoding="utf-8"?>
-<a:theme xmlns:a="http://schemas.openxmlformats.org/drawingml/2006/main" name="ChatGPT">
-  <a:themeElements>
-    <a:clrScheme name="ChatGPT">
-      <a:dk1>
-        <a:srgbClr val="000000"/>
-      </a:dk1>
-      <a:lt1>
-        <a:srgbClr val="FFFFFF"/>
-      </a:lt1>
-      <a:dk2>
-        <a:srgbClr val="0E2841"/>
-      </a:dk2>
-      <a:lt2>
-        <a:srgbClr val="E8E8E8"/>
-      </a:lt2>
-      <a:accent1>
-        <a:srgbClr val="156082"/>
-      </a:accent1>
-      <a:accent2>
-        <a:srgbClr val="E97132"/>
-      </a:accent2>
-      <a:accent3>
-        <a:srgbClr val="196B24"/>
-      </a:accent3>
-      <a:accent4>
-        <a:srgbClr val="0F9ED5"/>
-      </a:accent4>
-      <a:accent5>
-        <a:srgbClr val="A02B93"/>
-      </a:accent5>
-      <a:accent6>
-        <a:srgbClr val="4EA72E"/>
-      </a:accent6>
-      <a:hlink>
-        <a:srgbClr val="467886"/>
-      </a:hlink>
-      <a:folHlink>
-        <a:srgbClr val="96607D"/>
-      </a:folHlink>
-    </a:clrScheme>
-    <a:fontScheme name="">
-      <a:majorFont>
-        <a:latin typeface="Aptos"/>
-        <a:ea typeface=""/>
-        <a:cs typeface=""/>
-      </a:majorFont>
-      <a:minorFont>
-        <a:latin typeface="Aptos"/>
-        <a:ea typeface=""/>
-        <a:cs typeface=""/>
-      </a:minorFont>
-    </a:fontScheme>
-    <a:fmtScheme name="ChatGPT">
-      <a:fillStyleLst>
-        <a:solidFill>
-          <a:schemeClr val="phClr"/>
-        </a:solidFill>
-        <a:gradFill>
-          <a:gsLst>
-            <a:gs pos="0">
-              <a:schemeClr val="phClr">
-                <a:tint val="67000"/>
-                <a:lumMod val="110000"/>
-                <a:satMod val="105000"/>
-              </a:schemeClr>
-            </a:gs>
-            <a:gs pos="50000">
-              <a:schemeClr val="phClr">
-                <a:tint val="73000"/>
-                <a:lumMod val="105000"/>
-                <a:satMod val="103000"/>
-              </a:schemeClr>
-            </a:gs>
-            <a:gs pos="100000">
-              <a:schemeClr val="phClr">
-                <a:tint val="81000"/>
-                <a:lumMod val="105000"/>
-                <a:satMod val="109000"/>
-              </a:schemeClr>
-            </a:gs>
-          </a:gsLst>
-          <a:lin ang="5400000" scaled="0"/>
-        </a:gradFill>
-        <a:gradFill>
-          <a:gsLst>
-            <a:gs pos="0">
-              <a:schemeClr val="phClr">
-                <a:tint val="94000"/>
-                <a:lumMod val="102000"/>
-                <a:satMod val="103000"/>
-              </a:schemeClr>
-            </a:gs>
-            <a:gs pos="50000">
-              <a:schemeClr val="phClr">
-                <a:shade val="100000"/>
-                <a:lumMod val="100000"/>
-                <a:satMod val="110000"/>
-              </a:schemeClr>
-            </a:gs>
-            <a:gs pos="100000">
-              <a:schemeClr val="phClr">
-                <a:shade val="78000"/>
-                <a:lumMod val="99000"/>
-                <a:satMod val="120000"/>
-              </a:schemeClr>
-            </a:gs>
-          </a:gsLst>
-          <a:lin ang="5400000" scaled="0"/>
-        </a:gradFill>
-      </a:fillStyleLst>
-      <a:lnStyleLst>
-        <a:ln w="12700">
-          <a:solidFill>
-            <a:schemeClr val="phClr"/>
-          </a:solidFill>
-          <a:prstDash val="solid"/>
-        </a:ln>
-        <a:ln w="19050">
-          <a:solidFill>
-            <a:schemeClr val="phClr"/>
-          </a:solidFill>
-          <a:prstDash val="solid"/>
-        </a:ln>
-        <a:ln w="25400">
-          <a:solidFill>
-            <a:schemeClr val="phClr"/>
-          </a:solidFill>
-          <a:prstDash val="solid"/>
-        </a:ln>
-      </a:lnStyleLst>
-      <a:effectStyleLst>
-        <a:effectStyle>
-          <a:effectLst/>
-        </a:effectStyle>
-        <a:effectStyle>
-          <a:effectLst/>
-        </a:effectStyle>
-        <a:effectStyle>
-          <a:effectLst>
-            <a:outerShdw blurRad="57150" dist="19050" dir="5400000">
-              <a:srgbClr val="000000">
-                <a:alpha val="16000"/>
-              </a:srgbClr>
-            </a:outerShdw>
-          </a:effectLst>
-        </a:effectStyle>
-        <a:effectStyle>
-          <a:effectLst>
-            <a:outerShdw blurRad="19050" dist="9525" dir="5400000">
-              <a:srgbClr val="000000">
-                <a:alpha val="6000"/>
-              </a:srgbClr>
-            </a:outerShdw>
-          </a:effectLst>
-        </a:effectStyle>
-        <a:effectStyle>
-          <a:effectLst>
-            <a:outerShdw blurRad="28575" dist="9525" dir="5400000">
-              <a:srgbClr val="000000">
-                <a:alpha val="8000"/>
-              </a:srgbClr>
-            </a:outerShdw>
-          </a:effectLst>
-        </a:effectStyle>
-        <a:effectStyle>
-          <a:effectLst>
-            <a:outerShdw blurRad="57150" dist="19050" dir="5400000">
-              <a:srgbClr val="000000">
-                <a:alpha val="10000"/>
-              </a:srgbClr>
-            </a:outerShdw>
-          </a:effectLst>
-        </a:effectStyle>
-        <a:effectStyle>
-          <a:effectLst>
-            <a:outerShdw blurRad="114300" dist="38100" dir="5400000">
-              <a:srgbClr val="000000">
-                <a:alpha val="12000"/>
-              </a:srgbClr>
-            </a:outerShdw>
-          </a:effectLst>
-        </a:effectStyle>
-        <a:effectStyle>
-          <a:effectLst>
-            <a:outerShdw blurRad="171450" dist="57150" dir="5400000">
-              <a:srgbClr val="000000">
-                <a:alpha val="16000"/>
-              </a:srgbClr>
-            </a:outerShdw>
-          </a:effectLst>
-        </a:effectStyle>
-        <a:effectStyle>
-          <a:effectLst>
-            <a:outerShdw blurRad="266700" dist="95250" dir="5400000">
-              <a:srgbClr val="000000">
-                <a:alpha val="24000"/>
-              </a:srgbClr>
-            </a:outerShdw>
-          </a:effectLst>
-        </a:effectStyle>
-      </a:effectStyleLst>
-      <a:bgFillStyleLst>
-        <a:solidFill>
-          <a:schemeClr val="phClr"/>
-        </a:solidFill>
-        <a:solidFill>
-          <a:schemeClr val="phClr">
-            <a:tint val="95000"/>
-            <a:satMod val="170000"/>
-          </a:schemeClr>
-        </a:solidFill>
-        <a:gradFill>
-          <a:gsLst>
-            <a:gs pos="0">
-              <a:schemeClr val="phClr">
-                <a:tint val="93000"/>
-                <a:shade val="98000"/>
-                <a:lumMod val="102000"/>
-                <a:satMod val="150000"/>
-              </a:schemeClr>
-            </a:gs>
-            <a:gs pos="50000">
-              <a:schemeClr val="phClr">
-                <a:tint val="98000"/>
-                <a:shade val="90000"/>
-                <a:lumMod val="103000"/>
-                <a:satMod val="130000"/>
-              </a:schemeClr>
-            </a:gs>
-            <a:gs pos="100000">
-              <a:schemeClr val="phClr">
-                <a:shade val="63000"/>
-                <a:satMod val="120000"/>
-              </a:schemeClr>
-            </a:gs>
-          </a:gsLst>
-          <a:lin ang="5400000" scaled="0"/>
-        </a:gradFill>
-      </a:bgFillStyleLst>
-    </a:fmtScheme>
-  </a:themeElements>
-</a:theme>
-</file>
-
-<file path=ppt/notesSlides/notesSlide1.xml><?xml version="1.0" encoding="utf-8"?>
-<p:notes xmlns:p="http://schemas.openxmlformats.org/presentationml/2006/main">
-  <p:cSld>
-    <p:spTree>
-      <p:nvGrpSpPr>
-        <p:cNvPr id="1" name=""/>
-        <p:cNvGrpSpPr/>
-        <p:nvPr/>
-      </p:nvGrpSpPr>
-      <p:grpSpPr>
-        <a:xfrm xmlns:a="http://schemas.openxmlformats.org/drawingml/2006/main"/>
-      </p:grpSpPr>
-      <p:sp>
-        <p:nvSpPr>
-          <p:cNvPr id="2" name="Slide Image Placeholder 1"/>
-          <p:cNvSpPr>
-            <a:spLocks xmlns:a="http://schemas.openxmlformats.org/drawingml/2006/main" noGrp="1"/>
-          </p:cNvSpPr>
-          <p:nvPr>
-            <p:ph type="sldImg" idx="0"/>
-          </p:nvPr>
-        </p:nvSpPr>
-        <p:spPr/>
-      </p:sp>
-      <p:sp>
-        <p:nvSpPr>
-          <p:cNvPr id="3" name="Notes Placeholder 2"/>
-          <p:cNvSpPr>
-            <a:spLocks xmlns:a="http://schemas.openxmlformats.org/drawingml/2006/main" noGrp="1"/>
-          </p:cNvSpPr>
-          <p:nvPr>
-            <p:ph type="body" idx="1"/>
-          </p:nvPr>
-        </p:nvSpPr>
-        <p:spPr/>
-        <p:txBody>
-          <a:bodyPr xmlns:a="http://schemas.openxmlformats.org/drawingml/2006/main"/>
-          <a:lstStyle xmlns:a="http://schemas.openxmlformats.org/drawingml/2006/main"/>
-          <a:p xmlns:a="http://schemas.openxmlformats.org/drawingml/2006/main">
-            <a:r>
-              <a:t>Northern West Hawaiʻi near Upolu Point, with 2007 benthic habitat and NOAA logger sites OCC-HAW-001 and OCC-HAW-002.</a:t>
-            </a:r>
-          </a:p>
-          <a:p xmlns:a="http://schemas.openxmlformats.org/drawingml/2006/main">
-            <a:r>
-              <a:t>Map view from the Where to Begin sidecar: https://storymaps.arcgis.com/stories/7e6551719d15418a997e2517c2bc24cc</a:t>
-            </a:r>
-          </a:p>
-          <a:p xmlns:a="http://schemas.openxmlformats.org/drawingml/2006/main">
-            <a:r>
-              <a:t>NOAA NCEI underwater records: https://www.ncei.noaa.gov/erddap/tabledap/CRCP_Subsurface_Temp_Hawaii.html</a:t>
-            </a:r>
-          </a:p>
-          <a:p xmlns:a="http://schemas.openxmlformats.org/drawingml/2006/main">
-            <a:r>
-              <a:t>NOAA NCCOS habitat: https://products.coastalscience.noaa.gov/collections/benthic/e97hawaii/data2007.aspx</a:t>
-            </a:r>
-          </a:p>
-          <a:p xmlns:a="http://schemas.openxmlformats.org/drawingml/2006/main">
-            <a:r>
-              <a:t>The regional comparison focuses on 2015 and 2019. Forecasting evaluates 2015–2025 after development on 2003–2014.</a:t>
-            </a:r>
-          </a:p>
-        </p:txBody>
-      </p:sp>
-      <p:sp>
-        <p:nvSpPr>
-          <p:cNvPr id="4" name="Slide Number Placeholder 3"/>
-          <p:cNvSpPr>
-            <a:spLocks xmlns:a="http://schemas.openxmlformats.org/drawingml/2006/main" noGrp="1"/>
-          </p:cNvSpPr>
-          <p:nvPr>
-            <p:ph type="sldNum" idx="5"/>
-          </p:nvPr>
-        </p:nvSpPr>
-        <p:spPr/>
-        <p:txBody>
-          <a:bodyPr xmlns:a="http://schemas.openxmlformats.org/drawingml/2006/main"/>
-          <a:lstStyle xmlns:a="http://schemas.openxmlformats.org/drawingml/2006/main"/>
-          <a:p xmlns:a="http://schemas.openxmlformats.org/drawingml/2006/main"/>
-        </p:txBody>
-      </p:sp>
-    </p:spTree>
-  </p:cSld>
-  <p:clrMapOvr>
-    <a:masterClrMapping xmlns:a="http://schemas.openxmlformats.org/drawingml/2006/main"/>
-  </p:clrMapOvr>
-</p:notes>
-</file>
-
-<file path=ppt/notesSlides/notesSlide2.xml><?xml version="1.0" encoding="utf-8"?>
-<p:notes xmlns:p="http://schemas.openxmlformats.org/presentationml/2006/main">
-  <p:cSld>
-    <p:spTree>
-      <p:nvGrpSpPr>
-        <p:cNvPr id="1" name=""/>
-        <p:cNvGrpSpPr/>
-        <p:nvPr/>
-      </p:nvGrpSpPr>
-      <p:grpSpPr>
-        <a:xfrm xmlns:a="http://schemas.openxmlformats.org/drawingml/2006/main"/>
-      </p:grpSpPr>
-      <p:sp>
-        <p:nvSpPr>
-          <p:cNvPr id="2" name="Slide Image Placeholder 1"/>
-          <p:cNvSpPr>
-            <a:spLocks xmlns:a="http://schemas.openxmlformats.org/drawingml/2006/main" noGrp="1"/>
-          </p:cNvSpPr>
-          <p:nvPr>
-            <p:ph type="sldImg" idx="0"/>
-          </p:nvPr>
-        </p:nvSpPr>
-        <p:spPr/>
-      </p:sp>
-      <p:sp>
-        <p:nvSpPr>
-          <p:cNvPr id="3" name="Notes Placeholder 2"/>
-          <p:cNvSpPr>
-            <a:spLocks xmlns:a="http://schemas.openxmlformats.org/drawingml/2006/main" noGrp="1"/>
-          </p:cNvSpPr>
-          <p:nvPr>
-            <p:ph type="body" idx="1"/>
-          </p:nvPr>
-        </p:nvSpPr>
-        <p:spPr/>
-        <p:txBody>
-          <a:bodyPr xmlns:a="http://schemas.openxmlformats.org/drawingml/2006/main"/>
-          <a:lstStyle xmlns:a="http://schemas.openxmlformats.org/drawingml/2006/main"/>
-          <a:p xmlns:a="http://schemas.openxmlformats.org/drawingml/2006/main">
-            <a:r>
-              <a:t>The area of interest (AOI) covers West Hawaiʻi on Hawaiʻi Island. Its boundary is 18.90–20.30° N and −156.10 to −155.65° longitude. The satellite data use a 0.05-degree grid. Q1 compares full-calendar-year heat exposure in 2015 and 2019. Degree Heating Weeks (DHW) measures accumulated thermal stress in °C-weeks. Q2 compares matched seasons and complete nighttime logger means with satellite sea surface temperature (SST), using mean satellite-minus-logger difference and root mean square difference (RMSD). Q3 evaluates seven-day-ahead satellite SST forecasts with mean absolute error (MAE) and root mean square error (RMSE). Persistence forecasts today’s SST seven days ahead. Seasonal averages use historical temperatures around the target day of year.</a:t>
-            </a:r>
-          </a:p>
-          <a:p xmlns:a="http://schemas.openxmlformats.org/drawingml/2006/main">
-            <a:r>
-              <a:t>NOAA Coral Reef Watch via PacIOOS: https://pae-paha.pacioos.hawaii.edu/erddap/griddap/dhw_5km.html</a:t>
-            </a:r>
-          </a:p>
-          <a:p xmlns:a="http://schemas.openxmlformats.org/drawingml/2006/main">
-            <a:r>
-              <a:t>NOAA NCEI underwater temperatures: https://www.ncei.noaa.gov/erddap/tabledap/CRCP_Subsurface_Temp_Hawaii.html</a:t>
-            </a:r>
-          </a:p>
-          <a:p xmlns:a="http://schemas.openxmlformats.org/drawingml/2006/main">
-            <a:r>
-              <a:t>NOAA NCCOS habitat: https://products.coastalscience.noaa.gov/collections/benthic/e97hawaii/data2007.aspx</a:t>
-            </a:r>
-          </a:p>
-          <a:p xmlns:a="http://schemas.openxmlformats.org/drawingml/2006/main">
-            <a:r>
-              <a:t>Process log: https://github.com/drwbkr1/West-Hawaii-Heat-Stress-ASM540/blob/main/Documentation/PROCESS_LOG.md</a:t>
-            </a:r>
-          </a:p>
-          <a:p xmlns:a="http://schemas.openxmlformats.org/drawingml/2006/main">
-            <a:r>
-              <a:t>Notebook: https://github.com/drwbkr1/West-Hawaii-Heat-Stress-ASM540/blob/main/Analysis/Q3/Q3_SST_Forecasting.ipynb</a:t>
-            </a:r>
-          </a:p>
-        </p:txBody>
-      </p:sp>
-      <p:sp>
-        <p:nvSpPr>
-          <p:cNvPr id="4" name="Slide Number Placeholder 3"/>
-          <p:cNvSpPr>
-            <a:spLocks xmlns:a="http://schemas.openxmlformats.org/drawingml/2006/main" noGrp="1"/>
-          </p:cNvSpPr>
-          <p:nvPr>
-            <p:ph type="sldNum" idx="5"/>
-          </p:nvPr>
-        </p:nvSpPr>
-        <p:spPr/>
-        <p:txBody>
-          <a:bodyPr xmlns:a="http://schemas.openxmlformats.org/drawingml/2006/main"/>
-          <a:lstStyle xmlns:a="http://schemas.openxmlformats.org/drawingml/2006/main"/>
-          <a:p xmlns:a="http://schemas.openxmlformats.org/drawingml/2006/main"/>
-        </p:txBody>
-      </p:sp>
-    </p:spTree>
-  </p:cSld>
-  <p:clrMapOvr>
-    <a:masterClrMapping xmlns:a="http://schemas.openxmlformats.org/drawingml/2006/main"/>
-  </p:clrMapOvr>
-</p:notes>
-</file>
-
-<file path=ppt/notesSlides/notesSlide3.xml><?xml version="1.0" encoding="utf-8"?>
-<p:notes xmlns:p="http://schemas.openxmlformats.org/presentationml/2006/main">
-  <p:cSld>
-    <p:spTree>
-      <p:nvGrpSpPr>
-        <p:cNvPr id="1" name=""/>
-        <p:cNvGrpSpPr/>
-        <p:nvPr/>
-      </p:nvGrpSpPr>
-      <p:grpSpPr>
-        <a:xfrm xmlns:a="http://schemas.openxmlformats.org/drawingml/2006/main"/>
-      </p:grpSpPr>
-      <p:sp>
-        <p:nvSpPr>
-          <p:cNvPr id="2" name="Slide Image Placeholder 1"/>
-          <p:cNvSpPr>
-            <a:spLocks xmlns:a="http://schemas.openxmlformats.org/drawingml/2006/main" noGrp="1"/>
-          </p:cNvSpPr>
-          <p:nvPr>
-            <p:ph type="sldImg" idx="0"/>
-          </p:nvPr>
-        </p:nvSpPr>
-        <p:spPr/>
-      </p:sp>
-      <p:sp>
-        <p:nvSpPr>
-          <p:cNvPr id="3" name="Notes Placeholder 2"/>
-          <p:cNvSpPr>
-            <a:spLocks xmlns:a="http://schemas.openxmlformats.org/drawingml/2006/main" noGrp="1"/>
-          </p:cNvSpPr>
-          <p:nvPr>
-            <p:ph type="body" idx="1"/>
-          </p:nvPr>
-        </p:nvSpPr>
-        <p:spPr/>
-        <p:txBody>
-          <a:bodyPr xmlns:a="http://schemas.openxmlformats.org/drawingml/2006/main"/>
-          <a:lstStyle xmlns:a="http://schemas.openxmlformats.org/drawingml/2006/main"/>
-          <a:p xmlns:a="http://schemas.openxmlformats.org/drawingml/2006/main">
-            <a:r>
-              <a:t>Q1 GIS workflow: Create Fishnet makes the AOI and 0.05-degree satellite grid in WGS84. Project both to NAD83 UTM Zone 5N using NAD_1983_To_WGS_1984_3. Copy and Clip the 2007 NOAA NCCOS habitat to the AOI. Calculate geodesic hectares, select Coral Reef and Hardbottom, Intersect habitat with the projected grid, and summarize piece areas by Cell_ID. Prepare CRW_Key from cell-center latitude and longitude. Retain valid zero DHW values and set masked DHW to null. Summary Statistics by CRW_Key and Event_Year calculates annual maximum DHW, valid days, and days at DHW ≥4 and ≥8. Join annual values to grid copies, classify peak DHW, join classes to reef intersection pieces, and sum reef hectares. Match the 135 common cells with complete annual coverage for paired comparisons. Values on the slide list 2015 then 2019. Mapped reef/hardbottom area is 5,702.29 ha, of which 4,731.23 ha has valid DHW and 971.05 ha is unassessed.</a:t>
-            </a:r>
-          </a:p>
-          <a:p xmlns:a="http://schemas.openxmlformats.org/drawingml/2006/main">
-            <a:r>
-              <a:t>Results: https://github.com/drwbkr1/West-Hawaii-Heat-Stress-ASM540/tree/main/Analysis/Q1/Outputs</a:t>
-            </a:r>
-          </a:p>
-          <a:p xmlns:a="http://schemas.openxmlformats.org/drawingml/2006/main">
-            <a:r>
-              <a:t>NOAA Coral Reef Watch via PacIOOS: https://pae-paha.pacioos.hawaii.edu/erddap/griddap/dhw_5km.html</a:t>
-            </a:r>
-          </a:p>
-          <a:p xmlns:a="http://schemas.openxmlformats.org/drawingml/2006/main">
-            <a:r>
-              <a:t>NOAA NCEI underwater temperatures: https://www.ncei.noaa.gov/erddap/tabledap/CRCP_Subsurface_Temp_Hawaii.html</a:t>
-            </a:r>
-          </a:p>
-          <a:p xmlns:a="http://schemas.openxmlformats.org/drawingml/2006/main">
-            <a:r>
-              <a:t>NOAA NCCOS habitat: https://products.coastalscience.noaa.gov/collections/benthic/e97hawaii/data2007.aspx</a:t>
-            </a:r>
-          </a:p>
-          <a:p xmlns:a="http://schemas.openxmlformats.org/drawingml/2006/main">
-            <a:r>
-              <a:t>Process log: https://github.com/drwbkr1/West-Hawaii-Heat-Stress-ASM540/blob/main/Documentation/PROCESS_LOG.md</a:t>
-            </a:r>
-          </a:p>
-          <a:p xmlns:a="http://schemas.openxmlformats.org/drawingml/2006/main">
-            <a:r>
-              <a:t>Notebook: https://github.com/drwbkr1/West-Hawaii-Heat-Stress-ASM540/blob/main/Analysis/Q3/Q3_SST_Forecasting.ipynb</a:t>
-            </a:r>
-          </a:p>
-        </p:txBody>
-      </p:sp>
-      <p:sp>
-        <p:nvSpPr>
-          <p:cNvPr id="4" name="Slide Number Placeholder 3"/>
-          <p:cNvSpPr>
-            <a:spLocks xmlns:a="http://schemas.openxmlformats.org/drawingml/2006/main" noGrp="1"/>
-          </p:cNvSpPr>
-          <p:nvPr>
-            <p:ph type="sldNum" idx="5"/>
-          </p:nvPr>
-        </p:nvSpPr>
-        <p:spPr/>
-        <p:txBody>
-          <a:bodyPr xmlns:a="http://schemas.openxmlformats.org/drawingml/2006/main"/>
-          <a:lstStyle xmlns:a="http://schemas.openxmlformats.org/drawingml/2006/main"/>
-          <a:p xmlns:a="http://schemas.openxmlformats.org/drawingml/2006/main"/>
-        </p:txBody>
-      </p:sp>
-    </p:spTree>
-  </p:cSld>
-  <p:clrMapOvr>
-    <a:masterClrMapping xmlns:a="http://schemas.openxmlformats.org/drawingml/2006/main"/>
-  </p:clrMapOvr>
-</p:notes>
-</file>
-
-<file path=ppt/notesSlides/notesSlide4.xml><?xml version="1.0" encoding="utf-8"?>
-<p:notes xmlns:p="http://schemas.openxmlformats.org/presentationml/2006/main">
-  <p:cSld>
-    <p:spTree>
-      <p:nvGrpSpPr>
-        <p:cNvPr id="1" name=""/>
-        <p:cNvGrpSpPr/>
-        <p:nvPr/>
-      </p:nvGrpSpPr>
-      <p:grpSpPr>
-        <a:xfrm xmlns:a="http://schemas.openxmlformats.org/drawingml/2006/main"/>
-      </p:grpSpPr>
-      <p:sp>
-        <p:nvSpPr>
-          <p:cNvPr id="2" name="Slide Image Placeholder 1"/>
-          <p:cNvSpPr>
-            <a:spLocks xmlns:a="http://schemas.openxmlformats.org/drawingml/2006/main" noGrp="1"/>
-          </p:cNvSpPr>
-          <p:nvPr>
-            <p:ph type="sldImg" idx="0"/>
-          </p:nvPr>
-        </p:nvSpPr>
-        <p:spPr/>
-      </p:sp>
-      <p:sp>
-        <p:nvSpPr>
-          <p:cNvPr id="3" name="Notes Placeholder 2"/>
-          <p:cNvSpPr>
-            <a:spLocks xmlns:a="http://schemas.openxmlformats.org/drawingml/2006/main" noGrp="1"/>
-          </p:cNvSpPr>
-          <p:nvPr>
-            <p:ph type="body" idx="1"/>
-          </p:nvPr>
-        </p:nvSpPr>
-        <p:spPr/>
-        <p:txBody>
-          <a:bodyPr xmlns:a="http://schemas.openxmlformats.org/drawingml/2006/main"/>
-          <a:lstStyle xmlns:a="http://schemas.openxmlformats.org/drawingml/2006/main"/>
-          <a:p xmlns:a="http://schemas.openxmlformats.org/drawingml/2006/main">
-            <a:r>
-              <a:t>The existing printed chart is Documentation/Figures/August_November_RMSD.png. August–November RMSD (°C), 2015/2019: OCC-HAW-001 0.741/0.334, OCC-HAW-002 0.566/0.290, OCC-HAW-009 0.317/0.210. Q2 workflow: Copy Rows from CSV, remove units rows, Delete Identical on observation fields, and use Find Identical to check time/site/deployment keys. Parse numeric temperature/depth and convert UTC to HST (UTC−10). Merge observations and summarize deployment coordinates. XY Table To Point uses recorded longitude and latitude in WGS84. Spatial Join associates deployments with satellite cells, and attribute joins carry CRW_Key back to observations. These are coordinate-based points and spatial joins. No address geocoding is used. Select 00:00 to before 06:00 HST, summarize nightly temperatures, and keep complete nights with 72 five-minute or 360 one-minute readings. Join satellite SST by cell and date. Calculate satellite SST minus the nightly underwater mean, square the difference, summarize by common season/site/depth/year, and take the square root of mean squared difference. This late-season chart uses 122 complete matched nights per site/year, 732 comparisons in total.</a:t>
-            </a:r>
-          </a:p>
-          <a:p xmlns:a="http://schemas.openxmlformats.org/drawingml/2006/main">
-            <a:r>
-              <a:t>Results: https://github.com/drwbkr1/West-Hawaii-Heat-Stress-ASM540/blob/main/Analysis/Q2/Outputs/Q2_SiteSeason_Statistics.csv</a:t>
-            </a:r>
-          </a:p>
-          <a:p xmlns:a="http://schemas.openxmlformats.org/drawingml/2006/main">
-            <a:r>
-              <a:t>NOAA Coral Reef Watch via PacIOOS: https://pae-paha.pacioos.hawaii.edu/erddap/griddap/dhw_5km.html</a:t>
-            </a:r>
-          </a:p>
-          <a:p xmlns:a="http://schemas.openxmlformats.org/drawingml/2006/main">
-            <a:r>
-              <a:t>NOAA NCEI underwater temperatures: https://www.ncei.noaa.gov/erddap/tabledap/CRCP_Subsurface_Temp_Hawaii.html</a:t>
-            </a:r>
-          </a:p>
-          <a:p xmlns:a="http://schemas.openxmlformats.org/drawingml/2006/main">
-            <a:r>
-              <a:t>NOAA NCCOS habitat: https://products.coastalscience.noaa.gov/collections/benthic/e97hawaii/data2007.aspx</a:t>
-            </a:r>
-          </a:p>
-          <a:p xmlns:a="http://schemas.openxmlformats.org/drawingml/2006/main">
-            <a:r>
-              <a:t>Process log: https://github.com/drwbkr1/West-Hawaii-Heat-Stress-ASM540/blob/main/Documentation/PROCESS_LOG.md</a:t>
-            </a:r>
-          </a:p>
-          <a:p xmlns:a="http://schemas.openxmlformats.org/drawingml/2006/main">
-            <a:r>
-              <a:t>Notebook: https://github.com/drwbkr1/West-Hawaii-Heat-Stress-ASM540/blob/main/Analysis/Q3/Q3_SST_Forecasting.ipynb</a:t>
-            </a:r>
-          </a:p>
-        </p:txBody>
-      </p:sp>
-      <p:sp>
-        <p:nvSpPr>
-          <p:cNvPr id="4" name="Slide Number Placeholder 3"/>
-          <p:cNvSpPr>
-            <a:spLocks xmlns:a="http://schemas.openxmlformats.org/drawingml/2006/main" noGrp="1"/>
-          </p:cNvSpPr>
-          <p:nvPr>
-            <p:ph type="sldNum" idx="5"/>
-          </p:nvPr>
-        </p:nvSpPr>
-        <p:spPr/>
-        <p:txBody>
-          <a:bodyPr xmlns:a="http://schemas.openxmlformats.org/drawingml/2006/main"/>
-          <a:lstStyle xmlns:a="http://schemas.openxmlformats.org/drawingml/2006/main"/>
-          <a:p xmlns:a="http://schemas.openxmlformats.org/drawingml/2006/main"/>
-        </p:txBody>
-      </p:sp>
-    </p:spTree>
-  </p:cSld>
-  <p:clrMapOvr>
-    <a:masterClrMapping xmlns:a="http://schemas.openxmlformats.org/drawingml/2006/main"/>
-  </p:clrMapOvr>
-</p:notes>
-</file>
-
-<file path=ppt/notesSlides/notesSlide5.xml><?xml version="1.0" encoding="utf-8"?>
-<p:notes xmlns:p="http://schemas.openxmlformats.org/presentationml/2006/main">
-  <p:cSld>
-    <p:spTree>
-      <p:nvGrpSpPr>
-        <p:cNvPr id="1" name=""/>
-        <p:cNvGrpSpPr/>
-        <p:nvPr/>
-      </p:nvGrpSpPr>
-      <p:grpSpPr>
-        <a:xfrm xmlns:a="http://schemas.openxmlformats.org/drawingml/2006/main"/>
-      </p:grpSpPr>
-      <p:sp>
-        <p:nvSpPr>
-          <p:cNvPr id="2" name="Slide Image Placeholder 1"/>
-          <p:cNvSpPr>
-            <a:spLocks xmlns:a="http://schemas.openxmlformats.org/drawingml/2006/main" noGrp="1"/>
-          </p:cNvSpPr>
-          <p:nvPr>
-            <p:ph type="sldImg" idx="0"/>
-          </p:nvPr>
-        </p:nvSpPr>
-        <p:spPr/>
-      </p:sp>
-      <p:sp>
-        <p:nvSpPr>
-          <p:cNvPr id="3" name="Notes Placeholder 2"/>
-          <p:cNvSpPr>
-            <a:spLocks xmlns:a="http://schemas.openxmlformats.org/drawingml/2006/main" noGrp="1"/>
-          </p:cNvSpPr>
-          <p:nvPr>
-            <p:ph type="body" idx="1"/>
-          </p:nvPr>
-        </p:nvSpPr>
-        <p:spPr/>
-        <p:txBody>
-          <a:bodyPr xmlns:a="http://schemas.openxmlformats.org/drawingml/2006/main"/>
-          <a:lstStyle xmlns:a="http://schemas.openxmlformats.org/drawingml/2006/main"/>
-          <a:p xmlns:a="http://schemas.openxmlformats.org/drawingml/2006/main">
-            <a:r>
-              <a:t>The editable chart retains the saved held-out test MAE values: persistence 0.2228°C, random forest 0.2350°C, seasonal baseline 0.5656°C. The target is satellite SST seven days ahead. Chronological splits: initial training 2003–2013, 11,949 examples; validation 2014, 1,074 forecasts; final testing 2015–2025, 11,754 forecasts. Training targets precede validation issue dates. Development targets precede test issue dates. Four RF candidates combine maximum depth 8 or 16 with minimum leaf size 5 or 20. Each uses 300 trees and random seed 540. Select candidate 4 (depth 16, leaf size 20) using validation MAE, with RMSE as a tie-breaker. Validation MAE is RF 0.2116°C, persistence 0.2202°C, seasonal 0.5575°C. Refit the selected configuration on 13,044 eligible pre-2015 examples. Predictors use current/lagged SST, rolling means, seven-day change, seasonal sine/cosine, and cell indicators. Future DHW only groups evaluation results.</a:t>
-            </a:r>
-          </a:p>
-          <a:p xmlns:a="http://schemas.openxmlformats.org/drawingml/2006/main">
-            <a:r>
-              <a:t>NOAA Coral Reef Watch via PacIOOS: https://pae-paha.pacioos.hawaii.edu/erddap/griddap/dhw_5km.html</a:t>
-            </a:r>
-          </a:p>
-          <a:p xmlns:a="http://schemas.openxmlformats.org/drawingml/2006/main">
-            <a:r>
-              <a:t>NOAA NCEI underwater temperatures: https://www.ncei.noaa.gov/erddap/tabledap/CRCP_Subsurface_Temp_Hawaii.html</a:t>
-            </a:r>
-          </a:p>
-          <a:p xmlns:a="http://schemas.openxmlformats.org/drawingml/2006/main">
-            <a:r>
-              <a:t>NOAA NCCOS habitat: https://products.coastalscience.noaa.gov/collections/benthic/e97hawaii/data2007.aspx</a:t>
-            </a:r>
-          </a:p>
-          <a:p xmlns:a="http://schemas.openxmlformats.org/drawingml/2006/main">
-            <a:r>
-              <a:t>Process log: https://github.com/drwbkr1/West-Hawaii-Heat-Stress-ASM540/blob/main/Documentation/PROCESS_LOG.md</a:t>
-            </a:r>
-          </a:p>
-          <a:p xmlns:a="http://schemas.openxmlformats.org/drawingml/2006/main">
-            <a:r>
-              <a:t>Notebook: https://github.com/drwbkr1/West-Hawaii-Heat-Stress-ASM540/blob/main/Analysis/Q3/Q3_SST_Forecasting.ipynb</a:t>
-            </a:r>
-          </a:p>
-        </p:txBody>
-      </p:sp>
-      <p:sp>
-        <p:nvSpPr>
-          <p:cNvPr id="4" name="Slide Number Placeholder 3"/>
-          <p:cNvSpPr>
-            <a:spLocks xmlns:a="http://schemas.openxmlformats.org/drawingml/2006/main" noGrp="1"/>
-          </p:cNvSpPr>
-          <p:nvPr>
-            <p:ph type="sldNum" idx="5"/>
-          </p:nvPr>
-        </p:nvSpPr>
-        <p:spPr/>
-        <p:txBody>
-          <a:bodyPr xmlns:a="http://schemas.openxmlformats.org/drawingml/2006/main"/>
-          <a:lstStyle xmlns:a="http://schemas.openxmlformats.org/drawingml/2006/main"/>
-          <a:p xmlns:a="http://schemas.openxmlformats.org/drawingml/2006/main"/>
-        </p:txBody>
-      </p:sp>
-    </p:spTree>
-  </p:cSld>
-  <p:clrMapOvr>
-    <a:masterClrMapping xmlns:a="http://schemas.openxmlformats.org/drawingml/2006/main"/>
-  </p:clrMapOvr>
-</p:notes>
-</file>
-
-<file path=ppt/notesSlides/notesSlide6.xml><?xml version="1.0" encoding="utf-8"?>
-<p:notes xmlns:p="http://schemas.openxmlformats.org/presentationml/2006/main">
-  <p:cSld>
-    <p:spTree>
-      <p:nvGrpSpPr>
-        <p:cNvPr id="1" name=""/>
-        <p:cNvGrpSpPr/>
-        <p:nvPr/>
-      </p:nvGrpSpPr>
-      <p:grpSpPr>
-        <a:xfrm xmlns:a="http://schemas.openxmlformats.org/drawingml/2006/main"/>
-      </p:grpSpPr>
-      <p:sp>
-        <p:nvSpPr>
-          <p:cNvPr id="2" name="Slide Image Placeholder 1"/>
-          <p:cNvSpPr>
-            <a:spLocks xmlns:a="http://schemas.openxmlformats.org/drawingml/2006/main" noGrp="1"/>
-          </p:cNvSpPr>
-          <p:nvPr>
-            <p:ph type="sldImg" idx="0"/>
-          </p:nvPr>
-        </p:nvSpPr>
-        <p:spPr/>
-      </p:sp>
-      <p:sp>
-        <p:nvSpPr>
-          <p:cNvPr id="3" name="Notes Placeholder 2"/>
-          <p:cNvSpPr>
-            <a:spLocks xmlns:a="http://schemas.openxmlformats.org/drawingml/2006/main" noGrp="1"/>
-          </p:cNvSpPr>
-          <p:nvPr>
-            <p:ph type="body" idx="1"/>
-          </p:nvPr>
-        </p:nvSpPr>
-        <p:spPr/>
-        <p:txBody>
-          <a:bodyPr xmlns:a="http://schemas.openxmlformats.org/drawingml/2006/main"/>
-          <a:lstStyle xmlns:a="http://schemas.openxmlformats.org/drawingml/2006/main"/>
-          <a:p xmlns:a="http://schemas.openxmlformats.org/drawingml/2006/main">
-            <a:r>
-              <a:t>The animated GIF shows the two southern cells for every evaluated year from 2015 through 2025. RF skill varies by cell and year. Strong heat-stress years expose larger forecast errors. Animation color on the right represents annual RF improvement over persistence, 100 × (1 − RF MAE / persistence MAE). Positive skill favors RF and negative skill favors persistence. The accompanying DHW categories and errors on this slide pool all three forecast cells over held-out test target dates. DHW &lt;4: N=11,168, RF MAE 0.2214°C, persistence MAE 0.2209°C. DHW 4 to below 8: N=259, RF MAE 0.5392°C, persistence MAE 0.2337°C. DHW ≥8: N=327, RF MAE 0.4594°C, persistence MAE 0.2779°C. High-DHW RF MAE is about 65.3% higher than persistence and about 2.1 times its own low-DHW MAE. The low-DHW result is essentially a tie with persistence. For 2015 annual forecasts, southern nearshore RF skill is −63.5826% and offshore skill is −63.2058%, with 358 forecasts per cell. Peak DHW is 13.16 and 13.29 °C-weeks respectively, with 73 evaluated days at DHW ≥8 at each cell. The animation uses annual summaries of evaluated target dates. It is a different aggregation from the pooled DHW groups printed alongside it.</a:t>
-            </a:r>
-          </a:p>
-          <a:p xmlns:a="http://schemas.openxmlformats.org/drawingml/2006/main">
-            <a:r>
-              <a:t>Annual results: https://github.com/drwbkr1/West-Hawaii-Heat-Stress-ASM540/blob/main/Analysis/Q3/Outputs/Q3_CellForecast_Annual_Summary.csv</a:t>
-            </a:r>
-          </a:p>
-          <a:p xmlns:a="http://schemas.openxmlformats.org/drawingml/2006/main">
-            <a:r>
-              <a:t>NOAA Coral Reef Watch via PacIOOS: https://pae-paha.pacioos.hawaii.edu/erddap/griddap/dhw_5km.html</a:t>
-            </a:r>
-          </a:p>
-          <a:p xmlns:a="http://schemas.openxmlformats.org/drawingml/2006/main">
-            <a:r>
-              <a:t>NOAA NCEI underwater temperatures: https://www.ncei.noaa.gov/erddap/tabledap/CRCP_Subsurface_Temp_Hawaii.html</a:t>
-            </a:r>
-          </a:p>
-          <a:p xmlns:a="http://schemas.openxmlformats.org/drawingml/2006/main">
-            <a:r>
-              <a:t>NOAA NCCOS habitat: https://products.coastalscience.noaa.gov/collections/benthic/e97hawaii/data2007.aspx</a:t>
-            </a:r>
-          </a:p>
-          <a:p xmlns:a="http://schemas.openxmlformats.org/drawingml/2006/main">
-            <a:r>
-              <a:t>Process log: https://github.com/drwbkr1/West-Hawaii-Heat-Stress-ASM540/blob/main/Documentation/PROCESS_LOG.md</a:t>
-            </a:r>
-          </a:p>
-          <a:p xmlns:a="http://schemas.openxmlformats.org/drawingml/2006/main">
-            <a:r>
-              <a:t>Notebook: https://github.com/drwbkr1/West-Hawaii-Heat-Stress-ASM540/blob/main/Analysis/Q3/Q3_SST_Forecasting.ipynb</a:t>
-            </a:r>
-          </a:p>
-        </p:txBody>
-      </p:sp>
-      <p:sp>
-        <p:nvSpPr>
-          <p:cNvPr id="4" name="Slide Number Placeholder 3"/>
-          <p:cNvSpPr>
-            <a:spLocks xmlns:a="http://schemas.openxmlformats.org/drawingml/2006/main" noGrp="1"/>
-          </p:cNvSpPr>
-          <p:nvPr>
-            <p:ph type="sldNum" idx="5"/>
-          </p:nvPr>
-        </p:nvSpPr>
-        <p:spPr/>
-        <p:txBody>
-          <a:bodyPr xmlns:a="http://schemas.openxmlformats.org/drawingml/2006/main"/>
-          <a:lstStyle xmlns:a="http://schemas.openxmlformats.org/drawingml/2006/main"/>
-          <a:p xmlns:a="http://schemas.openxmlformats.org/drawingml/2006/main"/>
-        </p:txBody>
-      </p:sp>
-    </p:spTree>
-  </p:cSld>
-  <p:clrMapOvr>
-    <a:masterClrMapping xmlns:a="http://schemas.openxmlformats.org/drawingml/2006/main"/>
-  </p:clrMapOvr>
-</p:notes>
-</file>
-
-<file path=ppt/notesSlides/notesSlide7.xml><?xml version="1.0" encoding="utf-8"?>
-<p:notes xmlns:p="http://schemas.openxmlformats.org/presentationml/2006/main">
-  <p:cSld>
-    <p:spTree>
-      <p:nvGrpSpPr>
-        <p:cNvPr id="1" name=""/>
-        <p:cNvGrpSpPr/>
-        <p:nvPr/>
-      </p:nvGrpSpPr>
-      <p:grpSpPr>
-        <a:xfrm xmlns:a="http://schemas.openxmlformats.org/drawingml/2006/main"/>
-      </p:grpSpPr>
-      <p:sp>
-        <p:nvSpPr>
-          <p:cNvPr id="2" name="Slide Image Placeholder 1"/>
-          <p:cNvSpPr>
-            <a:spLocks xmlns:a="http://schemas.openxmlformats.org/drawingml/2006/main" noGrp="1"/>
-          </p:cNvSpPr>
-          <p:nvPr>
-            <p:ph type="sldImg" idx="0"/>
-          </p:nvPr>
-        </p:nvSpPr>
-        <p:spPr/>
-      </p:sp>
-      <p:sp>
-        <p:nvSpPr>
-          <p:cNvPr id="3" name="Notes Placeholder 2"/>
-          <p:cNvSpPr>
-            <a:spLocks xmlns:a="http://schemas.openxmlformats.org/drawingml/2006/main" noGrp="1"/>
-          </p:cNvSpPr>
-          <p:nvPr>
-            <p:ph type="body" idx="1"/>
-          </p:nvPr>
-        </p:nvSpPr>
-        <p:spPr/>
-        <p:txBody>
-          <a:bodyPr xmlns:a="http://schemas.openxmlformats.org/drawingml/2006/main"/>
-          <a:lstStyle xmlns:a="http://schemas.openxmlformats.org/drawingml/2006/main"/>
-          <a:p xmlns:a="http://schemas.openxmlformats.org/drawingml/2006/main">
-            <a:r>
-              <a:t>Q1: greater median peak DHW and more mapped reef area at DHW ≥8 in 2015 than 2019. Q2: lower August–November RMSD in 2019 at all three compared sites. Q3: persistence achieved the lowest overall held-out test MAE, and RF errors rose during high-DHW conditions. Further study could include anomaly-focused models, rolling evaluation across hot years, predictors such as currents and wind, expanded underwater monitoring, and newer habitat mapping.</a:t>
-            </a:r>
-          </a:p>
-          <a:p xmlns:a="http://schemas.openxmlformats.org/drawingml/2006/main">
-            <a:r>
-              <a:t>Sources and download locations:</a:t>
-            </a:r>
-          </a:p>
-          <a:p xmlns:a="http://schemas.openxmlformats.org/drawingml/2006/main">
-            <a:r>
-              <a:t>NOAA Coral Reef Watch via PacIOOS: https://pae-paha.pacioos.hawaii.edu/erddap/griddap/dhw_5km.html</a:t>
-            </a:r>
-          </a:p>
-          <a:p xmlns:a="http://schemas.openxmlformats.org/drawingml/2006/main">
-            <a:r>
-              <a:t>NOAA NCEI: https://www.ncei.noaa.gov/erddap/tabledap/CRCP_Subsurface_Temp_Hawaii.html</a:t>
-            </a:r>
-          </a:p>
-          <a:p xmlns:a="http://schemas.openxmlformats.org/drawingml/2006/main">
-            <a:r>
-              <a:t>NOAA NCCOS: https://products.coastalscience.noaa.gov/collections/benthic/e97hawaii/data2007.aspx</a:t>
-            </a:r>
-          </a:p>
-          <a:p xmlns:a="http://schemas.openxmlformats.org/drawingml/2006/main">
-            <a:r>
-              <a:t>Process log: https://github.com/drwbkr1/West-Hawaii-Heat-Stress-ASM540/blob/main/Documentation/PROCESS_LOG.md</a:t>
-            </a:r>
-          </a:p>
-          <a:p xmlns:a="http://schemas.openxmlformats.org/drawingml/2006/main">
-            <a:r>
-              <a:t>Python notebook: https://github.com/drwbkr1/West-Hawaii-Heat-Stress-ASM540/blob/main/Analysis/Q3/Q3_SST_Forecasting.ipynb</a:t>
-            </a:r>
-          </a:p>
-        </p:txBody>
-      </p:sp>
-      <p:sp>
-        <p:nvSpPr>
-          <p:cNvPr id="4" name="Slide Number Placeholder 3"/>
-          <p:cNvSpPr>
-            <a:spLocks xmlns:a="http://schemas.openxmlformats.org/drawingml/2006/main" noGrp="1"/>
-          </p:cNvSpPr>
-          <p:nvPr>
-            <p:ph type="sldNum" idx="5"/>
-          </p:nvPr>
-        </p:nvSpPr>
-        <p:spPr/>
-        <p:txBody>
-          <a:bodyPr xmlns:a="http://schemas.openxmlformats.org/drawingml/2006/main"/>
-          <a:lstStyle xmlns:a="http://schemas.openxmlformats.org/drawingml/2006/main"/>
-          <a:p xmlns:a="http://schemas.openxmlformats.org/drawingml/2006/main"/>
-        </p:txBody>
-      </p:sp>
-    </p:spTree>
-  </p:cSld>
-  <p:clrMapOvr>
-    <a:masterClrMapping xmlns:a="http://schemas.openxmlformats.org/drawingml/2006/main"/>
-  </p:clrMapOvr>
-</p:notes>
 </file>
 
 <file path=ppt/slideLayouts/slideLayout1.xml><?xml version="1.0" encoding="utf-8"?>

</xml_diff>